<commit_message>
Remove pi-recommendation training code, update research slide and notes
Co-Authored-By: Claude Sonnet 5 <noreply@anthropic.com>
</commit_message>
<xml_diff>
--- a/docs/18-08/Slide.pptx
+++ b/docs/18-08/Slide.pptx
@@ -5,21 +5,22 @@
     <p:sldMasterId id="2147483648" r:id="rId1"/>
   </p:sldMasterIdLst>
   <p:notesMasterIdLst>
-    <p:notesMasterId r:id="rId14"/>
+    <p:notesMasterId r:id="rId15"/>
   </p:notesMasterIdLst>
   <p:sldIdLst>
     <p:sldId id="256" r:id="rId2"/>
     <p:sldId id="258" r:id="rId3"/>
     <p:sldId id="259" r:id="rId4"/>
-    <p:sldId id="260" r:id="rId5"/>
-    <p:sldId id="262" r:id="rId6"/>
-    <p:sldId id="267" r:id="rId7"/>
-    <p:sldId id="272" r:id="rId8"/>
-    <p:sldId id="268" r:id="rId9"/>
-    <p:sldId id="269" r:id="rId10"/>
-    <p:sldId id="263" r:id="rId11"/>
-    <p:sldId id="266" r:id="rId12"/>
-    <p:sldId id="270" r:id="rId13"/>
+    <p:sldId id="273" r:id="rId5"/>
+    <p:sldId id="260" r:id="rId6"/>
+    <p:sldId id="270" r:id="rId7"/>
+    <p:sldId id="262" r:id="rId8"/>
+    <p:sldId id="267" r:id="rId9"/>
+    <p:sldId id="272" r:id="rId10"/>
+    <p:sldId id="268" r:id="rId11"/>
+    <p:sldId id="269" r:id="rId12"/>
+    <p:sldId id="263" r:id="rId13"/>
+    <p:sldId id="266" r:id="rId14"/>
   </p:sldIdLst>
   <p:sldSz cx="12192000" cy="6858000"/>
   <p:notesSz cx="6858000" cy="12192000"/>
@@ -419,7 +420,7 @@
           <a:p>
             <a:fld id="{F7021451-1387-4CA6-816F-3879F97B5CBC}" type="slidenum">
               <a:rPr lang="en-US"/>
-              <a:t>10</a:t>
+              <a:t>12</a:t>
             </a:fld>
             <a:endParaRPr lang="en-US"/>
           </a:p>
@@ -508,7 +509,7 @@
           <a:p>
             <a:fld id="{F7021451-1387-4CA6-816F-3879F97B5CBC}" type="slidenum">
               <a:rPr lang="en-US"/>
-              <a:t>11</a:t>
+              <a:t>13</a:t>
             </a:fld>
             <a:endParaRPr lang="en-US"/>
           </a:p>
@@ -775,7 +776,7 @@
           <a:p>
             <a:fld id="{F7021451-1387-4CA6-816F-3879F97B5CBC}" type="slidenum">
               <a:rPr lang="en-US"/>
-              <a:t>4</a:t>
+              <a:t>5</a:t>
             </a:fld>
             <a:endParaRPr lang="en-US"/>
           </a:p>
@@ -864,7 +865,7 @@
           <a:p>
             <a:fld id="{F7021451-1387-4CA6-816F-3879F97B5CBC}" type="slidenum">
               <a:rPr lang="en-US"/>
-              <a:t>5</a:t>
+              <a:t>7</a:t>
             </a:fld>
             <a:endParaRPr lang="en-US"/>
           </a:p>
@@ -1094,7 +1095,7 @@
           </a:prstGeom>
           <a:extLst>
             <a:ext uri="{C572A759-6A51-4108-AA02-DFA0A04FC94B}">
-              <ma14:wrappingTextBoxFlag xmlns:ma14="http://schemas.microsoft.com/office/mac/drawingml/2011/main" xmlns="" val="0"/>
+              <ma14:wrappingTextBoxFlag xmlns="" xmlns:ma14="http://schemas.microsoft.com/office/mac/drawingml/2011/main" val="0"/>
             </a:ext>
           </a:extLst>
         </p:spPr>
@@ -1172,7 +1173,7 @@
           </a:prstGeom>
           <a:extLst>
             <a:ext uri="{C572A759-6A51-4108-AA02-DFA0A04FC94B}">
-              <ma14:wrappingTextBoxFlag xmlns:ma14="http://schemas.microsoft.com/office/mac/drawingml/2011/main" xmlns="" val="0"/>
+              <ma14:wrappingTextBoxFlag xmlns="" xmlns:ma14="http://schemas.microsoft.com/office/mac/drawingml/2011/main" val="0"/>
             </a:ext>
           </a:extLst>
         </p:spPr>
@@ -1520,6 +1521,1629 @@
 
 <file path=ppt/slides/slide10.xml><?xml version="1.0" encoding="utf-8"?>
 <p:sld xmlns:a="http://schemas.openxmlformats.org/drawingml/2006/main" xmlns:r="http://schemas.openxmlformats.org/officeDocument/2006/relationships" xmlns:p="http://schemas.openxmlformats.org/presentationml/2006/main">
+  <p:cSld>
+    <p:spTree>
+      <p:nvGrpSpPr>
+        <p:cNvPr id="1" name=""/>
+        <p:cNvGrpSpPr/>
+        <p:nvPr/>
+      </p:nvGrpSpPr>
+      <p:grpSpPr>
+        <a:xfrm>
+          <a:off x="0" y="0"/>
+          <a:ext cx="0" cy="0"/>
+          <a:chOff x="0" y="0"/>
+          <a:chExt cx="0" cy="0"/>
+        </a:xfrm>
+      </p:grpSpPr>
+      <p:pic>
+        <p:nvPicPr>
+          <p:cNvPr id="6" name="Picture 5" descr="image.png"/>
+          <p:cNvPicPr>
+            <a:picLocks noChangeAspect="1"/>
+          </p:cNvPicPr>
+          <p:nvPr/>
+        </p:nvPicPr>
+        <p:blipFill>
+          <a:blip r:embed="rId3"/>
+          <a:stretch>
+            <a:fillRect/>
+          </a:stretch>
+        </p:blipFill>
+        <p:spPr>
+          <a:xfrm>
+            <a:off x="1494764" y="1115793"/>
+            <a:ext cx="9363456" cy="3446837"/>
+          </a:xfrm>
+          <a:prstGeom prst="rect">
+            <a:avLst/>
+          </a:prstGeom>
+        </p:spPr>
+      </p:pic>
+      <p:sp>
+        <p:nvSpPr>
+          <p:cNvPr id="7" name="TextBox 6"/>
+          <p:cNvSpPr txBox="1"/>
+          <p:nvPr/>
+        </p:nvSpPr>
+        <p:spPr>
+          <a:xfrm>
+            <a:off x="502920" y="228600"/>
+            <a:ext cx="11064240" cy="475488"/>
+          </a:xfrm>
+          <a:prstGeom prst="rect">
+            <a:avLst/>
+          </a:prstGeom>
+          <a:noFill/>
+        </p:spPr>
+        <p:txBody>
+          <a:bodyPr wrap="square" anchor="ctr">
+            <a:spAutoFit/>
+          </a:bodyPr>
+          <a:lstStyle/>
+          <a:p>
+            <a:pPr algn="l"/>
+            <a:r>
+              <a:rPr sz="2400" b="1">
+                <a:solidFill>
+                  <a:srgbClr val="192C4F"/>
+                </a:solidFill>
+                <a:latin typeface="Aptos"/>
+              </a:rPr>
+              <a:t>LazyAR — Không phải mọi decoder layer đều cần autoregressive</a:t>
+            </a:r>
+          </a:p>
+        </p:txBody>
+      </p:sp>
+      <p:sp>
+        <p:nvSpPr>
+          <p:cNvPr id="8" name="TextBox 7"/>
+          <p:cNvSpPr txBox="1"/>
+          <p:nvPr/>
+        </p:nvSpPr>
+        <p:spPr>
+          <a:xfrm>
+            <a:off x="530352" y="731520"/>
+            <a:ext cx="10881360" cy="329184"/>
+          </a:xfrm>
+          <a:prstGeom prst="rect">
+            <a:avLst/>
+          </a:prstGeom>
+          <a:noFill/>
+        </p:spPr>
+        <p:txBody>
+          <a:bodyPr wrap="square" anchor="ctr">
+            <a:spAutoFit/>
+          </a:bodyPr>
+          <a:lstStyle/>
+          <a:p>
+            <a:pPr algn="l"/>
+            <a:r>
+              <a:rPr sz="1350" b="0">
+                <a:solidFill>
+                  <a:srgbClr val="676F7B"/>
+                </a:solidFill>
+                <a:latin typeface="Aptos"/>
+              </a:rPr>
+              <a:t>Ý tưởng cốt lõi: chỉ inject token trước ở layer muộn; phần đầu được tính song song và reuse qua beam.</a:t>
+            </a:r>
+          </a:p>
+        </p:txBody>
+      </p:sp>
+      <p:sp>
+        <p:nvSpPr>
+          <p:cNvPr id="9" name="Rounded Rectangle 8"/>
+          <p:cNvSpPr/>
+          <p:nvPr/>
+        </p:nvSpPr>
+        <p:spPr>
+          <a:xfrm>
+            <a:off x="1173295" y="4617719"/>
+            <a:ext cx="3063240" cy="1417320"/>
+          </a:xfrm>
+          <a:prstGeom prst="roundRect">
+            <a:avLst/>
+          </a:prstGeom>
+          <a:solidFill>
+            <a:srgbClr val="F9FAFC"/>
+          </a:solidFill>
+          <a:ln w="12700">
+            <a:solidFill>
+              <a:srgbClr val="DBE0E7"/>
+            </a:solidFill>
+          </a:ln>
+        </p:spPr>
+        <p:style>
+          <a:lnRef idx="1">
+            <a:schemeClr val="accent1"/>
+          </a:lnRef>
+          <a:fillRef idx="3">
+            <a:schemeClr val="accent1"/>
+          </a:fillRef>
+          <a:effectRef idx="2">
+            <a:schemeClr val="accent1"/>
+          </a:effectRef>
+          <a:fontRef idx="minor">
+            <a:schemeClr val="lt1"/>
+          </a:fontRef>
+        </p:style>
+        <p:txBody>
+          <a:bodyPr rtlCol="0" anchor="ctr"/>
+          <a:lstStyle/>
+          <a:p>
+            <a:pPr algn="ctr"/>
+            <a:endParaRPr/>
+          </a:p>
+        </p:txBody>
+      </p:sp>
+      <p:sp>
+        <p:nvSpPr>
+          <p:cNvPr id="10" name="TextBox 9"/>
+          <p:cNvSpPr txBox="1"/>
+          <p:nvPr/>
+        </p:nvSpPr>
+        <p:spPr>
+          <a:xfrm>
+            <a:off x="1242277" y="4806235"/>
+            <a:ext cx="2743200" cy="256032"/>
+          </a:xfrm>
+          <a:prstGeom prst="rect">
+            <a:avLst/>
+          </a:prstGeom>
+          <a:noFill/>
+        </p:spPr>
+        <p:txBody>
+          <a:bodyPr wrap="square" anchor="t">
+            <a:spAutoFit/>
+          </a:bodyPr>
+          <a:lstStyle/>
+          <a:p>
+            <a:pPr algn="l"/>
+            <a:r>
+              <a:rPr sz="1550" b="1" dirty="0">
+                <a:solidFill>
+                  <a:srgbClr val="B74646"/>
+                </a:solidFill>
+                <a:latin typeface="Aptos"/>
+              </a:rPr>
+              <a:t>Vanilla AR</a:t>
+            </a:r>
+          </a:p>
+        </p:txBody>
+      </p:sp>
+      <p:sp>
+        <p:nvSpPr>
+          <p:cNvPr id="11" name="TextBox 10"/>
+          <p:cNvSpPr txBox="1"/>
+          <p:nvPr/>
+        </p:nvSpPr>
+        <p:spPr>
+          <a:xfrm>
+            <a:off x="1242277" y="5179497"/>
+            <a:ext cx="2743200" cy="749808"/>
+          </a:xfrm>
+          <a:prstGeom prst="rect">
+            <a:avLst/>
+          </a:prstGeom>
+          <a:noFill/>
+        </p:spPr>
+        <p:txBody>
+          <a:bodyPr wrap="square" anchor="t">
+            <a:spAutoFit/>
+          </a:bodyPr>
+          <a:lstStyle/>
+          <a:p>
+            <a:pPr algn="l"/>
+            <a:r>
+              <a:rPr sz="1180" b="0" dirty="0" err="1">
+                <a:solidFill>
+                  <a:srgbClr val="2B3341"/>
+                </a:solidFill>
+                <a:latin typeface="Aptos"/>
+              </a:rPr>
+              <a:t>Mỗi</a:t>
+            </a:r>
+            <a:r>
+              <a:rPr sz="1180" b="0" dirty="0">
+                <a:solidFill>
+                  <a:srgbClr val="2B3341"/>
+                </a:solidFill>
+                <a:latin typeface="Aptos"/>
+              </a:rPr>
+              <a:t> step </a:t>
+            </a:r>
+            <a:r>
+              <a:rPr sz="1180" b="0" dirty="0" err="1">
+                <a:solidFill>
+                  <a:srgbClr val="2B3341"/>
+                </a:solidFill>
+                <a:latin typeface="Aptos"/>
+              </a:rPr>
+              <a:t>chạy</a:t>
+            </a:r>
+            <a:r>
+              <a:rPr sz="1180" b="0" dirty="0">
+                <a:solidFill>
+                  <a:srgbClr val="2B3341"/>
+                </a:solidFill>
+                <a:latin typeface="Aptos"/>
+              </a:rPr>
+              <a:t> qua </a:t>
+            </a:r>
+            <a:r>
+              <a:rPr sz="1180" b="0" dirty="0" err="1">
+                <a:solidFill>
+                  <a:srgbClr val="2B3341"/>
+                </a:solidFill>
+                <a:latin typeface="Aptos"/>
+              </a:rPr>
+              <a:t>toàn</a:t>
+            </a:r>
+            <a:r>
+              <a:rPr sz="1180" b="0" dirty="0">
+                <a:solidFill>
+                  <a:srgbClr val="2B3341"/>
+                </a:solidFill>
+                <a:latin typeface="Aptos"/>
+              </a:rPr>
+              <a:t> </a:t>
+            </a:r>
+            <a:r>
+              <a:rPr sz="1180" b="0" dirty="0" err="1">
+                <a:solidFill>
+                  <a:srgbClr val="2B3341"/>
+                </a:solidFill>
+                <a:latin typeface="Aptos"/>
+              </a:rPr>
+              <a:t>bộ</a:t>
+            </a:r>
+            <a:r>
+              <a:rPr sz="1180" b="0" dirty="0">
+                <a:solidFill>
+                  <a:srgbClr val="2B3341"/>
+                </a:solidFill>
+                <a:latin typeface="Aptos"/>
+              </a:rPr>
+              <a:t> decoder </a:t>
+            </a:r>
+            <a:r>
+              <a:rPr sz="1180" b="0" dirty="0" err="1">
+                <a:solidFill>
+                  <a:srgbClr val="2B3341"/>
+                </a:solidFill>
+                <a:latin typeface="Aptos"/>
+              </a:rPr>
+              <a:t>và</a:t>
+            </a:r>
+            <a:r>
+              <a:rPr sz="1180" b="0" dirty="0">
+                <a:solidFill>
+                  <a:srgbClr val="2B3341"/>
+                </a:solidFill>
+                <a:latin typeface="Aptos"/>
+              </a:rPr>
+              <a:t> </a:t>
+            </a:r>
+            <a:r>
+              <a:rPr sz="1180" b="0" dirty="0" err="1">
+                <a:solidFill>
+                  <a:srgbClr val="2B3341"/>
+                </a:solidFill>
+                <a:latin typeface="Aptos"/>
+              </a:rPr>
+              <a:t>phụ</a:t>
+            </a:r>
+            <a:r>
+              <a:rPr sz="1180" b="0" dirty="0">
+                <a:solidFill>
+                  <a:srgbClr val="2B3341"/>
+                </a:solidFill>
+                <a:latin typeface="Aptos"/>
+              </a:rPr>
+              <a:t> </a:t>
+            </a:r>
+            <a:r>
+              <a:rPr sz="1180" b="0" dirty="0" err="1">
+                <a:solidFill>
+                  <a:srgbClr val="2B3341"/>
+                </a:solidFill>
+                <a:latin typeface="Aptos"/>
+              </a:rPr>
+              <a:t>thuộc</a:t>
+            </a:r>
+            <a:r>
+              <a:rPr sz="1180" b="0" dirty="0">
+                <a:solidFill>
+                  <a:srgbClr val="2B3341"/>
+                </a:solidFill>
+                <a:latin typeface="Aptos"/>
+              </a:rPr>
+              <a:t> token </a:t>
+            </a:r>
+            <a:r>
+              <a:rPr sz="1180" b="0" dirty="0" err="1">
+                <a:solidFill>
+                  <a:srgbClr val="2B3341"/>
+                </a:solidFill>
+                <a:latin typeface="Aptos"/>
+              </a:rPr>
+              <a:t>trước</a:t>
+            </a:r>
+            <a:r>
+              <a:rPr sz="1180" b="0" dirty="0">
+                <a:solidFill>
+                  <a:srgbClr val="2B3341"/>
+                </a:solidFill>
+                <a:latin typeface="Aptos"/>
+              </a:rPr>
+              <a:t> → sequential cost </a:t>
+            </a:r>
+            <a:r>
+              <a:rPr sz="1180" b="0" dirty="0" err="1">
+                <a:solidFill>
+                  <a:srgbClr val="2B3341"/>
+                </a:solidFill>
+                <a:latin typeface="Aptos"/>
+              </a:rPr>
+              <a:t>lớn</a:t>
+            </a:r>
+            <a:r>
+              <a:rPr sz="1180" b="0" dirty="0">
+                <a:solidFill>
+                  <a:srgbClr val="2B3341"/>
+                </a:solidFill>
+                <a:latin typeface="Aptos"/>
+              </a:rPr>
+              <a:t> </a:t>
+            </a:r>
+            <a:r>
+              <a:rPr sz="1180" b="0" dirty="0" err="1">
+                <a:solidFill>
+                  <a:srgbClr val="2B3341"/>
+                </a:solidFill>
+                <a:latin typeface="Aptos"/>
+              </a:rPr>
+              <a:t>khi</a:t>
+            </a:r>
+            <a:r>
+              <a:rPr sz="1180" b="0" dirty="0">
+                <a:solidFill>
+                  <a:srgbClr val="2B3341"/>
+                </a:solidFill>
+                <a:latin typeface="Aptos"/>
+              </a:rPr>
+              <a:t> beam </a:t>
+            </a:r>
+            <a:r>
+              <a:rPr sz="1180" b="0" dirty="0" err="1">
+                <a:solidFill>
+                  <a:srgbClr val="2B3341"/>
+                </a:solidFill>
+                <a:latin typeface="Aptos"/>
+              </a:rPr>
+              <a:t>tăng</a:t>
+            </a:r>
+            <a:r>
+              <a:rPr sz="1180" b="0" dirty="0">
+                <a:solidFill>
+                  <a:srgbClr val="2B3341"/>
+                </a:solidFill>
+                <a:latin typeface="Aptos"/>
+              </a:rPr>
+              <a:t>.</a:t>
+            </a:r>
+          </a:p>
+        </p:txBody>
+      </p:sp>
+      <p:sp>
+        <p:nvSpPr>
+          <p:cNvPr id="15" name="Rounded Rectangle 14"/>
+          <p:cNvSpPr/>
+          <p:nvPr/>
+        </p:nvSpPr>
+        <p:spPr>
+          <a:xfrm>
+            <a:off x="7955466" y="4645039"/>
+            <a:ext cx="3063240" cy="1417320"/>
+          </a:xfrm>
+          <a:prstGeom prst="roundRect">
+            <a:avLst/>
+          </a:prstGeom>
+          <a:solidFill>
+            <a:srgbClr val="F9FAFC"/>
+          </a:solidFill>
+          <a:ln w="12700">
+            <a:solidFill>
+              <a:srgbClr val="DBE0E7"/>
+            </a:solidFill>
+          </a:ln>
+        </p:spPr>
+        <p:style>
+          <a:lnRef idx="1">
+            <a:schemeClr val="accent1"/>
+          </a:lnRef>
+          <a:fillRef idx="3">
+            <a:schemeClr val="accent1"/>
+          </a:fillRef>
+          <a:effectRef idx="2">
+            <a:schemeClr val="accent1"/>
+          </a:effectRef>
+          <a:fontRef idx="minor">
+            <a:schemeClr val="lt1"/>
+          </a:fontRef>
+        </p:style>
+        <p:txBody>
+          <a:bodyPr rtlCol="0" anchor="ctr"/>
+          <a:lstStyle/>
+          <a:p>
+            <a:pPr algn="ctr"/>
+            <a:endParaRPr/>
+          </a:p>
+        </p:txBody>
+      </p:sp>
+      <p:sp>
+        <p:nvSpPr>
+          <p:cNvPr id="16" name="TextBox 15"/>
+          <p:cNvSpPr txBox="1"/>
+          <p:nvPr/>
+        </p:nvSpPr>
+        <p:spPr>
+          <a:xfrm>
+            <a:off x="8120057" y="4763911"/>
+            <a:ext cx="2743200" cy="256032"/>
+          </a:xfrm>
+          <a:prstGeom prst="rect">
+            <a:avLst/>
+          </a:prstGeom>
+          <a:noFill/>
+        </p:spPr>
+        <p:txBody>
+          <a:bodyPr wrap="square" anchor="t">
+            <a:spAutoFit/>
+          </a:bodyPr>
+          <a:lstStyle/>
+          <a:p>
+            <a:pPr algn="l"/>
+            <a:r>
+              <a:rPr sz="1550" b="1">
+                <a:solidFill>
+                  <a:srgbClr val="368461"/>
+                </a:solidFill>
+                <a:latin typeface="Aptos"/>
+              </a:rPr>
+              <a:t>LazyAR</a:t>
+            </a:r>
+          </a:p>
+        </p:txBody>
+      </p:sp>
+      <p:sp>
+        <p:nvSpPr>
+          <p:cNvPr id="17" name="TextBox 16"/>
+          <p:cNvSpPr txBox="1"/>
+          <p:nvPr/>
+        </p:nvSpPr>
+        <p:spPr>
+          <a:xfrm>
+            <a:off x="8120057" y="5102239"/>
+            <a:ext cx="2743200" cy="749808"/>
+          </a:xfrm>
+          <a:prstGeom prst="rect">
+            <a:avLst/>
+          </a:prstGeom>
+          <a:noFill/>
+        </p:spPr>
+        <p:txBody>
+          <a:bodyPr wrap="square" anchor="t">
+            <a:spAutoFit/>
+          </a:bodyPr>
+          <a:lstStyle/>
+          <a:p>
+            <a:pPr algn="l"/>
+            <a:r>
+              <a:rPr sz="1180" b="0">
+                <a:solidFill>
+                  <a:srgbClr val="2B3341"/>
+                </a:solidFill>
+                <a:latin typeface="Aptos"/>
+              </a:rPr>
+              <a:t>K layer đầu không phụ thuộc token trước → chạy song song, share qua beams. Chỉ L−K layer sau còn autoregressive.</a:t>
+            </a:r>
+          </a:p>
+        </p:txBody>
+      </p:sp>
+      <p:sp>
+        <p:nvSpPr>
+          <p:cNvPr id="18" name="TextBox 17"/>
+          <p:cNvSpPr txBox="1"/>
+          <p:nvPr/>
+        </p:nvSpPr>
+        <p:spPr>
+          <a:xfrm>
+            <a:off x="1353032" y="6269499"/>
+            <a:ext cx="9646920" cy="320040"/>
+          </a:xfrm>
+          <a:prstGeom prst="rect">
+            <a:avLst/>
+          </a:prstGeom>
+          <a:noFill/>
+        </p:spPr>
+        <p:txBody>
+          <a:bodyPr wrap="square" anchor="t">
+            <a:spAutoFit/>
+          </a:bodyPr>
+          <a:lstStyle/>
+          <a:p>
+            <a:pPr algn="ctr"/>
+            <a:r>
+              <a:rPr sz="1250" b="1" dirty="0">
+                <a:solidFill>
+                  <a:srgbClr val="192C4F"/>
+                </a:solidFill>
+                <a:latin typeface="Aptos"/>
+              </a:rPr>
+              <a:t>Trong </a:t>
+            </a:r>
+            <a:r>
+              <a:rPr sz="1250" b="1" dirty="0" err="1">
+                <a:solidFill>
+                  <a:srgbClr val="192C4F"/>
+                </a:solidFill>
+                <a:latin typeface="Aptos"/>
+              </a:rPr>
+              <a:t>thí</a:t>
+            </a:r>
+            <a:r>
+              <a:rPr sz="1250" b="1" dirty="0">
+                <a:solidFill>
+                  <a:srgbClr val="192C4F"/>
+                </a:solidFill>
+                <a:latin typeface="Aptos"/>
+              </a:rPr>
+              <a:t> </a:t>
+            </a:r>
+            <a:r>
+              <a:rPr sz="1250" b="1" dirty="0" err="1">
+                <a:solidFill>
+                  <a:srgbClr val="192C4F"/>
+                </a:solidFill>
+                <a:latin typeface="Aptos"/>
+              </a:rPr>
+              <a:t>nghiệm</a:t>
+            </a:r>
+            <a:r>
+              <a:rPr sz="1250" b="1" dirty="0">
+                <a:solidFill>
+                  <a:srgbClr val="192C4F"/>
+                </a:solidFill>
+                <a:latin typeface="Aptos"/>
+              </a:rPr>
+              <a:t>, </a:t>
+            </a:r>
+            <a:r>
+              <a:rPr sz="1250" b="1" dirty="0" err="1">
+                <a:solidFill>
+                  <a:srgbClr val="192C4F"/>
+                </a:solidFill>
+                <a:latin typeface="Aptos"/>
+              </a:rPr>
+              <a:t>một</a:t>
+            </a:r>
+            <a:r>
+              <a:rPr sz="1250" b="1" dirty="0">
+                <a:solidFill>
+                  <a:srgbClr val="192C4F"/>
+                </a:solidFill>
+                <a:latin typeface="Aptos"/>
+              </a:rPr>
+              <a:t> </a:t>
+            </a:r>
+            <a:r>
+              <a:rPr sz="1250" b="1" dirty="0" err="1">
+                <a:solidFill>
+                  <a:srgbClr val="192C4F"/>
+                </a:solidFill>
+                <a:latin typeface="Aptos"/>
+              </a:rPr>
+              <a:t>cấu</a:t>
+            </a:r>
+            <a:r>
+              <a:rPr sz="1250" b="1" dirty="0">
+                <a:solidFill>
+                  <a:srgbClr val="192C4F"/>
+                </a:solidFill>
+                <a:latin typeface="Aptos"/>
+              </a:rPr>
+              <a:t> </a:t>
+            </a:r>
+            <a:r>
+              <a:rPr sz="1250" b="1" dirty="0" err="1">
+                <a:solidFill>
+                  <a:srgbClr val="192C4F"/>
+                </a:solidFill>
+                <a:latin typeface="Aptos"/>
+              </a:rPr>
+              <a:t>hình</a:t>
+            </a:r>
+            <a:r>
+              <a:rPr sz="1250" b="1" dirty="0">
+                <a:solidFill>
+                  <a:srgbClr val="192C4F"/>
+                </a:solidFill>
+                <a:latin typeface="Aptos"/>
+              </a:rPr>
+              <a:t> K </a:t>
+            </a:r>
+            <a:r>
+              <a:rPr sz="1250" b="1" dirty="0" err="1">
+                <a:solidFill>
+                  <a:srgbClr val="192C4F"/>
+                </a:solidFill>
+                <a:latin typeface="Aptos"/>
+              </a:rPr>
+              <a:t>phù</a:t>
+            </a:r>
+            <a:r>
+              <a:rPr sz="1250" b="1" dirty="0">
+                <a:solidFill>
+                  <a:srgbClr val="192C4F"/>
+                </a:solidFill>
+                <a:latin typeface="Aptos"/>
+              </a:rPr>
+              <a:t> </a:t>
+            </a:r>
+            <a:r>
+              <a:rPr sz="1250" b="1" dirty="0" err="1">
+                <a:solidFill>
+                  <a:srgbClr val="192C4F"/>
+                </a:solidFill>
+                <a:latin typeface="Aptos"/>
+              </a:rPr>
+              <a:t>hợp</a:t>
+            </a:r>
+            <a:r>
+              <a:rPr sz="1250" b="1" dirty="0">
+                <a:solidFill>
+                  <a:srgbClr val="192C4F"/>
+                </a:solidFill>
+                <a:latin typeface="Aptos"/>
+              </a:rPr>
+              <a:t> </a:t>
+            </a:r>
+            <a:r>
+              <a:rPr sz="1250" b="1" dirty="0" err="1">
+                <a:solidFill>
+                  <a:srgbClr val="192C4F"/>
+                </a:solidFill>
+                <a:latin typeface="Aptos"/>
+              </a:rPr>
+              <a:t>giữ</a:t>
+            </a:r>
+            <a:r>
+              <a:rPr sz="1250" b="1" dirty="0">
+                <a:solidFill>
+                  <a:srgbClr val="192C4F"/>
+                </a:solidFill>
+                <a:latin typeface="Aptos"/>
+              </a:rPr>
+              <a:t> recommendation quality </a:t>
+            </a:r>
+            <a:r>
+              <a:rPr sz="1250" b="1" dirty="0" err="1">
+                <a:solidFill>
+                  <a:srgbClr val="192C4F"/>
+                </a:solidFill>
+                <a:latin typeface="Aptos"/>
+              </a:rPr>
+              <a:t>và</a:t>
+            </a:r>
+            <a:r>
+              <a:rPr sz="1250" b="1" dirty="0">
+                <a:solidFill>
+                  <a:srgbClr val="192C4F"/>
+                </a:solidFill>
+                <a:latin typeface="Aptos"/>
+              </a:rPr>
+              <a:t> </a:t>
+            </a:r>
+            <a:r>
+              <a:rPr sz="1250" b="1" dirty="0" err="1">
+                <a:solidFill>
+                  <a:srgbClr val="192C4F"/>
+                </a:solidFill>
+                <a:latin typeface="Aptos"/>
+              </a:rPr>
+              <a:t>gần</a:t>
+            </a:r>
+            <a:r>
+              <a:rPr sz="1250" b="1" dirty="0">
+                <a:solidFill>
+                  <a:srgbClr val="192C4F"/>
+                </a:solidFill>
+                <a:latin typeface="Aptos"/>
+              </a:rPr>
+              <a:t> </a:t>
+            </a:r>
+            <a:r>
+              <a:rPr sz="1250" b="1" dirty="0" err="1">
+                <a:solidFill>
+                  <a:srgbClr val="192C4F"/>
+                </a:solidFill>
+                <a:latin typeface="Aptos"/>
+              </a:rPr>
+              <a:t>như</a:t>
+            </a:r>
+            <a:r>
+              <a:rPr sz="1250" b="1" dirty="0">
+                <a:solidFill>
+                  <a:srgbClr val="192C4F"/>
+                </a:solidFill>
+                <a:latin typeface="Aptos"/>
+              </a:rPr>
+              <a:t> </a:t>
+            </a:r>
+            <a:r>
+              <a:rPr sz="1250" b="1" dirty="0" err="1">
+                <a:solidFill>
+                  <a:srgbClr val="192C4F"/>
+                </a:solidFill>
+                <a:latin typeface="Aptos"/>
+              </a:rPr>
+              <a:t>nhân</a:t>
+            </a:r>
+            <a:r>
+              <a:rPr sz="1250" b="1" dirty="0">
+                <a:solidFill>
+                  <a:srgbClr val="192C4F"/>
+                </a:solidFill>
+                <a:latin typeface="Aptos"/>
+              </a:rPr>
+              <a:t> </a:t>
+            </a:r>
+            <a:r>
+              <a:rPr sz="1250" b="1" dirty="0" err="1">
+                <a:solidFill>
+                  <a:srgbClr val="192C4F"/>
+                </a:solidFill>
+                <a:latin typeface="Aptos"/>
+              </a:rPr>
+              <a:t>đôi</a:t>
+            </a:r>
+            <a:r>
+              <a:rPr sz="1250" b="1" dirty="0">
+                <a:solidFill>
+                  <a:srgbClr val="192C4F"/>
+                </a:solidFill>
+                <a:latin typeface="Aptos"/>
+              </a:rPr>
+              <a:t> throughput.</a:t>
+            </a:r>
+          </a:p>
+        </p:txBody>
+      </p:sp>
+    </p:spTree>
+  </p:cSld>
+  <p:clrMapOvr>
+    <a:masterClrMapping/>
+  </p:clrMapOvr>
+</p:sld>
+</file>
+
+<file path=ppt/slides/slide11.xml><?xml version="1.0" encoding="utf-8"?>
+<p:sld xmlns:a="http://schemas.openxmlformats.org/drawingml/2006/main" xmlns:r="http://schemas.openxmlformats.org/officeDocument/2006/relationships" xmlns:p="http://schemas.openxmlformats.org/presentationml/2006/main">
+  <p:cSld>
+    <p:spTree>
+      <p:nvGrpSpPr>
+        <p:cNvPr id="1" name=""/>
+        <p:cNvGrpSpPr/>
+        <p:nvPr/>
+      </p:nvGrpSpPr>
+      <p:grpSpPr>
+        <a:xfrm>
+          <a:off x="0" y="0"/>
+          <a:ext cx="0" cy="0"/>
+          <a:chOff x="0" y="0"/>
+          <a:chExt cx="0" cy="0"/>
+        </a:xfrm>
+      </p:grpSpPr>
+      <p:pic>
+        <p:nvPicPr>
+          <p:cNvPr id="6" name="Picture 5" descr="GR4AD_Figure1.png"/>
+          <p:cNvPicPr>
+            <a:picLocks noChangeAspect="1"/>
+          </p:cNvPicPr>
+          <p:nvPr/>
+        </p:nvPicPr>
+        <p:blipFill>
+          <a:blip r:embed="rId3"/>
+          <a:stretch>
+            <a:fillRect/>
+          </a:stretch>
+        </p:blipFill>
+        <p:spPr>
+          <a:xfrm>
+            <a:off x="411480" y="1353312"/>
+            <a:ext cx="7543800" cy="4269335"/>
+          </a:xfrm>
+          <a:prstGeom prst="rect">
+            <a:avLst/>
+          </a:prstGeom>
+        </p:spPr>
+      </p:pic>
+      <p:sp>
+        <p:nvSpPr>
+          <p:cNvPr id="7" name="TextBox 6"/>
+          <p:cNvSpPr txBox="1"/>
+          <p:nvPr/>
+        </p:nvSpPr>
+        <p:spPr>
+          <a:xfrm>
+            <a:off x="502920" y="228600"/>
+            <a:ext cx="11064240" cy="475488"/>
+          </a:xfrm>
+          <a:prstGeom prst="rect">
+            <a:avLst/>
+          </a:prstGeom>
+          <a:noFill/>
+        </p:spPr>
+        <p:txBody>
+          <a:bodyPr wrap="square" anchor="ctr">
+            <a:spAutoFit/>
+          </a:bodyPr>
+          <a:lstStyle/>
+          <a:p>
+            <a:pPr algn="l"/>
+            <a:r>
+              <a:rPr sz="2400" b="1">
+                <a:solidFill>
+                  <a:srgbClr val="192C4F"/>
+                </a:solidFill>
+                <a:latin typeface="Aptos"/>
+              </a:rPr>
+              <a:t>VSL + RSPO — Tối ưu business value, không chỉ “đúng item”</a:t>
+            </a:r>
+          </a:p>
+        </p:txBody>
+      </p:sp>
+      <p:sp>
+        <p:nvSpPr>
+          <p:cNvPr id="8" name="TextBox 7"/>
+          <p:cNvSpPr txBox="1"/>
+          <p:nvPr/>
+        </p:nvSpPr>
+        <p:spPr>
+          <a:xfrm>
+            <a:off x="530352" y="731520"/>
+            <a:ext cx="10881360" cy="329184"/>
+          </a:xfrm>
+          <a:prstGeom prst="rect">
+            <a:avLst/>
+          </a:prstGeom>
+          <a:noFill/>
+        </p:spPr>
+        <p:txBody>
+          <a:bodyPr wrap="square" anchor="ctr">
+            <a:spAutoFit/>
+          </a:bodyPr>
+          <a:lstStyle/>
+          <a:p>
+            <a:pPr algn="l"/>
+            <a:r>
+              <a:rPr sz="1350" b="0">
+                <a:solidFill>
+                  <a:srgbClr val="676F7B"/>
+                </a:solidFill>
+                <a:latin typeface="Aptos"/>
+              </a:rPr>
+              <a:t>Ads trả về một ranked list; vì vậy per-item supervision chưa đủ để tối ưu doanh thu và thứ tự hiển thị.</a:t>
+            </a:r>
+          </a:p>
+        </p:txBody>
+      </p:sp>
+      <p:sp>
+        <p:nvSpPr>
+          <p:cNvPr id="9" name="Rounded Rectangle 8"/>
+          <p:cNvSpPr/>
+          <p:nvPr/>
+        </p:nvSpPr>
+        <p:spPr>
+          <a:xfrm>
+            <a:off x="8183879" y="1207008"/>
+            <a:ext cx="3429000" cy="2313432"/>
+          </a:xfrm>
+          <a:prstGeom prst="roundRect">
+            <a:avLst/>
+          </a:prstGeom>
+          <a:solidFill>
+            <a:srgbClr val="F9FAFC"/>
+          </a:solidFill>
+          <a:ln w="12700">
+            <a:solidFill>
+              <a:srgbClr val="DBE0E7"/>
+            </a:solidFill>
+          </a:ln>
+        </p:spPr>
+        <p:style>
+          <a:lnRef idx="1">
+            <a:schemeClr val="accent1"/>
+          </a:lnRef>
+          <a:fillRef idx="3">
+            <a:schemeClr val="accent1"/>
+          </a:fillRef>
+          <a:effectRef idx="2">
+            <a:schemeClr val="accent1"/>
+          </a:effectRef>
+          <a:fontRef idx="minor">
+            <a:schemeClr val="lt1"/>
+          </a:fontRef>
+        </p:style>
+        <p:txBody>
+          <a:bodyPr rtlCol="0" anchor="ctr"/>
+          <a:lstStyle/>
+          <a:p>
+            <a:pPr algn="ctr"/>
+            <a:endParaRPr/>
+          </a:p>
+        </p:txBody>
+      </p:sp>
+      <p:sp>
+        <p:nvSpPr>
+          <p:cNvPr id="10" name="TextBox 9"/>
+          <p:cNvSpPr txBox="1"/>
+          <p:nvPr/>
+        </p:nvSpPr>
+        <p:spPr>
+          <a:xfrm>
+            <a:off x="8348472" y="1389888"/>
+            <a:ext cx="2926080" cy="411480"/>
+          </a:xfrm>
+          <a:prstGeom prst="rect">
+            <a:avLst/>
+          </a:prstGeom>
+          <a:noFill/>
+        </p:spPr>
+        <p:txBody>
+          <a:bodyPr wrap="square" anchor="t">
+            <a:spAutoFit/>
+          </a:bodyPr>
+          <a:lstStyle/>
+          <a:p>
+            <a:pPr algn="l"/>
+            <a:r>
+              <a:rPr sz="1550" b="1" dirty="0">
+                <a:solidFill>
+                  <a:srgbClr val="368461"/>
+                </a:solidFill>
+                <a:latin typeface="Aptos"/>
+              </a:rPr>
+              <a:t>VSL · Value-Aware Supervised Learning</a:t>
+            </a:r>
+          </a:p>
+        </p:txBody>
+      </p:sp>
+      <p:sp>
+        <p:nvSpPr>
+          <p:cNvPr id="11" name="TextBox 10"/>
+          <p:cNvSpPr txBox="1"/>
+          <p:nvPr/>
+        </p:nvSpPr>
+        <p:spPr>
+          <a:xfrm>
+            <a:off x="8394192" y="1933114"/>
+            <a:ext cx="2834640" cy="1234440"/>
+          </a:xfrm>
+          <a:prstGeom prst="rect">
+            <a:avLst/>
+          </a:prstGeom>
+          <a:noFill/>
+        </p:spPr>
+        <p:txBody>
+          <a:bodyPr wrap="square">
+            <a:spAutoFit/>
+          </a:bodyPr>
+          <a:lstStyle/>
+          <a:p>
+            <a:pPr>
+              <a:lnSpc>
+                <a:spcPct val="105000"/>
+              </a:lnSpc>
+              <a:spcAft>
+                <a:spcPts val="600"/>
+              </a:spcAft>
+              <a:defRPr sz="1270">
+                <a:solidFill>
+                  <a:srgbClr val="2B3341"/>
+                </a:solidFill>
+                <a:latin typeface="Aptos"/>
+              </a:defRPr>
+            </a:pPr>
+            <a:r>
+              <a:rPr dirty="0"/>
+              <a:t>• Học SID </a:t>
+            </a:r>
+            <a:r>
+              <a:rPr dirty="0" err="1"/>
+              <a:t>bằng</a:t>
+            </a:r>
+            <a:r>
+              <a:rPr dirty="0"/>
+              <a:t> cross-entropy </a:t>
+            </a:r>
+            <a:r>
+              <a:rPr dirty="0" err="1"/>
+              <a:t>như</a:t>
+            </a:r>
+            <a:r>
+              <a:rPr dirty="0"/>
+              <a:t> </a:t>
+            </a:r>
+            <a:r>
+              <a:rPr dirty="0" err="1"/>
+              <a:t>bình</a:t>
+            </a:r>
+            <a:r>
+              <a:rPr dirty="0"/>
+              <a:t> </a:t>
+            </a:r>
+            <a:r>
+              <a:rPr dirty="0" err="1"/>
+              <a:t>thường</a:t>
+            </a:r>
+            <a:r>
+              <a:rPr dirty="0"/>
+              <a:t>.</a:t>
+            </a:r>
+          </a:p>
+          <a:p>
+            <a:pPr>
+              <a:lnSpc>
+                <a:spcPct val="105000"/>
+              </a:lnSpc>
+              <a:spcAft>
+                <a:spcPts val="600"/>
+              </a:spcAft>
+              <a:defRPr sz="1270">
+                <a:solidFill>
+                  <a:srgbClr val="2B3341"/>
+                </a:solidFill>
+                <a:latin typeface="Aptos"/>
+              </a:defRPr>
+            </a:pPr>
+            <a:r>
+              <a:rPr dirty="0"/>
+              <a:t>• </a:t>
+            </a:r>
+            <a:r>
+              <a:rPr dirty="0" err="1"/>
+              <a:t>Thêm</a:t>
+            </a:r>
+            <a:r>
+              <a:rPr dirty="0"/>
+              <a:t> </a:t>
+            </a:r>
+            <a:r>
+              <a:rPr dirty="0" err="1"/>
+              <a:t>eCPM</a:t>
+            </a:r>
+            <a:r>
+              <a:rPr dirty="0"/>
+              <a:t> token </a:t>
+            </a:r>
+            <a:r>
+              <a:rPr dirty="0" err="1"/>
+              <a:t>để</a:t>
+            </a:r>
+            <a:r>
+              <a:rPr dirty="0"/>
+              <a:t> model </a:t>
+            </a:r>
+            <a:r>
+              <a:rPr dirty="0" err="1"/>
+              <a:t>học</a:t>
+            </a:r>
+            <a:r>
+              <a:rPr dirty="0"/>
+              <a:t> business value </a:t>
+            </a:r>
+            <a:r>
+              <a:rPr dirty="0" err="1"/>
+              <a:t>của</a:t>
+            </a:r>
+            <a:r>
+              <a:rPr dirty="0"/>
+              <a:t> candidate.</a:t>
+            </a:r>
+          </a:p>
+          <a:p>
+            <a:pPr>
+              <a:lnSpc>
+                <a:spcPct val="105000"/>
+              </a:lnSpc>
+              <a:spcAft>
+                <a:spcPts val="600"/>
+              </a:spcAft>
+              <a:defRPr sz="1270">
+                <a:solidFill>
+                  <a:srgbClr val="2B3341"/>
+                </a:solidFill>
+                <a:latin typeface="Aptos"/>
+              </a:defRPr>
+            </a:pPr>
+            <a:r>
+              <a:rPr dirty="0"/>
+              <a:t>• Sample weight </a:t>
+            </a:r>
+            <a:r>
+              <a:rPr dirty="0" err="1"/>
+              <a:t>phụ</a:t>
+            </a:r>
+            <a:r>
+              <a:rPr dirty="0"/>
+              <a:t> </a:t>
+            </a:r>
+            <a:r>
+              <a:rPr dirty="0" err="1"/>
+              <a:t>thuộc</a:t>
+            </a:r>
+            <a:r>
+              <a:rPr dirty="0"/>
+              <a:t> </a:t>
+            </a:r>
+            <a:r>
+              <a:rPr dirty="0" err="1"/>
+              <a:t>giá</a:t>
+            </a:r>
+            <a:r>
+              <a:rPr dirty="0"/>
+              <a:t> </a:t>
+            </a:r>
+            <a:r>
+              <a:rPr dirty="0" err="1"/>
+              <a:t>trị</a:t>
+            </a:r>
+            <a:r>
+              <a:rPr dirty="0"/>
+              <a:t> user </a:t>
+            </a:r>
+            <a:r>
+              <a:rPr dirty="0" err="1"/>
+              <a:t>và</a:t>
+            </a:r>
+            <a:r>
+              <a:rPr dirty="0"/>
+              <a:t> </a:t>
+            </a:r>
+            <a:r>
+              <a:rPr dirty="0" err="1"/>
+              <a:t>mức</a:t>
+            </a:r>
+            <a:r>
+              <a:rPr dirty="0"/>
+              <a:t> </a:t>
+            </a:r>
+            <a:r>
+              <a:rPr dirty="0" err="1"/>
+              <a:t>độ</a:t>
+            </a:r>
+            <a:r>
+              <a:rPr dirty="0"/>
+              <a:t> behavior.</a:t>
+            </a:r>
+          </a:p>
+        </p:txBody>
+      </p:sp>
+      <p:sp>
+        <p:nvSpPr>
+          <p:cNvPr id="12" name="Rounded Rectangle 11"/>
+          <p:cNvSpPr/>
+          <p:nvPr/>
+        </p:nvSpPr>
+        <p:spPr>
+          <a:xfrm>
+            <a:off x="8183879" y="3675886"/>
+            <a:ext cx="3429000" cy="2736946"/>
+          </a:xfrm>
+          <a:prstGeom prst="roundRect">
+            <a:avLst/>
+          </a:prstGeom>
+          <a:solidFill>
+            <a:srgbClr val="F9FAFC"/>
+          </a:solidFill>
+          <a:ln w="12700">
+            <a:solidFill>
+              <a:srgbClr val="DBE0E7"/>
+            </a:solidFill>
+          </a:ln>
+        </p:spPr>
+        <p:style>
+          <a:lnRef idx="1">
+            <a:schemeClr val="accent1"/>
+          </a:lnRef>
+          <a:fillRef idx="3">
+            <a:schemeClr val="accent1"/>
+          </a:fillRef>
+          <a:effectRef idx="2">
+            <a:schemeClr val="accent1"/>
+          </a:effectRef>
+          <a:fontRef idx="minor">
+            <a:schemeClr val="lt1"/>
+          </a:fontRef>
+        </p:style>
+        <p:txBody>
+          <a:bodyPr rtlCol="0" anchor="ctr"/>
+          <a:lstStyle/>
+          <a:p>
+            <a:pPr algn="ctr"/>
+            <a:endParaRPr/>
+          </a:p>
+        </p:txBody>
+      </p:sp>
+      <p:sp>
+        <p:nvSpPr>
+          <p:cNvPr id="13" name="TextBox 12"/>
+          <p:cNvSpPr txBox="1"/>
+          <p:nvPr/>
+        </p:nvSpPr>
+        <p:spPr>
+          <a:xfrm>
+            <a:off x="8412480" y="3781886"/>
+            <a:ext cx="2926080" cy="411480"/>
+          </a:xfrm>
+          <a:prstGeom prst="rect">
+            <a:avLst/>
+          </a:prstGeom>
+          <a:noFill/>
+        </p:spPr>
+        <p:txBody>
+          <a:bodyPr wrap="square" anchor="t">
+            <a:spAutoFit/>
+          </a:bodyPr>
+          <a:lstStyle/>
+          <a:p>
+            <a:pPr algn="l"/>
+            <a:r>
+              <a:rPr sz="1550" b="1" dirty="0">
+                <a:solidFill>
+                  <a:srgbClr val="685094"/>
+                </a:solidFill>
+                <a:latin typeface="Aptos"/>
+              </a:rPr>
+              <a:t>RSPO · List-wise Preference Optimization</a:t>
+            </a:r>
+          </a:p>
+        </p:txBody>
+      </p:sp>
+      <p:sp>
+        <p:nvSpPr>
+          <p:cNvPr id="14" name="TextBox 13"/>
+          <p:cNvSpPr txBox="1"/>
+          <p:nvPr/>
+        </p:nvSpPr>
+        <p:spPr>
+          <a:xfrm>
+            <a:off x="8394192" y="4325112"/>
+            <a:ext cx="2834640" cy="1325880"/>
+          </a:xfrm>
+          <a:prstGeom prst="rect">
+            <a:avLst/>
+          </a:prstGeom>
+          <a:noFill/>
+        </p:spPr>
+        <p:txBody>
+          <a:bodyPr wrap="square">
+            <a:spAutoFit/>
+          </a:bodyPr>
+          <a:lstStyle/>
+          <a:p>
+            <a:pPr>
+              <a:lnSpc>
+                <a:spcPct val="105000"/>
+              </a:lnSpc>
+              <a:spcAft>
+                <a:spcPts val="600"/>
+              </a:spcAft>
+              <a:defRPr sz="1240">
+                <a:solidFill>
+                  <a:srgbClr val="2B3341"/>
+                </a:solidFill>
+                <a:latin typeface="Aptos"/>
+              </a:defRPr>
+            </a:pPr>
+            <a:r>
+              <a:rPr dirty="0"/>
+              <a:t>• VSL </a:t>
+            </a:r>
+            <a:r>
+              <a:rPr dirty="0" err="1"/>
+              <a:t>chủ</a:t>
+            </a:r>
+            <a:r>
+              <a:rPr dirty="0"/>
+              <a:t> </a:t>
+            </a:r>
+            <a:r>
+              <a:rPr dirty="0" err="1"/>
+              <a:t>yếu</a:t>
+            </a:r>
+            <a:r>
+              <a:rPr dirty="0"/>
+              <a:t> fit logged distribution; </a:t>
+            </a:r>
+            <a:r>
+              <a:rPr dirty="0" err="1"/>
+              <a:t>chưa</a:t>
+            </a:r>
+            <a:r>
+              <a:rPr dirty="0"/>
+              <a:t> </a:t>
+            </a:r>
+            <a:r>
+              <a:rPr dirty="0" err="1"/>
+              <a:t>trực</a:t>
+            </a:r>
+            <a:r>
+              <a:rPr dirty="0"/>
+              <a:t> </a:t>
+            </a:r>
+            <a:r>
+              <a:rPr dirty="0" err="1"/>
+              <a:t>tiếp</a:t>
+            </a:r>
+            <a:r>
+              <a:rPr dirty="0"/>
+              <a:t> </a:t>
+            </a:r>
+            <a:r>
+              <a:rPr dirty="0" err="1"/>
+              <a:t>tối</a:t>
+            </a:r>
+            <a:r>
+              <a:rPr dirty="0"/>
+              <a:t> </a:t>
+            </a:r>
+            <a:r>
+              <a:rPr dirty="0" err="1"/>
+              <a:t>ưu</a:t>
+            </a:r>
+            <a:r>
+              <a:rPr dirty="0"/>
+              <a:t> downstream objective.</a:t>
+            </a:r>
+          </a:p>
+          <a:p>
+            <a:pPr>
+              <a:lnSpc>
+                <a:spcPct val="105000"/>
+              </a:lnSpc>
+              <a:spcAft>
+                <a:spcPts val="600"/>
+              </a:spcAft>
+              <a:defRPr sz="1240">
+                <a:solidFill>
+                  <a:srgbClr val="2B3341"/>
+                </a:solidFill>
+                <a:latin typeface="Aptos"/>
+              </a:defRPr>
+            </a:pPr>
+            <a:r>
+              <a:rPr dirty="0"/>
+              <a:t>• RSPO </a:t>
+            </a:r>
+            <a:r>
+              <a:rPr dirty="0" err="1"/>
+              <a:t>dùng</a:t>
+            </a:r>
+            <a:r>
+              <a:rPr dirty="0"/>
+              <a:t> reward (</a:t>
+            </a:r>
+            <a:r>
+              <a:rPr dirty="0" err="1"/>
+              <a:t>eCPM</a:t>
+            </a:r>
+            <a:r>
+              <a:rPr dirty="0"/>
+              <a:t>) </a:t>
+            </a:r>
+            <a:r>
+              <a:rPr dirty="0" err="1"/>
+              <a:t>trên</a:t>
+            </a:r>
+            <a:r>
+              <a:rPr dirty="0"/>
+              <a:t> </a:t>
+            </a:r>
+            <a:r>
+              <a:rPr dirty="0" err="1"/>
+              <a:t>cả</a:t>
+            </a:r>
+            <a:r>
+              <a:rPr dirty="0"/>
+              <a:t> candidate list </a:t>
+            </a:r>
+            <a:r>
+              <a:rPr dirty="0" err="1"/>
+              <a:t>và</a:t>
+            </a:r>
+            <a:r>
+              <a:rPr dirty="0"/>
+              <a:t> align objective </a:t>
+            </a:r>
+            <a:r>
+              <a:rPr dirty="0" err="1"/>
+              <a:t>với</a:t>
+            </a:r>
+            <a:r>
+              <a:rPr dirty="0"/>
+              <a:t> ranking/NDCG.</a:t>
+            </a:r>
+          </a:p>
+          <a:p>
+            <a:pPr>
+              <a:lnSpc>
+                <a:spcPct val="105000"/>
+              </a:lnSpc>
+              <a:spcAft>
+                <a:spcPts val="600"/>
+              </a:spcAft>
+              <a:defRPr sz="1240">
+                <a:solidFill>
+                  <a:srgbClr val="2B3341"/>
+                </a:solidFill>
+                <a:latin typeface="Aptos"/>
+              </a:defRPr>
+            </a:pPr>
+            <a:r>
+              <a:rPr dirty="0"/>
+              <a:t>• Cho </a:t>
+            </a:r>
+            <a:r>
+              <a:rPr dirty="0" err="1"/>
+              <a:t>phép</a:t>
+            </a:r>
+            <a:r>
+              <a:rPr dirty="0"/>
+              <a:t> controlled exploration </a:t>
+            </a:r>
+            <a:r>
+              <a:rPr dirty="0" err="1"/>
+              <a:t>nhưng</a:t>
+            </a:r>
+            <a:r>
+              <a:rPr dirty="0"/>
+              <a:t> </a:t>
+            </a:r>
+            <a:r>
+              <a:rPr dirty="0" err="1"/>
+              <a:t>vẫn</a:t>
+            </a:r>
+            <a:r>
+              <a:rPr dirty="0"/>
+              <a:t> </a:t>
+            </a:r>
+            <a:r>
+              <a:rPr dirty="0" err="1"/>
+              <a:t>giữ</a:t>
+            </a:r>
+            <a:r>
+              <a:rPr dirty="0"/>
+              <a:t> model </a:t>
+            </a:r>
+            <a:r>
+              <a:rPr dirty="0" err="1"/>
+              <a:t>gần</a:t>
+            </a:r>
+            <a:r>
+              <a:rPr dirty="0"/>
+              <a:t> distribution </a:t>
+            </a:r>
+            <a:r>
+              <a:rPr dirty="0" err="1"/>
+              <a:t>đã</a:t>
+            </a:r>
+            <a:r>
+              <a:rPr dirty="0"/>
+              <a:t> </a:t>
+            </a:r>
+            <a:r>
+              <a:rPr dirty="0" err="1"/>
+              <a:t>học</a:t>
+            </a:r>
+            <a:r>
+              <a:rPr dirty="0"/>
+              <a:t>.</a:t>
+            </a:r>
+          </a:p>
+        </p:txBody>
+      </p:sp>
+      <p:sp>
+        <p:nvSpPr>
+          <p:cNvPr id="15" name="TextBox 14"/>
+          <p:cNvSpPr txBox="1"/>
+          <p:nvPr/>
+        </p:nvSpPr>
+        <p:spPr>
+          <a:xfrm>
+            <a:off x="914400" y="5989320"/>
+            <a:ext cx="6492240" cy="347472"/>
+          </a:xfrm>
+          <a:prstGeom prst="rect">
+            <a:avLst/>
+          </a:prstGeom>
+          <a:noFill/>
+        </p:spPr>
+        <p:txBody>
+          <a:bodyPr wrap="square" anchor="t">
+            <a:spAutoFit/>
+          </a:bodyPr>
+          <a:lstStyle/>
+          <a:p>
+            <a:pPr algn="ctr"/>
+            <a:r>
+              <a:rPr sz="1250" b="1">
+                <a:solidFill>
+                  <a:srgbClr val="192C4F"/>
+                </a:solidFill>
+                <a:latin typeface="Aptos"/>
+              </a:rPr>
+              <a:t>Mục tiêu cuối: sinh một ranked set có giá trị, không chỉ một tập candidate liên quan.</a:t>
+            </a:r>
+          </a:p>
+        </p:txBody>
+      </p:sp>
+      <p:sp>
+        <p:nvSpPr>
+          <p:cNvPr id="16" name="TextBox 15"/>
+          <p:cNvSpPr txBox="1"/>
+          <p:nvPr/>
+        </p:nvSpPr>
+        <p:spPr>
+          <a:xfrm>
+            <a:off x="8348472" y="6442792"/>
+            <a:ext cx="3931920" cy="256032"/>
+          </a:xfrm>
+          <a:prstGeom prst="rect">
+            <a:avLst/>
+          </a:prstGeom>
+          <a:noFill/>
+        </p:spPr>
+        <p:txBody>
+          <a:bodyPr wrap="square" anchor="ctr">
+            <a:spAutoFit/>
+          </a:bodyPr>
+          <a:lstStyle/>
+          <a:p>
+            <a:pPr algn="l"/>
+            <a:r>
+              <a:rPr sz="950" b="0" dirty="0" err="1">
+                <a:solidFill>
+                  <a:srgbClr val="676F7B"/>
+                </a:solidFill>
+                <a:latin typeface="Aptos"/>
+              </a:rPr>
+              <a:t>Nguồn</a:t>
+            </a:r>
+            <a:r>
+              <a:rPr sz="950" b="0" dirty="0">
+                <a:solidFill>
+                  <a:srgbClr val="676F7B"/>
+                </a:solidFill>
+                <a:latin typeface="Aptos"/>
+              </a:rPr>
+              <a:t>: GR4AD, §3.3–3.4 &amp; Fig.1 · arXiv:2602.22732v3</a:t>
+            </a:r>
+          </a:p>
+        </p:txBody>
+      </p:sp>
+    </p:spTree>
+  </p:cSld>
+  <p:clrMapOvr>
+    <a:masterClrMapping/>
+  </p:clrMapOvr>
+</p:sld>
+</file>
+
+<file path=ppt/slides/slide12.xml><?xml version="1.0" encoding="utf-8"?>
+<p:sld xmlns:a="http://schemas.openxmlformats.org/drawingml/2006/main" xmlns:r="http://schemas.openxmlformats.org/officeDocument/2006/relationships" xmlns:p="http://schemas.openxmlformats.org/presentationml/2006/main">
   <p:cSld name="Slide 8">
     <p:spTree>
       <p:nvGrpSpPr>
@@ -1638,7 +3262,7 @@
         <p:spPr>
           <a:xfrm>
             <a:off x="7315200" y="1353312"/>
-            <a:ext cx="4297680" cy="3429000"/>
+            <a:ext cx="4297680" cy="3794760"/>
           </a:xfrm>
           <a:prstGeom prst="roundRect">
             <a:avLst/>
@@ -2625,7 +4249,7 @@
 </p:sld>
 </file>
 
-<file path=ppt/slides/slide11.xml><?xml version="1.0" encoding="utf-8"?>
+<file path=ppt/slides/slide13.xml><?xml version="1.0" encoding="utf-8"?>
 <p:sld xmlns:a="http://schemas.openxmlformats.org/drawingml/2006/main" xmlns:r="http://schemas.openxmlformats.org/officeDocument/2006/relationships" xmlns:p="http://schemas.openxmlformats.org/presentationml/2006/main">
   <p:cSld name="Slide 11">
     <p:spTree>
@@ -3310,66 +4934,6 @@
         </p:txBody>
       </p:sp>
     </p:spTree>
-  </p:cSld>
-  <p:clrMapOvr>
-    <a:masterClrMapping/>
-  </p:clrMapOvr>
-</p:sld>
-</file>
-
-<file path=ppt/slides/slide12.xml><?xml version="1.0" encoding="utf-8"?>
-<p:sld xmlns:a="http://schemas.openxmlformats.org/drawingml/2006/main" xmlns:r="http://schemas.openxmlformats.org/officeDocument/2006/relationships" xmlns:p="http://schemas.openxmlformats.org/presentationml/2006/main">
-  <p:cSld>
-    <p:spTree>
-      <p:nvGrpSpPr>
-        <p:cNvPr id="1" name=""/>
-        <p:cNvGrpSpPr/>
-        <p:nvPr/>
-      </p:nvGrpSpPr>
-      <p:grpSpPr>
-        <a:xfrm>
-          <a:off x="0" y="0"/>
-          <a:ext cx="0" cy="0"/>
-          <a:chOff x="0" y="0"/>
-          <a:chExt cx="0" cy="0"/>
-        </a:xfrm>
-      </p:grpSpPr>
-      <p:pic>
-        <p:nvPicPr>
-          <p:cNvPr id="3" name="Picture 2">
-            <a:extLst>
-              <a:ext uri="{FF2B5EF4-FFF2-40B4-BE49-F238E27FC236}">
-                <a16:creationId xmlns:a16="http://schemas.microsoft.com/office/drawing/2014/main" id="{9AFCEB2C-91C3-5CCC-B0CC-A3C1AEE7ECFA}"/>
-              </a:ext>
-            </a:extLst>
-          </p:cNvPr>
-          <p:cNvPicPr>
-            <a:picLocks noChangeAspect="1"/>
-          </p:cNvPicPr>
-          <p:nvPr/>
-        </p:nvPicPr>
-        <p:blipFill>
-          <a:blip r:embed="rId2"/>
-          <a:stretch>
-            <a:fillRect/>
-          </a:stretch>
-        </p:blipFill>
-        <p:spPr>
-          <a:xfrm>
-            <a:off x="0" y="805042"/>
-            <a:ext cx="12192000" cy="5247916"/>
-          </a:xfrm>
-          <a:prstGeom prst="rect">
-            <a:avLst/>
-          </a:prstGeom>
-        </p:spPr>
-      </p:pic>
-    </p:spTree>
-    <p:extLst>
-      <p:ext uri="{BB962C8B-B14F-4D97-AF65-F5344CB8AC3E}">
-        <p14:creationId xmlns:p14="http://schemas.microsoft.com/office/powerpoint/2010/main" val="3235951530"/>
-      </p:ext>
-    </p:extLst>
   </p:cSld>
   <p:clrMapOvr>
     <a:masterClrMapping/>
@@ -4327,7 +5891,7 @@
         </p:blipFill>
         <p:spPr>
           <a:xfrm>
-            <a:off x="615725" y="1297421"/>
+            <a:off x="615725" y="828558"/>
             <a:ext cx="10960549" cy="4263157"/>
           </a:xfrm>
           <a:prstGeom prst="rect">
@@ -4385,6 +5949,66 @@
 </file>
 
 <file path=ppt/slides/slide4.xml><?xml version="1.0" encoding="utf-8"?>
+<p:sld xmlns:a="http://schemas.openxmlformats.org/drawingml/2006/main" xmlns:r="http://schemas.openxmlformats.org/officeDocument/2006/relationships" xmlns:p="http://schemas.openxmlformats.org/presentationml/2006/main">
+  <p:cSld>
+    <p:spTree>
+      <p:nvGrpSpPr>
+        <p:cNvPr id="1" name=""/>
+        <p:cNvGrpSpPr/>
+        <p:nvPr/>
+      </p:nvGrpSpPr>
+      <p:grpSpPr>
+        <a:xfrm>
+          <a:off x="0" y="0"/>
+          <a:ext cx="0" cy="0"/>
+          <a:chOff x="0" y="0"/>
+          <a:chExt cx="0" cy="0"/>
+        </a:xfrm>
+      </p:grpSpPr>
+      <p:pic>
+        <p:nvPicPr>
+          <p:cNvPr id="2" name="Picture 1" descr="深度剖析RQ-VAE：从向量量化到生成式推荐的语义ID技术- 石头开会- 博客园">
+            <a:extLst>
+              <a:ext uri="{FF2B5EF4-FFF2-40B4-BE49-F238E27FC236}">
+                <a16:creationId xmlns:a16="http://schemas.microsoft.com/office/drawing/2014/main" id="{116150A3-0C9C-CE8E-2215-5F6482D7968F}"/>
+              </a:ext>
+            </a:extLst>
+          </p:cNvPr>
+          <p:cNvPicPr>
+            <a:picLocks noChangeAspect="1"/>
+          </p:cNvPicPr>
+          <p:nvPr/>
+        </p:nvPicPr>
+        <p:blipFill>
+          <a:blip r:embed="rId2"/>
+          <a:stretch>
+            <a:fillRect/>
+          </a:stretch>
+        </p:blipFill>
+        <p:spPr>
+          <a:xfrm>
+            <a:off x="1285290" y="655475"/>
+            <a:ext cx="9185655" cy="5213480"/>
+          </a:xfrm>
+          <a:prstGeom prst="rect">
+            <a:avLst/>
+          </a:prstGeom>
+        </p:spPr>
+      </p:pic>
+    </p:spTree>
+    <p:extLst>
+      <p:ext uri="{BB962C8B-B14F-4D97-AF65-F5344CB8AC3E}">
+        <p14:creationId xmlns:p14="http://schemas.microsoft.com/office/powerpoint/2010/main" val="1376345734"/>
+      </p:ext>
+    </p:extLst>
+  </p:cSld>
+  <p:clrMapOvr>
+    <a:masterClrMapping/>
+  </p:clrMapOvr>
+</p:sld>
+</file>
+
+<file path=ppt/slides/slide5.xml><?xml version="1.0" encoding="utf-8"?>
 <p:sld xmlns:a="http://schemas.openxmlformats.org/drawingml/2006/main" xmlns:r="http://schemas.openxmlformats.org/officeDocument/2006/relationships" xmlns:p="http://schemas.openxmlformats.org/presentationml/2006/main">
   <p:cSld name="Slide 5">
     <p:spTree>
@@ -5171,7 +6795,67 @@
 </p:sld>
 </file>
 
-<file path=ppt/slides/slide5.xml><?xml version="1.0" encoding="utf-8"?>
+<file path=ppt/slides/slide6.xml><?xml version="1.0" encoding="utf-8"?>
+<p:sld xmlns:a="http://schemas.openxmlformats.org/drawingml/2006/main" xmlns:r="http://schemas.openxmlformats.org/officeDocument/2006/relationships" xmlns:p="http://schemas.openxmlformats.org/presentationml/2006/main">
+  <p:cSld>
+    <p:spTree>
+      <p:nvGrpSpPr>
+        <p:cNvPr id="1" name=""/>
+        <p:cNvGrpSpPr/>
+        <p:nvPr/>
+      </p:nvGrpSpPr>
+      <p:grpSpPr>
+        <a:xfrm>
+          <a:off x="0" y="0"/>
+          <a:ext cx="0" cy="0"/>
+          <a:chOff x="0" y="0"/>
+          <a:chExt cx="0" cy="0"/>
+        </a:xfrm>
+      </p:grpSpPr>
+      <p:pic>
+        <p:nvPicPr>
+          <p:cNvPr id="3" name="Picture 2">
+            <a:extLst>
+              <a:ext uri="{FF2B5EF4-FFF2-40B4-BE49-F238E27FC236}">
+                <a16:creationId xmlns:a16="http://schemas.microsoft.com/office/drawing/2014/main" id="{9AFCEB2C-91C3-5CCC-B0CC-A3C1AEE7ECFA}"/>
+              </a:ext>
+            </a:extLst>
+          </p:cNvPr>
+          <p:cNvPicPr>
+            <a:picLocks noChangeAspect="1"/>
+          </p:cNvPicPr>
+          <p:nvPr/>
+        </p:nvPicPr>
+        <p:blipFill>
+          <a:blip r:embed="rId2"/>
+          <a:stretch>
+            <a:fillRect/>
+          </a:stretch>
+        </p:blipFill>
+        <p:spPr>
+          <a:xfrm>
+            <a:off x="0" y="805042"/>
+            <a:ext cx="12192000" cy="5247916"/>
+          </a:xfrm>
+          <a:prstGeom prst="rect">
+            <a:avLst/>
+          </a:prstGeom>
+        </p:spPr>
+      </p:pic>
+    </p:spTree>
+    <p:extLst>
+      <p:ext uri="{BB962C8B-B14F-4D97-AF65-F5344CB8AC3E}">
+        <p14:creationId xmlns:p14="http://schemas.microsoft.com/office/powerpoint/2010/main" val="3235951530"/>
+      </p:ext>
+    </p:extLst>
+  </p:cSld>
+  <p:clrMapOvr>
+    <a:masterClrMapping/>
+  </p:clrMapOvr>
+</p:sld>
+</file>
+
+<file path=ppt/slides/slide7.xml><?xml version="1.0" encoding="utf-8"?>
 <p:sld xmlns:a="http://schemas.openxmlformats.org/drawingml/2006/main" xmlns:r="http://schemas.openxmlformats.org/officeDocument/2006/relationships" xmlns:p="http://schemas.openxmlformats.org/presentationml/2006/main">
   <p:cSld name="Slide 7">
     <p:spTree>
@@ -5940,7 +7624,7 @@
 </p:sld>
 </file>
 
-<file path=ppt/slides/slide6.xml><?xml version="1.0" encoding="utf-8"?>
+<file path=ppt/slides/slide8.xml><?xml version="1.0" encoding="utf-8"?>
 <p:sld xmlns:a="http://schemas.openxmlformats.org/drawingml/2006/main" xmlns:r="http://schemas.openxmlformats.org/officeDocument/2006/relationships" xmlns:p="http://schemas.openxmlformats.org/presentationml/2006/main">
   <p:cSld>
     <p:spTree>
@@ -6593,7 +8277,7 @@
 </p:sld>
 </file>
 
-<file path=ppt/slides/slide7.xml><?xml version="1.0" encoding="utf-8"?>
+<file path=ppt/slides/slide9.xml><?xml version="1.0" encoding="utf-8"?>
 <p:sld xmlns:a="http://schemas.openxmlformats.org/drawingml/2006/main" xmlns:r="http://schemas.openxmlformats.org/officeDocument/2006/relationships" xmlns:p="http://schemas.openxmlformats.org/presentationml/2006/main">
   <p:cSld>
     <p:spTree>
@@ -7335,1629 +9019,6 @@
         <p14:creationId xmlns:p14="http://schemas.microsoft.com/office/powerpoint/2010/main" val="3768493168"/>
       </p:ext>
     </p:extLst>
-  </p:cSld>
-  <p:clrMapOvr>
-    <a:masterClrMapping/>
-  </p:clrMapOvr>
-</p:sld>
-</file>
-
-<file path=ppt/slides/slide8.xml><?xml version="1.0" encoding="utf-8"?>
-<p:sld xmlns:a="http://schemas.openxmlformats.org/drawingml/2006/main" xmlns:r="http://schemas.openxmlformats.org/officeDocument/2006/relationships" xmlns:p="http://schemas.openxmlformats.org/presentationml/2006/main">
-  <p:cSld>
-    <p:spTree>
-      <p:nvGrpSpPr>
-        <p:cNvPr id="1" name=""/>
-        <p:cNvGrpSpPr/>
-        <p:nvPr/>
-      </p:nvGrpSpPr>
-      <p:grpSpPr>
-        <a:xfrm>
-          <a:off x="0" y="0"/>
-          <a:ext cx="0" cy="0"/>
-          <a:chOff x="0" y="0"/>
-          <a:chExt cx="0" cy="0"/>
-        </a:xfrm>
-      </p:grpSpPr>
-      <p:pic>
-        <p:nvPicPr>
-          <p:cNvPr id="6" name="Picture 5" descr="image.png"/>
-          <p:cNvPicPr>
-            <a:picLocks noChangeAspect="1"/>
-          </p:cNvPicPr>
-          <p:nvPr/>
-        </p:nvPicPr>
-        <p:blipFill>
-          <a:blip r:embed="rId3"/>
-          <a:stretch>
-            <a:fillRect/>
-          </a:stretch>
-        </p:blipFill>
-        <p:spPr>
-          <a:xfrm>
-            <a:off x="1494764" y="1115793"/>
-            <a:ext cx="9363456" cy="3446837"/>
-          </a:xfrm>
-          <a:prstGeom prst="rect">
-            <a:avLst/>
-          </a:prstGeom>
-        </p:spPr>
-      </p:pic>
-      <p:sp>
-        <p:nvSpPr>
-          <p:cNvPr id="7" name="TextBox 6"/>
-          <p:cNvSpPr txBox="1"/>
-          <p:nvPr/>
-        </p:nvSpPr>
-        <p:spPr>
-          <a:xfrm>
-            <a:off x="502920" y="228600"/>
-            <a:ext cx="11064240" cy="475488"/>
-          </a:xfrm>
-          <a:prstGeom prst="rect">
-            <a:avLst/>
-          </a:prstGeom>
-          <a:noFill/>
-        </p:spPr>
-        <p:txBody>
-          <a:bodyPr wrap="square" anchor="ctr">
-            <a:spAutoFit/>
-          </a:bodyPr>
-          <a:lstStyle/>
-          <a:p>
-            <a:pPr algn="l"/>
-            <a:r>
-              <a:rPr sz="2400" b="1">
-                <a:solidFill>
-                  <a:srgbClr val="192C4F"/>
-                </a:solidFill>
-                <a:latin typeface="Aptos"/>
-              </a:rPr>
-              <a:t>LazyAR — Không phải mọi decoder layer đều cần autoregressive</a:t>
-            </a:r>
-          </a:p>
-        </p:txBody>
-      </p:sp>
-      <p:sp>
-        <p:nvSpPr>
-          <p:cNvPr id="8" name="TextBox 7"/>
-          <p:cNvSpPr txBox="1"/>
-          <p:nvPr/>
-        </p:nvSpPr>
-        <p:spPr>
-          <a:xfrm>
-            <a:off x="530352" y="731520"/>
-            <a:ext cx="10881360" cy="329184"/>
-          </a:xfrm>
-          <a:prstGeom prst="rect">
-            <a:avLst/>
-          </a:prstGeom>
-          <a:noFill/>
-        </p:spPr>
-        <p:txBody>
-          <a:bodyPr wrap="square" anchor="ctr">
-            <a:spAutoFit/>
-          </a:bodyPr>
-          <a:lstStyle/>
-          <a:p>
-            <a:pPr algn="l"/>
-            <a:r>
-              <a:rPr sz="1350" b="0">
-                <a:solidFill>
-                  <a:srgbClr val="676F7B"/>
-                </a:solidFill>
-                <a:latin typeface="Aptos"/>
-              </a:rPr>
-              <a:t>Ý tưởng cốt lõi: chỉ inject token trước ở layer muộn; phần đầu được tính song song và reuse qua beam.</a:t>
-            </a:r>
-          </a:p>
-        </p:txBody>
-      </p:sp>
-      <p:sp>
-        <p:nvSpPr>
-          <p:cNvPr id="9" name="Rounded Rectangle 8"/>
-          <p:cNvSpPr/>
-          <p:nvPr/>
-        </p:nvSpPr>
-        <p:spPr>
-          <a:xfrm>
-            <a:off x="1173295" y="4617719"/>
-            <a:ext cx="3063240" cy="1417320"/>
-          </a:xfrm>
-          <a:prstGeom prst="roundRect">
-            <a:avLst/>
-          </a:prstGeom>
-          <a:solidFill>
-            <a:srgbClr val="F9FAFC"/>
-          </a:solidFill>
-          <a:ln w="12700">
-            <a:solidFill>
-              <a:srgbClr val="DBE0E7"/>
-            </a:solidFill>
-          </a:ln>
-        </p:spPr>
-        <p:style>
-          <a:lnRef idx="1">
-            <a:schemeClr val="accent1"/>
-          </a:lnRef>
-          <a:fillRef idx="3">
-            <a:schemeClr val="accent1"/>
-          </a:fillRef>
-          <a:effectRef idx="2">
-            <a:schemeClr val="accent1"/>
-          </a:effectRef>
-          <a:fontRef idx="minor">
-            <a:schemeClr val="lt1"/>
-          </a:fontRef>
-        </p:style>
-        <p:txBody>
-          <a:bodyPr rtlCol="0" anchor="ctr"/>
-          <a:lstStyle/>
-          <a:p>
-            <a:pPr algn="ctr"/>
-            <a:endParaRPr/>
-          </a:p>
-        </p:txBody>
-      </p:sp>
-      <p:sp>
-        <p:nvSpPr>
-          <p:cNvPr id="10" name="TextBox 9"/>
-          <p:cNvSpPr txBox="1"/>
-          <p:nvPr/>
-        </p:nvSpPr>
-        <p:spPr>
-          <a:xfrm>
-            <a:off x="1242277" y="4806235"/>
-            <a:ext cx="2743200" cy="256032"/>
-          </a:xfrm>
-          <a:prstGeom prst="rect">
-            <a:avLst/>
-          </a:prstGeom>
-          <a:noFill/>
-        </p:spPr>
-        <p:txBody>
-          <a:bodyPr wrap="square" anchor="t">
-            <a:spAutoFit/>
-          </a:bodyPr>
-          <a:lstStyle/>
-          <a:p>
-            <a:pPr algn="l"/>
-            <a:r>
-              <a:rPr sz="1550" b="1" dirty="0">
-                <a:solidFill>
-                  <a:srgbClr val="B74646"/>
-                </a:solidFill>
-                <a:latin typeface="Aptos"/>
-              </a:rPr>
-              <a:t>Vanilla AR</a:t>
-            </a:r>
-          </a:p>
-        </p:txBody>
-      </p:sp>
-      <p:sp>
-        <p:nvSpPr>
-          <p:cNvPr id="11" name="TextBox 10"/>
-          <p:cNvSpPr txBox="1"/>
-          <p:nvPr/>
-        </p:nvSpPr>
-        <p:spPr>
-          <a:xfrm>
-            <a:off x="1242277" y="5179497"/>
-            <a:ext cx="2743200" cy="749808"/>
-          </a:xfrm>
-          <a:prstGeom prst="rect">
-            <a:avLst/>
-          </a:prstGeom>
-          <a:noFill/>
-        </p:spPr>
-        <p:txBody>
-          <a:bodyPr wrap="square" anchor="t">
-            <a:spAutoFit/>
-          </a:bodyPr>
-          <a:lstStyle/>
-          <a:p>
-            <a:pPr algn="l"/>
-            <a:r>
-              <a:rPr sz="1180" b="0" dirty="0" err="1">
-                <a:solidFill>
-                  <a:srgbClr val="2B3341"/>
-                </a:solidFill>
-                <a:latin typeface="Aptos"/>
-              </a:rPr>
-              <a:t>Mỗi</a:t>
-            </a:r>
-            <a:r>
-              <a:rPr sz="1180" b="0" dirty="0">
-                <a:solidFill>
-                  <a:srgbClr val="2B3341"/>
-                </a:solidFill>
-                <a:latin typeface="Aptos"/>
-              </a:rPr>
-              <a:t> step </a:t>
-            </a:r>
-            <a:r>
-              <a:rPr sz="1180" b="0" dirty="0" err="1">
-                <a:solidFill>
-                  <a:srgbClr val="2B3341"/>
-                </a:solidFill>
-                <a:latin typeface="Aptos"/>
-              </a:rPr>
-              <a:t>chạy</a:t>
-            </a:r>
-            <a:r>
-              <a:rPr sz="1180" b="0" dirty="0">
-                <a:solidFill>
-                  <a:srgbClr val="2B3341"/>
-                </a:solidFill>
-                <a:latin typeface="Aptos"/>
-              </a:rPr>
-              <a:t> qua </a:t>
-            </a:r>
-            <a:r>
-              <a:rPr sz="1180" b="0" dirty="0" err="1">
-                <a:solidFill>
-                  <a:srgbClr val="2B3341"/>
-                </a:solidFill>
-                <a:latin typeface="Aptos"/>
-              </a:rPr>
-              <a:t>toàn</a:t>
-            </a:r>
-            <a:r>
-              <a:rPr sz="1180" b="0" dirty="0">
-                <a:solidFill>
-                  <a:srgbClr val="2B3341"/>
-                </a:solidFill>
-                <a:latin typeface="Aptos"/>
-              </a:rPr>
-              <a:t> </a:t>
-            </a:r>
-            <a:r>
-              <a:rPr sz="1180" b="0" dirty="0" err="1">
-                <a:solidFill>
-                  <a:srgbClr val="2B3341"/>
-                </a:solidFill>
-                <a:latin typeface="Aptos"/>
-              </a:rPr>
-              <a:t>bộ</a:t>
-            </a:r>
-            <a:r>
-              <a:rPr sz="1180" b="0" dirty="0">
-                <a:solidFill>
-                  <a:srgbClr val="2B3341"/>
-                </a:solidFill>
-                <a:latin typeface="Aptos"/>
-              </a:rPr>
-              <a:t> decoder </a:t>
-            </a:r>
-            <a:r>
-              <a:rPr sz="1180" b="0" dirty="0" err="1">
-                <a:solidFill>
-                  <a:srgbClr val="2B3341"/>
-                </a:solidFill>
-                <a:latin typeface="Aptos"/>
-              </a:rPr>
-              <a:t>và</a:t>
-            </a:r>
-            <a:r>
-              <a:rPr sz="1180" b="0" dirty="0">
-                <a:solidFill>
-                  <a:srgbClr val="2B3341"/>
-                </a:solidFill>
-                <a:latin typeface="Aptos"/>
-              </a:rPr>
-              <a:t> </a:t>
-            </a:r>
-            <a:r>
-              <a:rPr sz="1180" b="0" dirty="0" err="1">
-                <a:solidFill>
-                  <a:srgbClr val="2B3341"/>
-                </a:solidFill>
-                <a:latin typeface="Aptos"/>
-              </a:rPr>
-              <a:t>phụ</a:t>
-            </a:r>
-            <a:r>
-              <a:rPr sz="1180" b="0" dirty="0">
-                <a:solidFill>
-                  <a:srgbClr val="2B3341"/>
-                </a:solidFill>
-                <a:latin typeface="Aptos"/>
-              </a:rPr>
-              <a:t> </a:t>
-            </a:r>
-            <a:r>
-              <a:rPr sz="1180" b="0" dirty="0" err="1">
-                <a:solidFill>
-                  <a:srgbClr val="2B3341"/>
-                </a:solidFill>
-                <a:latin typeface="Aptos"/>
-              </a:rPr>
-              <a:t>thuộc</a:t>
-            </a:r>
-            <a:r>
-              <a:rPr sz="1180" b="0" dirty="0">
-                <a:solidFill>
-                  <a:srgbClr val="2B3341"/>
-                </a:solidFill>
-                <a:latin typeface="Aptos"/>
-              </a:rPr>
-              <a:t> token </a:t>
-            </a:r>
-            <a:r>
-              <a:rPr sz="1180" b="0" dirty="0" err="1">
-                <a:solidFill>
-                  <a:srgbClr val="2B3341"/>
-                </a:solidFill>
-                <a:latin typeface="Aptos"/>
-              </a:rPr>
-              <a:t>trước</a:t>
-            </a:r>
-            <a:r>
-              <a:rPr sz="1180" b="0" dirty="0">
-                <a:solidFill>
-                  <a:srgbClr val="2B3341"/>
-                </a:solidFill>
-                <a:latin typeface="Aptos"/>
-              </a:rPr>
-              <a:t> → sequential cost </a:t>
-            </a:r>
-            <a:r>
-              <a:rPr sz="1180" b="0" dirty="0" err="1">
-                <a:solidFill>
-                  <a:srgbClr val="2B3341"/>
-                </a:solidFill>
-                <a:latin typeface="Aptos"/>
-              </a:rPr>
-              <a:t>lớn</a:t>
-            </a:r>
-            <a:r>
-              <a:rPr sz="1180" b="0" dirty="0">
-                <a:solidFill>
-                  <a:srgbClr val="2B3341"/>
-                </a:solidFill>
-                <a:latin typeface="Aptos"/>
-              </a:rPr>
-              <a:t> </a:t>
-            </a:r>
-            <a:r>
-              <a:rPr sz="1180" b="0" dirty="0" err="1">
-                <a:solidFill>
-                  <a:srgbClr val="2B3341"/>
-                </a:solidFill>
-                <a:latin typeface="Aptos"/>
-              </a:rPr>
-              <a:t>khi</a:t>
-            </a:r>
-            <a:r>
-              <a:rPr sz="1180" b="0" dirty="0">
-                <a:solidFill>
-                  <a:srgbClr val="2B3341"/>
-                </a:solidFill>
-                <a:latin typeface="Aptos"/>
-              </a:rPr>
-              <a:t> beam </a:t>
-            </a:r>
-            <a:r>
-              <a:rPr sz="1180" b="0" dirty="0" err="1">
-                <a:solidFill>
-                  <a:srgbClr val="2B3341"/>
-                </a:solidFill>
-                <a:latin typeface="Aptos"/>
-              </a:rPr>
-              <a:t>tăng</a:t>
-            </a:r>
-            <a:r>
-              <a:rPr sz="1180" b="0" dirty="0">
-                <a:solidFill>
-                  <a:srgbClr val="2B3341"/>
-                </a:solidFill>
-                <a:latin typeface="Aptos"/>
-              </a:rPr>
-              <a:t>.</a:t>
-            </a:r>
-          </a:p>
-        </p:txBody>
-      </p:sp>
-      <p:sp>
-        <p:nvSpPr>
-          <p:cNvPr id="15" name="Rounded Rectangle 14"/>
-          <p:cNvSpPr/>
-          <p:nvPr/>
-        </p:nvSpPr>
-        <p:spPr>
-          <a:xfrm>
-            <a:off x="7955466" y="4645039"/>
-            <a:ext cx="3063240" cy="1417320"/>
-          </a:xfrm>
-          <a:prstGeom prst="roundRect">
-            <a:avLst/>
-          </a:prstGeom>
-          <a:solidFill>
-            <a:srgbClr val="F9FAFC"/>
-          </a:solidFill>
-          <a:ln w="12700">
-            <a:solidFill>
-              <a:srgbClr val="DBE0E7"/>
-            </a:solidFill>
-          </a:ln>
-        </p:spPr>
-        <p:style>
-          <a:lnRef idx="1">
-            <a:schemeClr val="accent1"/>
-          </a:lnRef>
-          <a:fillRef idx="3">
-            <a:schemeClr val="accent1"/>
-          </a:fillRef>
-          <a:effectRef idx="2">
-            <a:schemeClr val="accent1"/>
-          </a:effectRef>
-          <a:fontRef idx="minor">
-            <a:schemeClr val="lt1"/>
-          </a:fontRef>
-        </p:style>
-        <p:txBody>
-          <a:bodyPr rtlCol="0" anchor="ctr"/>
-          <a:lstStyle/>
-          <a:p>
-            <a:pPr algn="ctr"/>
-            <a:endParaRPr/>
-          </a:p>
-        </p:txBody>
-      </p:sp>
-      <p:sp>
-        <p:nvSpPr>
-          <p:cNvPr id="16" name="TextBox 15"/>
-          <p:cNvSpPr txBox="1"/>
-          <p:nvPr/>
-        </p:nvSpPr>
-        <p:spPr>
-          <a:xfrm>
-            <a:off x="8120057" y="4763911"/>
-            <a:ext cx="2743200" cy="256032"/>
-          </a:xfrm>
-          <a:prstGeom prst="rect">
-            <a:avLst/>
-          </a:prstGeom>
-          <a:noFill/>
-        </p:spPr>
-        <p:txBody>
-          <a:bodyPr wrap="square" anchor="t">
-            <a:spAutoFit/>
-          </a:bodyPr>
-          <a:lstStyle/>
-          <a:p>
-            <a:pPr algn="l"/>
-            <a:r>
-              <a:rPr sz="1550" b="1">
-                <a:solidFill>
-                  <a:srgbClr val="368461"/>
-                </a:solidFill>
-                <a:latin typeface="Aptos"/>
-              </a:rPr>
-              <a:t>LazyAR</a:t>
-            </a:r>
-          </a:p>
-        </p:txBody>
-      </p:sp>
-      <p:sp>
-        <p:nvSpPr>
-          <p:cNvPr id="17" name="TextBox 16"/>
-          <p:cNvSpPr txBox="1"/>
-          <p:nvPr/>
-        </p:nvSpPr>
-        <p:spPr>
-          <a:xfrm>
-            <a:off x="8120057" y="5102239"/>
-            <a:ext cx="2743200" cy="749808"/>
-          </a:xfrm>
-          <a:prstGeom prst="rect">
-            <a:avLst/>
-          </a:prstGeom>
-          <a:noFill/>
-        </p:spPr>
-        <p:txBody>
-          <a:bodyPr wrap="square" anchor="t">
-            <a:spAutoFit/>
-          </a:bodyPr>
-          <a:lstStyle/>
-          <a:p>
-            <a:pPr algn="l"/>
-            <a:r>
-              <a:rPr sz="1180" b="0">
-                <a:solidFill>
-                  <a:srgbClr val="2B3341"/>
-                </a:solidFill>
-                <a:latin typeface="Aptos"/>
-              </a:rPr>
-              <a:t>K layer đầu không phụ thuộc token trước → chạy song song, share qua beams. Chỉ L−K layer sau còn autoregressive.</a:t>
-            </a:r>
-          </a:p>
-        </p:txBody>
-      </p:sp>
-      <p:sp>
-        <p:nvSpPr>
-          <p:cNvPr id="18" name="TextBox 17"/>
-          <p:cNvSpPr txBox="1"/>
-          <p:nvPr/>
-        </p:nvSpPr>
-        <p:spPr>
-          <a:xfrm>
-            <a:off x="1353032" y="6269499"/>
-            <a:ext cx="9646920" cy="320040"/>
-          </a:xfrm>
-          <a:prstGeom prst="rect">
-            <a:avLst/>
-          </a:prstGeom>
-          <a:noFill/>
-        </p:spPr>
-        <p:txBody>
-          <a:bodyPr wrap="square" anchor="t">
-            <a:spAutoFit/>
-          </a:bodyPr>
-          <a:lstStyle/>
-          <a:p>
-            <a:pPr algn="ctr"/>
-            <a:r>
-              <a:rPr sz="1250" b="1" dirty="0">
-                <a:solidFill>
-                  <a:srgbClr val="192C4F"/>
-                </a:solidFill>
-                <a:latin typeface="Aptos"/>
-              </a:rPr>
-              <a:t>Trong </a:t>
-            </a:r>
-            <a:r>
-              <a:rPr sz="1250" b="1" dirty="0" err="1">
-                <a:solidFill>
-                  <a:srgbClr val="192C4F"/>
-                </a:solidFill>
-                <a:latin typeface="Aptos"/>
-              </a:rPr>
-              <a:t>thí</a:t>
-            </a:r>
-            <a:r>
-              <a:rPr sz="1250" b="1" dirty="0">
-                <a:solidFill>
-                  <a:srgbClr val="192C4F"/>
-                </a:solidFill>
-                <a:latin typeface="Aptos"/>
-              </a:rPr>
-              <a:t> </a:t>
-            </a:r>
-            <a:r>
-              <a:rPr sz="1250" b="1" dirty="0" err="1">
-                <a:solidFill>
-                  <a:srgbClr val="192C4F"/>
-                </a:solidFill>
-                <a:latin typeface="Aptos"/>
-              </a:rPr>
-              <a:t>nghiệm</a:t>
-            </a:r>
-            <a:r>
-              <a:rPr sz="1250" b="1" dirty="0">
-                <a:solidFill>
-                  <a:srgbClr val="192C4F"/>
-                </a:solidFill>
-                <a:latin typeface="Aptos"/>
-              </a:rPr>
-              <a:t>, </a:t>
-            </a:r>
-            <a:r>
-              <a:rPr sz="1250" b="1" dirty="0" err="1">
-                <a:solidFill>
-                  <a:srgbClr val="192C4F"/>
-                </a:solidFill>
-                <a:latin typeface="Aptos"/>
-              </a:rPr>
-              <a:t>một</a:t>
-            </a:r>
-            <a:r>
-              <a:rPr sz="1250" b="1" dirty="0">
-                <a:solidFill>
-                  <a:srgbClr val="192C4F"/>
-                </a:solidFill>
-                <a:latin typeface="Aptos"/>
-              </a:rPr>
-              <a:t> </a:t>
-            </a:r>
-            <a:r>
-              <a:rPr sz="1250" b="1" dirty="0" err="1">
-                <a:solidFill>
-                  <a:srgbClr val="192C4F"/>
-                </a:solidFill>
-                <a:latin typeface="Aptos"/>
-              </a:rPr>
-              <a:t>cấu</a:t>
-            </a:r>
-            <a:r>
-              <a:rPr sz="1250" b="1" dirty="0">
-                <a:solidFill>
-                  <a:srgbClr val="192C4F"/>
-                </a:solidFill>
-                <a:latin typeface="Aptos"/>
-              </a:rPr>
-              <a:t> </a:t>
-            </a:r>
-            <a:r>
-              <a:rPr sz="1250" b="1" dirty="0" err="1">
-                <a:solidFill>
-                  <a:srgbClr val="192C4F"/>
-                </a:solidFill>
-                <a:latin typeface="Aptos"/>
-              </a:rPr>
-              <a:t>hình</a:t>
-            </a:r>
-            <a:r>
-              <a:rPr sz="1250" b="1" dirty="0">
-                <a:solidFill>
-                  <a:srgbClr val="192C4F"/>
-                </a:solidFill>
-                <a:latin typeface="Aptos"/>
-              </a:rPr>
-              <a:t> K </a:t>
-            </a:r>
-            <a:r>
-              <a:rPr sz="1250" b="1" dirty="0" err="1">
-                <a:solidFill>
-                  <a:srgbClr val="192C4F"/>
-                </a:solidFill>
-                <a:latin typeface="Aptos"/>
-              </a:rPr>
-              <a:t>phù</a:t>
-            </a:r>
-            <a:r>
-              <a:rPr sz="1250" b="1" dirty="0">
-                <a:solidFill>
-                  <a:srgbClr val="192C4F"/>
-                </a:solidFill>
-                <a:latin typeface="Aptos"/>
-              </a:rPr>
-              <a:t> </a:t>
-            </a:r>
-            <a:r>
-              <a:rPr sz="1250" b="1" dirty="0" err="1">
-                <a:solidFill>
-                  <a:srgbClr val="192C4F"/>
-                </a:solidFill>
-                <a:latin typeface="Aptos"/>
-              </a:rPr>
-              <a:t>hợp</a:t>
-            </a:r>
-            <a:r>
-              <a:rPr sz="1250" b="1" dirty="0">
-                <a:solidFill>
-                  <a:srgbClr val="192C4F"/>
-                </a:solidFill>
-                <a:latin typeface="Aptos"/>
-              </a:rPr>
-              <a:t> </a:t>
-            </a:r>
-            <a:r>
-              <a:rPr sz="1250" b="1" dirty="0" err="1">
-                <a:solidFill>
-                  <a:srgbClr val="192C4F"/>
-                </a:solidFill>
-                <a:latin typeface="Aptos"/>
-              </a:rPr>
-              <a:t>giữ</a:t>
-            </a:r>
-            <a:r>
-              <a:rPr sz="1250" b="1" dirty="0">
-                <a:solidFill>
-                  <a:srgbClr val="192C4F"/>
-                </a:solidFill>
-                <a:latin typeface="Aptos"/>
-              </a:rPr>
-              <a:t> recommendation quality </a:t>
-            </a:r>
-            <a:r>
-              <a:rPr sz="1250" b="1" dirty="0" err="1">
-                <a:solidFill>
-                  <a:srgbClr val="192C4F"/>
-                </a:solidFill>
-                <a:latin typeface="Aptos"/>
-              </a:rPr>
-              <a:t>và</a:t>
-            </a:r>
-            <a:r>
-              <a:rPr sz="1250" b="1" dirty="0">
-                <a:solidFill>
-                  <a:srgbClr val="192C4F"/>
-                </a:solidFill>
-                <a:latin typeface="Aptos"/>
-              </a:rPr>
-              <a:t> </a:t>
-            </a:r>
-            <a:r>
-              <a:rPr sz="1250" b="1" dirty="0" err="1">
-                <a:solidFill>
-                  <a:srgbClr val="192C4F"/>
-                </a:solidFill>
-                <a:latin typeface="Aptos"/>
-              </a:rPr>
-              <a:t>gần</a:t>
-            </a:r>
-            <a:r>
-              <a:rPr sz="1250" b="1" dirty="0">
-                <a:solidFill>
-                  <a:srgbClr val="192C4F"/>
-                </a:solidFill>
-                <a:latin typeface="Aptos"/>
-              </a:rPr>
-              <a:t> </a:t>
-            </a:r>
-            <a:r>
-              <a:rPr sz="1250" b="1" dirty="0" err="1">
-                <a:solidFill>
-                  <a:srgbClr val="192C4F"/>
-                </a:solidFill>
-                <a:latin typeface="Aptos"/>
-              </a:rPr>
-              <a:t>như</a:t>
-            </a:r>
-            <a:r>
-              <a:rPr sz="1250" b="1" dirty="0">
-                <a:solidFill>
-                  <a:srgbClr val="192C4F"/>
-                </a:solidFill>
-                <a:latin typeface="Aptos"/>
-              </a:rPr>
-              <a:t> </a:t>
-            </a:r>
-            <a:r>
-              <a:rPr sz="1250" b="1" dirty="0" err="1">
-                <a:solidFill>
-                  <a:srgbClr val="192C4F"/>
-                </a:solidFill>
-                <a:latin typeface="Aptos"/>
-              </a:rPr>
-              <a:t>nhân</a:t>
-            </a:r>
-            <a:r>
-              <a:rPr sz="1250" b="1" dirty="0">
-                <a:solidFill>
-                  <a:srgbClr val="192C4F"/>
-                </a:solidFill>
-                <a:latin typeface="Aptos"/>
-              </a:rPr>
-              <a:t> </a:t>
-            </a:r>
-            <a:r>
-              <a:rPr sz="1250" b="1" dirty="0" err="1">
-                <a:solidFill>
-                  <a:srgbClr val="192C4F"/>
-                </a:solidFill>
-                <a:latin typeface="Aptos"/>
-              </a:rPr>
-              <a:t>đôi</a:t>
-            </a:r>
-            <a:r>
-              <a:rPr sz="1250" b="1" dirty="0">
-                <a:solidFill>
-                  <a:srgbClr val="192C4F"/>
-                </a:solidFill>
-                <a:latin typeface="Aptos"/>
-              </a:rPr>
-              <a:t> throughput.</a:t>
-            </a:r>
-          </a:p>
-        </p:txBody>
-      </p:sp>
-    </p:spTree>
-  </p:cSld>
-  <p:clrMapOvr>
-    <a:masterClrMapping/>
-  </p:clrMapOvr>
-</p:sld>
-</file>
-
-<file path=ppt/slides/slide9.xml><?xml version="1.0" encoding="utf-8"?>
-<p:sld xmlns:a="http://schemas.openxmlformats.org/drawingml/2006/main" xmlns:r="http://schemas.openxmlformats.org/officeDocument/2006/relationships" xmlns:p="http://schemas.openxmlformats.org/presentationml/2006/main">
-  <p:cSld>
-    <p:spTree>
-      <p:nvGrpSpPr>
-        <p:cNvPr id="1" name=""/>
-        <p:cNvGrpSpPr/>
-        <p:nvPr/>
-      </p:nvGrpSpPr>
-      <p:grpSpPr>
-        <a:xfrm>
-          <a:off x="0" y="0"/>
-          <a:ext cx="0" cy="0"/>
-          <a:chOff x="0" y="0"/>
-          <a:chExt cx="0" cy="0"/>
-        </a:xfrm>
-      </p:grpSpPr>
-      <p:pic>
-        <p:nvPicPr>
-          <p:cNvPr id="6" name="Picture 5" descr="GR4AD_Figure1.png"/>
-          <p:cNvPicPr>
-            <a:picLocks noChangeAspect="1"/>
-          </p:cNvPicPr>
-          <p:nvPr/>
-        </p:nvPicPr>
-        <p:blipFill>
-          <a:blip r:embed="rId3"/>
-          <a:stretch>
-            <a:fillRect/>
-          </a:stretch>
-        </p:blipFill>
-        <p:spPr>
-          <a:xfrm>
-            <a:off x="411480" y="1353312"/>
-            <a:ext cx="7543800" cy="4269335"/>
-          </a:xfrm>
-          <a:prstGeom prst="rect">
-            <a:avLst/>
-          </a:prstGeom>
-        </p:spPr>
-      </p:pic>
-      <p:sp>
-        <p:nvSpPr>
-          <p:cNvPr id="7" name="TextBox 6"/>
-          <p:cNvSpPr txBox="1"/>
-          <p:nvPr/>
-        </p:nvSpPr>
-        <p:spPr>
-          <a:xfrm>
-            <a:off x="502920" y="228600"/>
-            <a:ext cx="11064240" cy="475488"/>
-          </a:xfrm>
-          <a:prstGeom prst="rect">
-            <a:avLst/>
-          </a:prstGeom>
-          <a:noFill/>
-        </p:spPr>
-        <p:txBody>
-          <a:bodyPr wrap="square" anchor="ctr">
-            <a:spAutoFit/>
-          </a:bodyPr>
-          <a:lstStyle/>
-          <a:p>
-            <a:pPr algn="l"/>
-            <a:r>
-              <a:rPr sz="2400" b="1">
-                <a:solidFill>
-                  <a:srgbClr val="192C4F"/>
-                </a:solidFill>
-                <a:latin typeface="Aptos"/>
-              </a:rPr>
-              <a:t>VSL + RSPO — Tối ưu business value, không chỉ “đúng item”</a:t>
-            </a:r>
-          </a:p>
-        </p:txBody>
-      </p:sp>
-      <p:sp>
-        <p:nvSpPr>
-          <p:cNvPr id="8" name="TextBox 7"/>
-          <p:cNvSpPr txBox="1"/>
-          <p:nvPr/>
-        </p:nvSpPr>
-        <p:spPr>
-          <a:xfrm>
-            <a:off x="530352" y="731520"/>
-            <a:ext cx="10881360" cy="329184"/>
-          </a:xfrm>
-          <a:prstGeom prst="rect">
-            <a:avLst/>
-          </a:prstGeom>
-          <a:noFill/>
-        </p:spPr>
-        <p:txBody>
-          <a:bodyPr wrap="square" anchor="ctr">
-            <a:spAutoFit/>
-          </a:bodyPr>
-          <a:lstStyle/>
-          <a:p>
-            <a:pPr algn="l"/>
-            <a:r>
-              <a:rPr sz="1350" b="0">
-                <a:solidFill>
-                  <a:srgbClr val="676F7B"/>
-                </a:solidFill>
-                <a:latin typeface="Aptos"/>
-              </a:rPr>
-              <a:t>Ads trả về một ranked list; vì vậy per-item supervision chưa đủ để tối ưu doanh thu và thứ tự hiển thị.</a:t>
-            </a:r>
-          </a:p>
-        </p:txBody>
-      </p:sp>
-      <p:sp>
-        <p:nvSpPr>
-          <p:cNvPr id="9" name="Rounded Rectangle 8"/>
-          <p:cNvSpPr/>
-          <p:nvPr/>
-        </p:nvSpPr>
-        <p:spPr>
-          <a:xfrm>
-            <a:off x="8183879" y="1207008"/>
-            <a:ext cx="3429000" cy="2313432"/>
-          </a:xfrm>
-          <a:prstGeom prst="roundRect">
-            <a:avLst/>
-          </a:prstGeom>
-          <a:solidFill>
-            <a:srgbClr val="F9FAFC"/>
-          </a:solidFill>
-          <a:ln w="12700">
-            <a:solidFill>
-              <a:srgbClr val="DBE0E7"/>
-            </a:solidFill>
-          </a:ln>
-        </p:spPr>
-        <p:style>
-          <a:lnRef idx="1">
-            <a:schemeClr val="accent1"/>
-          </a:lnRef>
-          <a:fillRef idx="3">
-            <a:schemeClr val="accent1"/>
-          </a:fillRef>
-          <a:effectRef idx="2">
-            <a:schemeClr val="accent1"/>
-          </a:effectRef>
-          <a:fontRef idx="minor">
-            <a:schemeClr val="lt1"/>
-          </a:fontRef>
-        </p:style>
-        <p:txBody>
-          <a:bodyPr rtlCol="0" anchor="ctr"/>
-          <a:lstStyle/>
-          <a:p>
-            <a:pPr algn="ctr"/>
-            <a:endParaRPr/>
-          </a:p>
-        </p:txBody>
-      </p:sp>
-      <p:sp>
-        <p:nvSpPr>
-          <p:cNvPr id="10" name="TextBox 9"/>
-          <p:cNvSpPr txBox="1"/>
-          <p:nvPr/>
-        </p:nvSpPr>
-        <p:spPr>
-          <a:xfrm>
-            <a:off x="8348472" y="1389888"/>
-            <a:ext cx="2926080" cy="411480"/>
-          </a:xfrm>
-          <a:prstGeom prst="rect">
-            <a:avLst/>
-          </a:prstGeom>
-          <a:noFill/>
-        </p:spPr>
-        <p:txBody>
-          <a:bodyPr wrap="square" anchor="t">
-            <a:spAutoFit/>
-          </a:bodyPr>
-          <a:lstStyle/>
-          <a:p>
-            <a:pPr algn="l"/>
-            <a:r>
-              <a:rPr sz="1550" b="1" dirty="0">
-                <a:solidFill>
-                  <a:srgbClr val="368461"/>
-                </a:solidFill>
-                <a:latin typeface="Aptos"/>
-              </a:rPr>
-              <a:t>VSL · Value-Aware Supervised Learning</a:t>
-            </a:r>
-          </a:p>
-        </p:txBody>
-      </p:sp>
-      <p:sp>
-        <p:nvSpPr>
-          <p:cNvPr id="11" name="TextBox 10"/>
-          <p:cNvSpPr txBox="1"/>
-          <p:nvPr/>
-        </p:nvSpPr>
-        <p:spPr>
-          <a:xfrm>
-            <a:off x="8394192" y="1933114"/>
-            <a:ext cx="2834640" cy="1234440"/>
-          </a:xfrm>
-          <a:prstGeom prst="rect">
-            <a:avLst/>
-          </a:prstGeom>
-          <a:noFill/>
-        </p:spPr>
-        <p:txBody>
-          <a:bodyPr wrap="square">
-            <a:spAutoFit/>
-          </a:bodyPr>
-          <a:lstStyle/>
-          <a:p>
-            <a:pPr>
-              <a:lnSpc>
-                <a:spcPct val="105000"/>
-              </a:lnSpc>
-              <a:spcAft>
-                <a:spcPts val="600"/>
-              </a:spcAft>
-              <a:defRPr sz="1270">
-                <a:solidFill>
-                  <a:srgbClr val="2B3341"/>
-                </a:solidFill>
-                <a:latin typeface="Aptos"/>
-              </a:defRPr>
-            </a:pPr>
-            <a:r>
-              <a:rPr dirty="0"/>
-              <a:t>• Học SID </a:t>
-            </a:r>
-            <a:r>
-              <a:rPr dirty="0" err="1"/>
-              <a:t>bằng</a:t>
-            </a:r>
-            <a:r>
-              <a:rPr dirty="0"/>
-              <a:t> cross-entropy </a:t>
-            </a:r>
-            <a:r>
-              <a:rPr dirty="0" err="1"/>
-              <a:t>như</a:t>
-            </a:r>
-            <a:r>
-              <a:rPr dirty="0"/>
-              <a:t> </a:t>
-            </a:r>
-            <a:r>
-              <a:rPr dirty="0" err="1"/>
-              <a:t>bình</a:t>
-            </a:r>
-            <a:r>
-              <a:rPr dirty="0"/>
-              <a:t> </a:t>
-            </a:r>
-            <a:r>
-              <a:rPr dirty="0" err="1"/>
-              <a:t>thường</a:t>
-            </a:r>
-            <a:r>
-              <a:rPr dirty="0"/>
-              <a:t>.</a:t>
-            </a:r>
-          </a:p>
-          <a:p>
-            <a:pPr>
-              <a:lnSpc>
-                <a:spcPct val="105000"/>
-              </a:lnSpc>
-              <a:spcAft>
-                <a:spcPts val="600"/>
-              </a:spcAft>
-              <a:defRPr sz="1270">
-                <a:solidFill>
-                  <a:srgbClr val="2B3341"/>
-                </a:solidFill>
-                <a:latin typeface="Aptos"/>
-              </a:defRPr>
-            </a:pPr>
-            <a:r>
-              <a:rPr dirty="0"/>
-              <a:t>• </a:t>
-            </a:r>
-            <a:r>
-              <a:rPr dirty="0" err="1"/>
-              <a:t>Thêm</a:t>
-            </a:r>
-            <a:r>
-              <a:rPr dirty="0"/>
-              <a:t> </a:t>
-            </a:r>
-            <a:r>
-              <a:rPr dirty="0" err="1"/>
-              <a:t>eCPM</a:t>
-            </a:r>
-            <a:r>
-              <a:rPr dirty="0"/>
-              <a:t> token </a:t>
-            </a:r>
-            <a:r>
-              <a:rPr dirty="0" err="1"/>
-              <a:t>để</a:t>
-            </a:r>
-            <a:r>
-              <a:rPr dirty="0"/>
-              <a:t> model </a:t>
-            </a:r>
-            <a:r>
-              <a:rPr dirty="0" err="1"/>
-              <a:t>học</a:t>
-            </a:r>
-            <a:r>
-              <a:rPr dirty="0"/>
-              <a:t> business value </a:t>
-            </a:r>
-            <a:r>
-              <a:rPr dirty="0" err="1"/>
-              <a:t>của</a:t>
-            </a:r>
-            <a:r>
-              <a:rPr dirty="0"/>
-              <a:t> candidate.</a:t>
-            </a:r>
-          </a:p>
-          <a:p>
-            <a:pPr>
-              <a:lnSpc>
-                <a:spcPct val="105000"/>
-              </a:lnSpc>
-              <a:spcAft>
-                <a:spcPts val="600"/>
-              </a:spcAft>
-              <a:defRPr sz="1270">
-                <a:solidFill>
-                  <a:srgbClr val="2B3341"/>
-                </a:solidFill>
-                <a:latin typeface="Aptos"/>
-              </a:defRPr>
-            </a:pPr>
-            <a:r>
-              <a:rPr dirty="0"/>
-              <a:t>• Sample weight </a:t>
-            </a:r>
-            <a:r>
-              <a:rPr dirty="0" err="1"/>
-              <a:t>phụ</a:t>
-            </a:r>
-            <a:r>
-              <a:rPr dirty="0"/>
-              <a:t> </a:t>
-            </a:r>
-            <a:r>
-              <a:rPr dirty="0" err="1"/>
-              <a:t>thuộc</a:t>
-            </a:r>
-            <a:r>
-              <a:rPr dirty="0"/>
-              <a:t> </a:t>
-            </a:r>
-            <a:r>
-              <a:rPr dirty="0" err="1"/>
-              <a:t>giá</a:t>
-            </a:r>
-            <a:r>
-              <a:rPr dirty="0"/>
-              <a:t> </a:t>
-            </a:r>
-            <a:r>
-              <a:rPr dirty="0" err="1"/>
-              <a:t>trị</a:t>
-            </a:r>
-            <a:r>
-              <a:rPr dirty="0"/>
-              <a:t> user </a:t>
-            </a:r>
-            <a:r>
-              <a:rPr dirty="0" err="1"/>
-              <a:t>và</a:t>
-            </a:r>
-            <a:r>
-              <a:rPr dirty="0"/>
-              <a:t> </a:t>
-            </a:r>
-            <a:r>
-              <a:rPr dirty="0" err="1"/>
-              <a:t>mức</a:t>
-            </a:r>
-            <a:r>
-              <a:rPr dirty="0"/>
-              <a:t> </a:t>
-            </a:r>
-            <a:r>
-              <a:rPr dirty="0" err="1"/>
-              <a:t>độ</a:t>
-            </a:r>
-            <a:r>
-              <a:rPr dirty="0"/>
-              <a:t> behavior.</a:t>
-            </a:r>
-          </a:p>
-        </p:txBody>
-      </p:sp>
-      <p:sp>
-        <p:nvSpPr>
-          <p:cNvPr id="12" name="Rounded Rectangle 11"/>
-          <p:cNvSpPr/>
-          <p:nvPr/>
-        </p:nvSpPr>
-        <p:spPr>
-          <a:xfrm>
-            <a:off x="8183879" y="3675886"/>
-            <a:ext cx="3429000" cy="2736946"/>
-          </a:xfrm>
-          <a:prstGeom prst="roundRect">
-            <a:avLst/>
-          </a:prstGeom>
-          <a:solidFill>
-            <a:srgbClr val="F9FAFC"/>
-          </a:solidFill>
-          <a:ln w="12700">
-            <a:solidFill>
-              <a:srgbClr val="DBE0E7"/>
-            </a:solidFill>
-          </a:ln>
-        </p:spPr>
-        <p:style>
-          <a:lnRef idx="1">
-            <a:schemeClr val="accent1"/>
-          </a:lnRef>
-          <a:fillRef idx="3">
-            <a:schemeClr val="accent1"/>
-          </a:fillRef>
-          <a:effectRef idx="2">
-            <a:schemeClr val="accent1"/>
-          </a:effectRef>
-          <a:fontRef idx="minor">
-            <a:schemeClr val="lt1"/>
-          </a:fontRef>
-        </p:style>
-        <p:txBody>
-          <a:bodyPr rtlCol="0" anchor="ctr"/>
-          <a:lstStyle/>
-          <a:p>
-            <a:pPr algn="ctr"/>
-            <a:endParaRPr/>
-          </a:p>
-        </p:txBody>
-      </p:sp>
-      <p:sp>
-        <p:nvSpPr>
-          <p:cNvPr id="13" name="TextBox 12"/>
-          <p:cNvSpPr txBox="1"/>
-          <p:nvPr/>
-        </p:nvSpPr>
-        <p:spPr>
-          <a:xfrm>
-            <a:off x="8412480" y="3781886"/>
-            <a:ext cx="2926080" cy="411480"/>
-          </a:xfrm>
-          <a:prstGeom prst="rect">
-            <a:avLst/>
-          </a:prstGeom>
-          <a:noFill/>
-        </p:spPr>
-        <p:txBody>
-          <a:bodyPr wrap="square" anchor="t">
-            <a:spAutoFit/>
-          </a:bodyPr>
-          <a:lstStyle/>
-          <a:p>
-            <a:pPr algn="l"/>
-            <a:r>
-              <a:rPr sz="1550" b="1" dirty="0">
-                <a:solidFill>
-                  <a:srgbClr val="685094"/>
-                </a:solidFill>
-                <a:latin typeface="Aptos"/>
-              </a:rPr>
-              <a:t>RSPO · List-wise Preference Optimization</a:t>
-            </a:r>
-          </a:p>
-        </p:txBody>
-      </p:sp>
-      <p:sp>
-        <p:nvSpPr>
-          <p:cNvPr id="14" name="TextBox 13"/>
-          <p:cNvSpPr txBox="1"/>
-          <p:nvPr/>
-        </p:nvSpPr>
-        <p:spPr>
-          <a:xfrm>
-            <a:off x="8394192" y="4325112"/>
-            <a:ext cx="2834640" cy="1325880"/>
-          </a:xfrm>
-          <a:prstGeom prst="rect">
-            <a:avLst/>
-          </a:prstGeom>
-          <a:noFill/>
-        </p:spPr>
-        <p:txBody>
-          <a:bodyPr wrap="square">
-            <a:spAutoFit/>
-          </a:bodyPr>
-          <a:lstStyle/>
-          <a:p>
-            <a:pPr>
-              <a:lnSpc>
-                <a:spcPct val="105000"/>
-              </a:lnSpc>
-              <a:spcAft>
-                <a:spcPts val="600"/>
-              </a:spcAft>
-              <a:defRPr sz="1240">
-                <a:solidFill>
-                  <a:srgbClr val="2B3341"/>
-                </a:solidFill>
-                <a:latin typeface="Aptos"/>
-              </a:defRPr>
-            </a:pPr>
-            <a:r>
-              <a:rPr dirty="0"/>
-              <a:t>• VSL </a:t>
-            </a:r>
-            <a:r>
-              <a:rPr dirty="0" err="1"/>
-              <a:t>chủ</a:t>
-            </a:r>
-            <a:r>
-              <a:rPr dirty="0"/>
-              <a:t> </a:t>
-            </a:r>
-            <a:r>
-              <a:rPr dirty="0" err="1"/>
-              <a:t>yếu</a:t>
-            </a:r>
-            <a:r>
-              <a:rPr dirty="0"/>
-              <a:t> fit logged distribution; </a:t>
-            </a:r>
-            <a:r>
-              <a:rPr dirty="0" err="1"/>
-              <a:t>chưa</a:t>
-            </a:r>
-            <a:r>
-              <a:rPr dirty="0"/>
-              <a:t> </a:t>
-            </a:r>
-            <a:r>
-              <a:rPr dirty="0" err="1"/>
-              <a:t>trực</a:t>
-            </a:r>
-            <a:r>
-              <a:rPr dirty="0"/>
-              <a:t> </a:t>
-            </a:r>
-            <a:r>
-              <a:rPr dirty="0" err="1"/>
-              <a:t>tiếp</a:t>
-            </a:r>
-            <a:r>
-              <a:rPr dirty="0"/>
-              <a:t> </a:t>
-            </a:r>
-            <a:r>
-              <a:rPr dirty="0" err="1"/>
-              <a:t>tối</a:t>
-            </a:r>
-            <a:r>
-              <a:rPr dirty="0"/>
-              <a:t> </a:t>
-            </a:r>
-            <a:r>
-              <a:rPr dirty="0" err="1"/>
-              <a:t>ưu</a:t>
-            </a:r>
-            <a:r>
-              <a:rPr dirty="0"/>
-              <a:t> downstream objective.</a:t>
-            </a:r>
-          </a:p>
-          <a:p>
-            <a:pPr>
-              <a:lnSpc>
-                <a:spcPct val="105000"/>
-              </a:lnSpc>
-              <a:spcAft>
-                <a:spcPts val="600"/>
-              </a:spcAft>
-              <a:defRPr sz="1240">
-                <a:solidFill>
-                  <a:srgbClr val="2B3341"/>
-                </a:solidFill>
-                <a:latin typeface="Aptos"/>
-              </a:defRPr>
-            </a:pPr>
-            <a:r>
-              <a:rPr dirty="0"/>
-              <a:t>• RSPO </a:t>
-            </a:r>
-            <a:r>
-              <a:rPr dirty="0" err="1"/>
-              <a:t>dùng</a:t>
-            </a:r>
-            <a:r>
-              <a:rPr dirty="0"/>
-              <a:t> reward (</a:t>
-            </a:r>
-            <a:r>
-              <a:rPr dirty="0" err="1"/>
-              <a:t>eCPM</a:t>
-            </a:r>
-            <a:r>
-              <a:rPr dirty="0"/>
-              <a:t>) </a:t>
-            </a:r>
-            <a:r>
-              <a:rPr dirty="0" err="1"/>
-              <a:t>trên</a:t>
-            </a:r>
-            <a:r>
-              <a:rPr dirty="0"/>
-              <a:t> </a:t>
-            </a:r>
-            <a:r>
-              <a:rPr dirty="0" err="1"/>
-              <a:t>cả</a:t>
-            </a:r>
-            <a:r>
-              <a:rPr dirty="0"/>
-              <a:t> candidate list </a:t>
-            </a:r>
-            <a:r>
-              <a:rPr dirty="0" err="1"/>
-              <a:t>và</a:t>
-            </a:r>
-            <a:r>
-              <a:rPr dirty="0"/>
-              <a:t> align objective </a:t>
-            </a:r>
-            <a:r>
-              <a:rPr dirty="0" err="1"/>
-              <a:t>với</a:t>
-            </a:r>
-            <a:r>
-              <a:rPr dirty="0"/>
-              <a:t> ranking/NDCG.</a:t>
-            </a:r>
-          </a:p>
-          <a:p>
-            <a:pPr>
-              <a:lnSpc>
-                <a:spcPct val="105000"/>
-              </a:lnSpc>
-              <a:spcAft>
-                <a:spcPts val="600"/>
-              </a:spcAft>
-              <a:defRPr sz="1240">
-                <a:solidFill>
-                  <a:srgbClr val="2B3341"/>
-                </a:solidFill>
-                <a:latin typeface="Aptos"/>
-              </a:defRPr>
-            </a:pPr>
-            <a:r>
-              <a:rPr dirty="0"/>
-              <a:t>• Cho </a:t>
-            </a:r>
-            <a:r>
-              <a:rPr dirty="0" err="1"/>
-              <a:t>phép</a:t>
-            </a:r>
-            <a:r>
-              <a:rPr dirty="0"/>
-              <a:t> controlled exploration </a:t>
-            </a:r>
-            <a:r>
-              <a:rPr dirty="0" err="1"/>
-              <a:t>nhưng</a:t>
-            </a:r>
-            <a:r>
-              <a:rPr dirty="0"/>
-              <a:t> </a:t>
-            </a:r>
-            <a:r>
-              <a:rPr dirty="0" err="1"/>
-              <a:t>vẫn</a:t>
-            </a:r>
-            <a:r>
-              <a:rPr dirty="0"/>
-              <a:t> </a:t>
-            </a:r>
-            <a:r>
-              <a:rPr dirty="0" err="1"/>
-              <a:t>giữ</a:t>
-            </a:r>
-            <a:r>
-              <a:rPr dirty="0"/>
-              <a:t> model </a:t>
-            </a:r>
-            <a:r>
-              <a:rPr dirty="0" err="1"/>
-              <a:t>gần</a:t>
-            </a:r>
-            <a:r>
-              <a:rPr dirty="0"/>
-              <a:t> distribution </a:t>
-            </a:r>
-            <a:r>
-              <a:rPr dirty="0" err="1"/>
-              <a:t>đã</a:t>
-            </a:r>
-            <a:r>
-              <a:rPr dirty="0"/>
-              <a:t> </a:t>
-            </a:r>
-            <a:r>
-              <a:rPr dirty="0" err="1"/>
-              <a:t>học</a:t>
-            </a:r>
-            <a:r>
-              <a:rPr dirty="0"/>
-              <a:t>.</a:t>
-            </a:r>
-          </a:p>
-        </p:txBody>
-      </p:sp>
-      <p:sp>
-        <p:nvSpPr>
-          <p:cNvPr id="15" name="TextBox 14"/>
-          <p:cNvSpPr txBox="1"/>
-          <p:nvPr/>
-        </p:nvSpPr>
-        <p:spPr>
-          <a:xfrm>
-            <a:off x="914400" y="5989320"/>
-            <a:ext cx="6492240" cy="347472"/>
-          </a:xfrm>
-          <a:prstGeom prst="rect">
-            <a:avLst/>
-          </a:prstGeom>
-          <a:noFill/>
-        </p:spPr>
-        <p:txBody>
-          <a:bodyPr wrap="square" anchor="t">
-            <a:spAutoFit/>
-          </a:bodyPr>
-          <a:lstStyle/>
-          <a:p>
-            <a:pPr algn="ctr"/>
-            <a:r>
-              <a:rPr sz="1250" b="1">
-                <a:solidFill>
-                  <a:srgbClr val="192C4F"/>
-                </a:solidFill>
-                <a:latin typeface="Aptos"/>
-              </a:rPr>
-              <a:t>Mục tiêu cuối: sinh một ranked set có giá trị, không chỉ một tập candidate liên quan.</a:t>
-            </a:r>
-          </a:p>
-        </p:txBody>
-      </p:sp>
-      <p:sp>
-        <p:nvSpPr>
-          <p:cNvPr id="16" name="TextBox 15"/>
-          <p:cNvSpPr txBox="1"/>
-          <p:nvPr/>
-        </p:nvSpPr>
-        <p:spPr>
-          <a:xfrm>
-            <a:off x="8348472" y="6442792"/>
-            <a:ext cx="3931920" cy="256032"/>
-          </a:xfrm>
-          <a:prstGeom prst="rect">
-            <a:avLst/>
-          </a:prstGeom>
-          <a:noFill/>
-        </p:spPr>
-        <p:txBody>
-          <a:bodyPr wrap="square" anchor="ctr">
-            <a:spAutoFit/>
-          </a:bodyPr>
-          <a:lstStyle/>
-          <a:p>
-            <a:pPr algn="l"/>
-            <a:r>
-              <a:rPr sz="950" b="0" dirty="0" err="1">
-                <a:solidFill>
-                  <a:srgbClr val="676F7B"/>
-                </a:solidFill>
-                <a:latin typeface="Aptos"/>
-              </a:rPr>
-              <a:t>Nguồn</a:t>
-            </a:r>
-            <a:r>
-              <a:rPr sz="950" b="0" dirty="0">
-                <a:solidFill>
-                  <a:srgbClr val="676F7B"/>
-                </a:solidFill>
-                <a:latin typeface="Aptos"/>
-              </a:rPr>
-              <a:t>: GR4AD, §3.3–3.4 &amp; Fig.1 · arXiv:2602.22732v3</a:t>
-            </a:r>
-          </a:p>
-        </p:txBody>
-      </p:sp>
-    </p:spTree>
   </p:cSld>
   <p:clrMapOvr>
     <a:masterClrMapping/>

</xml_diff>

<commit_message>
Update research notes and slide
Co-Authored-By: Claude Sonnet 5 <noreply@anthropic.com>
</commit_message>
<xml_diff>
--- a/docs/18-08/Slide.pptx
+++ b/docs/18-08/Slide.pptx
@@ -5,22 +5,21 @@
     <p:sldMasterId id="2147483648" r:id="rId1"/>
   </p:sldMasterIdLst>
   <p:notesMasterIdLst>
-    <p:notesMasterId r:id="rId15"/>
+    <p:notesMasterId r:id="rId14"/>
   </p:notesMasterIdLst>
   <p:sldIdLst>
     <p:sldId id="256" r:id="rId2"/>
     <p:sldId id="258" r:id="rId3"/>
     <p:sldId id="259" r:id="rId4"/>
-    <p:sldId id="273" r:id="rId5"/>
-    <p:sldId id="260" r:id="rId6"/>
-    <p:sldId id="270" r:id="rId7"/>
-    <p:sldId id="262" r:id="rId8"/>
-    <p:sldId id="267" r:id="rId9"/>
-    <p:sldId id="272" r:id="rId10"/>
-    <p:sldId id="268" r:id="rId11"/>
-    <p:sldId id="269" r:id="rId12"/>
-    <p:sldId id="263" r:id="rId13"/>
-    <p:sldId id="266" r:id="rId14"/>
+    <p:sldId id="260" r:id="rId5"/>
+    <p:sldId id="270" r:id="rId6"/>
+    <p:sldId id="262" r:id="rId7"/>
+    <p:sldId id="267" r:id="rId8"/>
+    <p:sldId id="272" r:id="rId9"/>
+    <p:sldId id="268" r:id="rId10"/>
+    <p:sldId id="269" r:id="rId11"/>
+    <p:sldId id="263" r:id="rId12"/>
+    <p:sldId id="266" r:id="rId13"/>
   </p:sldIdLst>
   <p:sldSz cx="12192000" cy="6858000"/>
   <p:notesSz cx="6858000" cy="12192000"/>
@@ -420,7 +419,7 @@
           <a:p>
             <a:fld id="{F7021451-1387-4CA6-816F-3879F97B5CBC}" type="slidenum">
               <a:rPr lang="en-US"/>
-              <a:t>12</a:t>
+              <a:t>11</a:t>
             </a:fld>
             <a:endParaRPr lang="en-US"/>
           </a:p>
@@ -509,7 +508,7 @@
           <a:p>
             <a:fld id="{F7021451-1387-4CA6-816F-3879F97B5CBC}" type="slidenum">
               <a:rPr lang="en-US"/>
-              <a:t>13</a:t>
+              <a:t>12</a:t>
             </a:fld>
             <a:endParaRPr lang="en-US"/>
           </a:p>
@@ -776,7 +775,7 @@
           <a:p>
             <a:fld id="{F7021451-1387-4CA6-816F-3879F97B5CBC}" type="slidenum">
               <a:rPr lang="en-US"/>
-              <a:t>5</a:t>
+              <a:t>4</a:t>
             </a:fld>
             <a:endParaRPr lang="en-US"/>
           </a:p>
@@ -865,7 +864,7 @@
           <a:p>
             <a:fld id="{F7021451-1387-4CA6-816F-3879F97B5CBC}" type="slidenum">
               <a:rPr lang="en-US"/>
-              <a:t>7</a:t>
+              <a:t>6</a:t>
             </a:fld>
             <a:endParaRPr lang="en-US"/>
           </a:p>
@@ -1095,7 +1094,7 @@
           </a:prstGeom>
           <a:extLst>
             <a:ext uri="{C572A759-6A51-4108-AA02-DFA0A04FC94B}">
-              <ma14:wrappingTextBoxFlag xmlns="" xmlns:ma14="http://schemas.microsoft.com/office/mac/drawingml/2011/main" val="0"/>
+              <ma14:wrappingTextBoxFlag xmlns:ma14="http://schemas.microsoft.com/office/mac/drawingml/2011/main" xmlns="" val="0"/>
             </a:ext>
           </a:extLst>
         </p:spPr>
@@ -1173,7 +1172,7 @@
           </a:prstGeom>
           <a:extLst>
             <a:ext uri="{C572A759-6A51-4108-AA02-DFA0A04FC94B}">
-              <ma14:wrappingTextBoxFlag xmlns="" xmlns:ma14="http://schemas.microsoft.com/office/mac/drawingml/2011/main" val="0"/>
+              <ma14:wrappingTextBoxFlag xmlns:ma14="http://schemas.microsoft.com/office/mac/drawingml/2011/main" xmlns="" val="0"/>
             </a:ext>
           </a:extLst>
         </p:spPr>
@@ -1538,815 +1537,6 @@
       </p:grpSpPr>
       <p:pic>
         <p:nvPicPr>
-          <p:cNvPr id="6" name="Picture 5" descr="image.png"/>
-          <p:cNvPicPr>
-            <a:picLocks noChangeAspect="1"/>
-          </p:cNvPicPr>
-          <p:nvPr/>
-        </p:nvPicPr>
-        <p:blipFill>
-          <a:blip r:embed="rId3"/>
-          <a:stretch>
-            <a:fillRect/>
-          </a:stretch>
-        </p:blipFill>
-        <p:spPr>
-          <a:xfrm>
-            <a:off x="1494764" y="1115793"/>
-            <a:ext cx="9363456" cy="3446837"/>
-          </a:xfrm>
-          <a:prstGeom prst="rect">
-            <a:avLst/>
-          </a:prstGeom>
-        </p:spPr>
-      </p:pic>
-      <p:sp>
-        <p:nvSpPr>
-          <p:cNvPr id="7" name="TextBox 6"/>
-          <p:cNvSpPr txBox="1"/>
-          <p:nvPr/>
-        </p:nvSpPr>
-        <p:spPr>
-          <a:xfrm>
-            <a:off x="502920" y="228600"/>
-            <a:ext cx="11064240" cy="475488"/>
-          </a:xfrm>
-          <a:prstGeom prst="rect">
-            <a:avLst/>
-          </a:prstGeom>
-          <a:noFill/>
-        </p:spPr>
-        <p:txBody>
-          <a:bodyPr wrap="square" anchor="ctr">
-            <a:spAutoFit/>
-          </a:bodyPr>
-          <a:lstStyle/>
-          <a:p>
-            <a:pPr algn="l"/>
-            <a:r>
-              <a:rPr sz="2400" b="1">
-                <a:solidFill>
-                  <a:srgbClr val="192C4F"/>
-                </a:solidFill>
-                <a:latin typeface="Aptos"/>
-              </a:rPr>
-              <a:t>LazyAR — Không phải mọi decoder layer đều cần autoregressive</a:t>
-            </a:r>
-          </a:p>
-        </p:txBody>
-      </p:sp>
-      <p:sp>
-        <p:nvSpPr>
-          <p:cNvPr id="8" name="TextBox 7"/>
-          <p:cNvSpPr txBox="1"/>
-          <p:nvPr/>
-        </p:nvSpPr>
-        <p:spPr>
-          <a:xfrm>
-            <a:off x="530352" y="731520"/>
-            <a:ext cx="10881360" cy="329184"/>
-          </a:xfrm>
-          <a:prstGeom prst="rect">
-            <a:avLst/>
-          </a:prstGeom>
-          <a:noFill/>
-        </p:spPr>
-        <p:txBody>
-          <a:bodyPr wrap="square" anchor="ctr">
-            <a:spAutoFit/>
-          </a:bodyPr>
-          <a:lstStyle/>
-          <a:p>
-            <a:pPr algn="l"/>
-            <a:r>
-              <a:rPr sz="1350" b="0">
-                <a:solidFill>
-                  <a:srgbClr val="676F7B"/>
-                </a:solidFill>
-                <a:latin typeface="Aptos"/>
-              </a:rPr>
-              <a:t>Ý tưởng cốt lõi: chỉ inject token trước ở layer muộn; phần đầu được tính song song và reuse qua beam.</a:t>
-            </a:r>
-          </a:p>
-        </p:txBody>
-      </p:sp>
-      <p:sp>
-        <p:nvSpPr>
-          <p:cNvPr id="9" name="Rounded Rectangle 8"/>
-          <p:cNvSpPr/>
-          <p:nvPr/>
-        </p:nvSpPr>
-        <p:spPr>
-          <a:xfrm>
-            <a:off x="1173295" y="4617719"/>
-            <a:ext cx="3063240" cy="1417320"/>
-          </a:xfrm>
-          <a:prstGeom prst="roundRect">
-            <a:avLst/>
-          </a:prstGeom>
-          <a:solidFill>
-            <a:srgbClr val="F9FAFC"/>
-          </a:solidFill>
-          <a:ln w="12700">
-            <a:solidFill>
-              <a:srgbClr val="DBE0E7"/>
-            </a:solidFill>
-          </a:ln>
-        </p:spPr>
-        <p:style>
-          <a:lnRef idx="1">
-            <a:schemeClr val="accent1"/>
-          </a:lnRef>
-          <a:fillRef idx="3">
-            <a:schemeClr val="accent1"/>
-          </a:fillRef>
-          <a:effectRef idx="2">
-            <a:schemeClr val="accent1"/>
-          </a:effectRef>
-          <a:fontRef idx="minor">
-            <a:schemeClr val="lt1"/>
-          </a:fontRef>
-        </p:style>
-        <p:txBody>
-          <a:bodyPr rtlCol="0" anchor="ctr"/>
-          <a:lstStyle/>
-          <a:p>
-            <a:pPr algn="ctr"/>
-            <a:endParaRPr/>
-          </a:p>
-        </p:txBody>
-      </p:sp>
-      <p:sp>
-        <p:nvSpPr>
-          <p:cNvPr id="10" name="TextBox 9"/>
-          <p:cNvSpPr txBox="1"/>
-          <p:nvPr/>
-        </p:nvSpPr>
-        <p:spPr>
-          <a:xfrm>
-            <a:off x="1242277" y="4806235"/>
-            <a:ext cx="2743200" cy="256032"/>
-          </a:xfrm>
-          <a:prstGeom prst="rect">
-            <a:avLst/>
-          </a:prstGeom>
-          <a:noFill/>
-        </p:spPr>
-        <p:txBody>
-          <a:bodyPr wrap="square" anchor="t">
-            <a:spAutoFit/>
-          </a:bodyPr>
-          <a:lstStyle/>
-          <a:p>
-            <a:pPr algn="l"/>
-            <a:r>
-              <a:rPr sz="1550" b="1" dirty="0">
-                <a:solidFill>
-                  <a:srgbClr val="B74646"/>
-                </a:solidFill>
-                <a:latin typeface="Aptos"/>
-              </a:rPr>
-              <a:t>Vanilla AR</a:t>
-            </a:r>
-          </a:p>
-        </p:txBody>
-      </p:sp>
-      <p:sp>
-        <p:nvSpPr>
-          <p:cNvPr id="11" name="TextBox 10"/>
-          <p:cNvSpPr txBox="1"/>
-          <p:nvPr/>
-        </p:nvSpPr>
-        <p:spPr>
-          <a:xfrm>
-            <a:off x="1242277" y="5179497"/>
-            <a:ext cx="2743200" cy="749808"/>
-          </a:xfrm>
-          <a:prstGeom prst="rect">
-            <a:avLst/>
-          </a:prstGeom>
-          <a:noFill/>
-        </p:spPr>
-        <p:txBody>
-          <a:bodyPr wrap="square" anchor="t">
-            <a:spAutoFit/>
-          </a:bodyPr>
-          <a:lstStyle/>
-          <a:p>
-            <a:pPr algn="l"/>
-            <a:r>
-              <a:rPr sz="1180" b="0" dirty="0" err="1">
-                <a:solidFill>
-                  <a:srgbClr val="2B3341"/>
-                </a:solidFill>
-                <a:latin typeface="Aptos"/>
-              </a:rPr>
-              <a:t>Mỗi</a:t>
-            </a:r>
-            <a:r>
-              <a:rPr sz="1180" b="0" dirty="0">
-                <a:solidFill>
-                  <a:srgbClr val="2B3341"/>
-                </a:solidFill>
-                <a:latin typeface="Aptos"/>
-              </a:rPr>
-              <a:t> step </a:t>
-            </a:r>
-            <a:r>
-              <a:rPr sz="1180" b="0" dirty="0" err="1">
-                <a:solidFill>
-                  <a:srgbClr val="2B3341"/>
-                </a:solidFill>
-                <a:latin typeface="Aptos"/>
-              </a:rPr>
-              <a:t>chạy</a:t>
-            </a:r>
-            <a:r>
-              <a:rPr sz="1180" b="0" dirty="0">
-                <a:solidFill>
-                  <a:srgbClr val="2B3341"/>
-                </a:solidFill>
-                <a:latin typeface="Aptos"/>
-              </a:rPr>
-              <a:t> qua </a:t>
-            </a:r>
-            <a:r>
-              <a:rPr sz="1180" b="0" dirty="0" err="1">
-                <a:solidFill>
-                  <a:srgbClr val="2B3341"/>
-                </a:solidFill>
-                <a:latin typeface="Aptos"/>
-              </a:rPr>
-              <a:t>toàn</a:t>
-            </a:r>
-            <a:r>
-              <a:rPr sz="1180" b="0" dirty="0">
-                <a:solidFill>
-                  <a:srgbClr val="2B3341"/>
-                </a:solidFill>
-                <a:latin typeface="Aptos"/>
-              </a:rPr>
-              <a:t> </a:t>
-            </a:r>
-            <a:r>
-              <a:rPr sz="1180" b="0" dirty="0" err="1">
-                <a:solidFill>
-                  <a:srgbClr val="2B3341"/>
-                </a:solidFill>
-                <a:latin typeface="Aptos"/>
-              </a:rPr>
-              <a:t>bộ</a:t>
-            </a:r>
-            <a:r>
-              <a:rPr sz="1180" b="0" dirty="0">
-                <a:solidFill>
-                  <a:srgbClr val="2B3341"/>
-                </a:solidFill>
-                <a:latin typeface="Aptos"/>
-              </a:rPr>
-              <a:t> decoder </a:t>
-            </a:r>
-            <a:r>
-              <a:rPr sz="1180" b="0" dirty="0" err="1">
-                <a:solidFill>
-                  <a:srgbClr val="2B3341"/>
-                </a:solidFill>
-                <a:latin typeface="Aptos"/>
-              </a:rPr>
-              <a:t>và</a:t>
-            </a:r>
-            <a:r>
-              <a:rPr sz="1180" b="0" dirty="0">
-                <a:solidFill>
-                  <a:srgbClr val="2B3341"/>
-                </a:solidFill>
-                <a:latin typeface="Aptos"/>
-              </a:rPr>
-              <a:t> </a:t>
-            </a:r>
-            <a:r>
-              <a:rPr sz="1180" b="0" dirty="0" err="1">
-                <a:solidFill>
-                  <a:srgbClr val="2B3341"/>
-                </a:solidFill>
-                <a:latin typeface="Aptos"/>
-              </a:rPr>
-              <a:t>phụ</a:t>
-            </a:r>
-            <a:r>
-              <a:rPr sz="1180" b="0" dirty="0">
-                <a:solidFill>
-                  <a:srgbClr val="2B3341"/>
-                </a:solidFill>
-                <a:latin typeface="Aptos"/>
-              </a:rPr>
-              <a:t> </a:t>
-            </a:r>
-            <a:r>
-              <a:rPr sz="1180" b="0" dirty="0" err="1">
-                <a:solidFill>
-                  <a:srgbClr val="2B3341"/>
-                </a:solidFill>
-                <a:latin typeface="Aptos"/>
-              </a:rPr>
-              <a:t>thuộc</a:t>
-            </a:r>
-            <a:r>
-              <a:rPr sz="1180" b="0" dirty="0">
-                <a:solidFill>
-                  <a:srgbClr val="2B3341"/>
-                </a:solidFill>
-                <a:latin typeface="Aptos"/>
-              </a:rPr>
-              <a:t> token </a:t>
-            </a:r>
-            <a:r>
-              <a:rPr sz="1180" b="0" dirty="0" err="1">
-                <a:solidFill>
-                  <a:srgbClr val="2B3341"/>
-                </a:solidFill>
-                <a:latin typeface="Aptos"/>
-              </a:rPr>
-              <a:t>trước</a:t>
-            </a:r>
-            <a:r>
-              <a:rPr sz="1180" b="0" dirty="0">
-                <a:solidFill>
-                  <a:srgbClr val="2B3341"/>
-                </a:solidFill>
-                <a:latin typeface="Aptos"/>
-              </a:rPr>
-              <a:t> → sequential cost </a:t>
-            </a:r>
-            <a:r>
-              <a:rPr sz="1180" b="0" dirty="0" err="1">
-                <a:solidFill>
-                  <a:srgbClr val="2B3341"/>
-                </a:solidFill>
-                <a:latin typeface="Aptos"/>
-              </a:rPr>
-              <a:t>lớn</a:t>
-            </a:r>
-            <a:r>
-              <a:rPr sz="1180" b="0" dirty="0">
-                <a:solidFill>
-                  <a:srgbClr val="2B3341"/>
-                </a:solidFill>
-                <a:latin typeface="Aptos"/>
-              </a:rPr>
-              <a:t> </a:t>
-            </a:r>
-            <a:r>
-              <a:rPr sz="1180" b="0" dirty="0" err="1">
-                <a:solidFill>
-                  <a:srgbClr val="2B3341"/>
-                </a:solidFill>
-                <a:latin typeface="Aptos"/>
-              </a:rPr>
-              <a:t>khi</a:t>
-            </a:r>
-            <a:r>
-              <a:rPr sz="1180" b="0" dirty="0">
-                <a:solidFill>
-                  <a:srgbClr val="2B3341"/>
-                </a:solidFill>
-                <a:latin typeface="Aptos"/>
-              </a:rPr>
-              <a:t> beam </a:t>
-            </a:r>
-            <a:r>
-              <a:rPr sz="1180" b="0" dirty="0" err="1">
-                <a:solidFill>
-                  <a:srgbClr val="2B3341"/>
-                </a:solidFill>
-                <a:latin typeface="Aptos"/>
-              </a:rPr>
-              <a:t>tăng</a:t>
-            </a:r>
-            <a:r>
-              <a:rPr sz="1180" b="0" dirty="0">
-                <a:solidFill>
-                  <a:srgbClr val="2B3341"/>
-                </a:solidFill>
-                <a:latin typeface="Aptos"/>
-              </a:rPr>
-              <a:t>.</a:t>
-            </a:r>
-          </a:p>
-        </p:txBody>
-      </p:sp>
-      <p:sp>
-        <p:nvSpPr>
-          <p:cNvPr id="15" name="Rounded Rectangle 14"/>
-          <p:cNvSpPr/>
-          <p:nvPr/>
-        </p:nvSpPr>
-        <p:spPr>
-          <a:xfrm>
-            <a:off x="7955466" y="4645039"/>
-            <a:ext cx="3063240" cy="1417320"/>
-          </a:xfrm>
-          <a:prstGeom prst="roundRect">
-            <a:avLst/>
-          </a:prstGeom>
-          <a:solidFill>
-            <a:srgbClr val="F9FAFC"/>
-          </a:solidFill>
-          <a:ln w="12700">
-            <a:solidFill>
-              <a:srgbClr val="DBE0E7"/>
-            </a:solidFill>
-          </a:ln>
-        </p:spPr>
-        <p:style>
-          <a:lnRef idx="1">
-            <a:schemeClr val="accent1"/>
-          </a:lnRef>
-          <a:fillRef idx="3">
-            <a:schemeClr val="accent1"/>
-          </a:fillRef>
-          <a:effectRef idx="2">
-            <a:schemeClr val="accent1"/>
-          </a:effectRef>
-          <a:fontRef idx="minor">
-            <a:schemeClr val="lt1"/>
-          </a:fontRef>
-        </p:style>
-        <p:txBody>
-          <a:bodyPr rtlCol="0" anchor="ctr"/>
-          <a:lstStyle/>
-          <a:p>
-            <a:pPr algn="ctr"/>
-            <a:endParaRPr/>
-          </a:p>
-        </p:txBody>
-      </p:sp>
-      <p:sp>
-        <p:nvSpPr>
-          <p:cNvPr id="16" name="TextBox 15"/>
-          <p:cNvSpPr txBox="1"/>
-          <p:nvPr/>
-        </p:nvSpPr>
-        <p:spPr>
-          <a:xfrm>
-            <a:off x="8120057" y="4763911"/>
-            <a:ext cx="2743200" cy="256032"/>
-          </a:xfrm>
-          <a:prstGeom prst="rect">
-            <a:avLst/>
-          </a:prstGeom>
-          <a:noFill/>
-        </p:spPr>
-        <p:txBody>
-          <a:bodyPr wrap="square" anchor="t">
-            <a:spAutoFit/>
-          </a:bodyPr>
-          <a:lstStyle/>
-          <a:p>
-            <a:pPr algn="l"/>
-            <a:r>
-              <a:rPr sz="1550" b="1">
-                <a:solidFill>
-                  <a:srgbClr val="368461"/>
-                </a:solidFill>
-                <a:latin typeface="Aptos"/>
-              </a:rPr>
-              <a:t>LazyAR</a:t>
-            </a:r>
-          </a:p>
-        </p:txBody>
-      </p:sp>
-      <p:sp>
-        <p:nvSpPr>
-          <p:cNvPr id="17" name="TextBox 16"/>
-          <p:cNvSpPr txBox="1"/>
-          <p:nvPr/>
-        </p:nvSpPr>
-        <p:spPr>
-          <a:xfrm>
-            <a:off x="8120057" y="5102239"/>
-            <a:ext cx="2743200" cy="749808"/>
-          </a:xfrm>
-          <a:prstGeom prst="rect">
-            <a:avLst/>
-          </a:prstGeom>
-          <a:noFill/>
-        </p:spPr>
-        <p:txBody>
-          <a:bodyPr wrap="square" anchor="t">
-            <a:spAutoFit/>
-          </a:bodyPr>
-          <a:lstStyle/>
-          <a:p>
-            <a:pPr algn="l"/>
-            <a:r>
-              <a:rPr sz="1180" b="0">
-                <a:solidFill>
-                  <a:srgbClr val="2B3341"/>
-                </a:solidFill>
-                <a:latin typeface="Aptos"/>
-              </a:rPr>
-              <a:t>K layer đầu không phụ thuộc token trước → chạy song song, share qua beams. Chỉ L−K layer sau còn autoregressive.</a:t>
-            </a:r>
-          </a:p>
-        </p:txBody>
-      </p:sp>
-      <p:sp>
-        <p:nvSpPr>
-          <p:cNvPr id="18" name="TextBox 17"/>
-          <p:cNvSpPr txBox="1"/>
-          <p:nvPr/>
-        </p:nvSpPr>
-        <p:spPr>
-          <a:xfrm>
-            <a:off x="1353032" y="6269499"/>
-            <a:ext cx="9646920" cy="320040"/>
-          </a:xfrm>
-          <a:prstGeom prst="rect">
-            <a:avLst/>
-          </a:prstGeom>
-          <a:noFill/>
-        </p:spPr>
-        <p:txBody>
-          <a:bodyPr wrap="square" anchor="t">
-            <a:spAutoFit/>
-          </a:bodyPr>
-          <a:lstStyle/>
-          <a:p>
-            <a:pPr algn="ctr"/>
-            <a:r>
-              <a:rPr sz="1250" b="1" dirty="0">
-                <a:solidFill>
-                  <a:srgbClr val="192C4F"/>
-                </a:solidFill>
-                <a:latin typeface="Aptos"/>
-              </a:rPr>
-              <a:t>Trong </a:t>
-            </a:r>
-            <a:r>
-              <a:rPr sz="1250" b="1" dirty="0" err="1">
-                <a:solidFill>
-                  <a:srgbClr val="192C4F"/>
-                </a:solidFill>
-                <a:latin typeface="Aptos"/>
-              </a:rPr>
-              <a:t>thí</a:t>
-            </a:r>
-            <a:r>
-              <a:rPr sz="1250" b="1" dirty="0">
-                <a:solidFill>
-                  <a:srgbClr val="192C4F"/>
-                </a:solidFill>
-                <a:latin typeface="Aptos"/>
-              </a:rPr>
-              <a:t> </a:t>
-            </a:r>
-            <a:r>
-              <a:rPr sz="1250" b="1" dirty="0" err="1">
-                <a:solidFill>
-                  <a:srgbClr val="192C4F"/>
-                </a:solidFill>
-                <a:latin typeface="Aptos"/>
-              </a:rPr>
-              <a:t>nghiệm</a:t>
-            </a:r>
-            <a:r>
-              <a:rPr sz="1250" b="1" dirty="0">
-                <a:solidFill>
-                  <a:srgbClr val="192C4F"/>
-                </a:solidFill>
-                <a:latin typeface="Aptos"/>
-              </a:rPr>
-              <a:t>, </a:t>
-            </a:r>
-            <a:r>
-              <a:rPr sz="1250" b="1" dirty="0" err="1">
-                <a:solidFill>
-                  <a:srgbClr val="192C4F"/>
-                </a:solidFill>
-                <a:latin typeface="Aptos"/>
-              </a:rPr>
-              <a:t>một</a:t>
-            </a:r>
-            <a:r>
-              <a:rPr sz="1250" b="1" dirty="0">
-                <a:solidFill>
-                  <a:srgbClr val="192C4F"/>
-                </a:solidFill>
-                <a:latin typeface="Aptos"/>
-              </a:rPr>
-              <a:t> </a:t>
-            </a:r>
-            <a:r>
-              <a:rPr sz="1250" b="1" dirty="0" err="1">
-                <a:solidFill>
-                  <a:srgbClr val="192C4F"/>
-                </a:solidFill>
-                <a:latin typeface="Aptos"/>
-              </a:rPr>
-              <a:t>cấu</a:t>
-            </a:r>
-            <a:r>
-              <a:rPr sz="1250" b="1" dirty="0">
-                <a:solidFill>
-                  <a:srgbClr val="192C4F"/>
-                </a:solidFill>
-                <a:latin typeface="Aptos"/>
-              </a:rPr>
-              <a:t> </a:t>
-            </a:r>
-            <a:r>
-              <a:rPr sz="1250" b="1" dirty="0" err="1">
-                <a:solidFill>
-                  <a:srgbClr val="192C4F"/>
-                </a:solidFill>
-                <a:latin typeface="Aptos"/>
-              </a:rPr>
-              <a:t>hình</a:t>
-            </a:r>
-            <a:r>
-              <a:rPr sz="1250" b="1" dirty="0">
-                <a:solidFill>
-                  <a:srgbClr val="192C4F"/>
-                </a:solidFill>
-                <a:latin typeface="Aptos"/>
-              </a:rPr>
-              <a:t> K </a:t>
-            </a:r>
-            <a:r>
-              <a:rPr sz="1250" b="1" dirty="0" err="1">
-                <a:solidFill>
-                  <a:srgbClr val="192C4F"/>
-                </a:solidFill>
-                <a:latin typeface="Aptos"/>
-              </a:rPr>
-              <a:t>phù</a:t>
-            </a:r>
-            <a:r>
-              <a:rPr sz="1250" b="1" dirty="0">
-                <a:solidFill>
-                  <a:srgbClr val="192C4F"/>
-                </a:solidFill>
-                <a:latin typeface="Aptos"/>
-              </a:rPr>
-              <a:t> </a:t>
-            </a:r>
-            <a:r>
-              <a:rPr sz="1250" b="1" dirty="0" err="1">
-                <a:solidFill>
-                  <a:srgbClr val="192C4F"/>
-                </a:solidFill>
-                <a:latin typeface="Aptos"/>
-              </a:rPr>
-              <a:t>hợp</a:t>
-            </a:r>
-            <a:r>
-              <a:rPr sz="1250" b="1" dirty="0">
-                <a:solidFill>
-                  <a:srgbClr val="192C4F"/>
-                </a:solidFill>
-                <a:latin typeface="Aptos"/>
-              </a:rPr>
-              <a:t> </a:t>
-            </a:r>
-            <a:r>
-              <a:rPr sz="1250" b="1" dirty="0" err="1">
-                <a:solidFill>
-                  <a:srgbClr val="192C4F"/>
-                </a:solidFill>
-                <a:latin typeface="Aptos"/>
-              </a:rPr>
-              <a:t>giữ</a:t>
-            </a:r>
-            <a:r>
-              <a:rPr sz="1250" b="1" dirty="0">
-                <a:solidFill>
-                  <a:srgbClr val="192C4F"/>
-                </a:solidFill>
-                <a:latin typeface="Aptos"/>
-              </a:rPr>
-              <a:t> recommendation quality </a:t>
-            </a:r>
-            <a:r>
-              <a:rPr sz="1250" b="1" dirty="0" err="1">
-                <a:solidFill>
-                  <a:srgbClr val="192C4F"/>
-                </a:solidFill>
-                <a:latin typeface="Aptos"/>
-              </a:rPr>
-              <a:t>và</a:t>
-            </a:r>
-            <a:r>
-              <a:rPr sz="1250" b="1" dirty="0">
-                <a:solidFill>
-                  <a:srgbClr val="192C4F"/>
-                </a:solidFill>
-                <a:latin typeface="Aptos"/>
-              </a:rPr>
-              <a:t> </a:t>
-            </a:r>
-            <a:r>
-              <a:rPr sz="1250" b="1" dirty="0" err="1">
-                <a:solidFill>
-                  <a:srgbClr val="192C4F"/>
-                </a:solidFill>
-                <a:latin typeface="Aptos"/>
-              </a:rPr>
-              <a:t>gần</a:t>
-            </a:r>
-            <a:r>
-              <a:rPr sz="1250" b="1" dirty="0">
-                <a:solidFill>
-                  <a:srgbClr val="192C4F"/>
-                </a:solidFill>
-                <a:latin typeface="Aptos"/>
-              </a:rPr>
-              <a:t> </a:t>
-            </a:r>
-            <a:r>
-              <a:rPr sz="1250" b="1" dirty="0" err="1">
-                <a:solidFill>
-                  <a:srgbClr val="192C4F"/>
-                </a:solidFill>
-                <a:latin typeface="Aptos"/>
-              </a:rPr>
-              <a:t>như</a:t>
-            </a:r>
-            <a:r>
-              <a:rPr sz="1250" b="1" dirty="0">
-                <a:solidFill>
-                  <a:srgbClr val="192C4F"/>
-                </a:solidFill>
-                <a:latin typeface="Aptos"/>
-              </a:rPr>
-              <a:t> </a:t>
-            </a:r>
-            <a:r>
-              <a:rPr sz="1250" b="1" dirty="0" err="1">
-                <a:solidFill>
-                  <a:srgbClr val="192C4F"/>
-                </a:solidFill>
-                <a:latin typeface="Aptos"/>
-              </a:rPr>
-              <a:t>nhân</a:t>
-            </a:r>
-            <a:r>
-              <a:rPr sz="1250" b="1" dirty="0">
-                <a:solidFill>
-                  <a:srgbClr val="192C4F"/>
-                </a:solidFill>
-                <a:latin typeface="Aptos"/>
-              </a:rPr>
-              <a:t> </a:t>
-            </a:r>
-            <a:r>
-              <a:rPr sz="1250" b="1" dirty="0" err="1">
-                <a:solidFill>
-                  <a:srgbClr val="192C4F"/>
-                </a:solidFill>
-                <a:latin typeface="Aptos"/>
-              </a:rPr>
-              <a:t>đôi</a:t>
-            </a:r>
-            <a:r>
-              <a:rPr sz="1250" b="1" dirty="0">
-                <a:solidFill>
-                  <a:srgbClr val="192C4F"/>
-                </a:solidFill>
-                <a:latin typeface="Aptos"/>
-              </a:rPr>
-              <a:t> throughput.</a:t>
-            </a:r>
-          </a:p>
-        </p:txBody>
-      </p:sp>
-    </p:spTree>
-  </p:cSld>
-  <p:clrMapOvr>
-    <a:masterClrMapping/>
-  </p:clrMapOvr>
-</p:sld>
-</file>
-
-<file path=ppt/slides/slide11.xml><?xml version="1.0" encoding="utf-8"?>
-<p:sld xmlns:a="http://schemas.openxmlformats.org/drawingml/2006/main" xmlns:r="http://schemas.openxmlformats.org/officeDocument/2006/relationships" xmlns:p="http://schemas.openxmlformats.org/presentationml/2006/main">
-  <p:cSld>
-    <p:spTree>
-      <p:nvGrpSpPr>
-        <p:cNvPr id="1" name=""/>
-        <p:cNvGrpSpPr/>
-        <p:nvPr/>
-      </p:nvGrpSpPr>
-      <p:grpSpPr>
-        <a:xfrm>
-          <a:off x="0" y="0"/>
-          <a:ext cx="0" cy="0"/>
-          <a:chOff x="0" y="0"/>
-          <a:chExt cx="0" cy="0"/>
-        </a:xfrm>
-      </p:grpSpPr>
-      <p:pic>
-        <p:nvPicPr>
           <p:cNvPr id="6" name="Picture 5" descr="GR4AD_Figure1.png"/>
           <p:cNvPicPr>
             <a:picLocks noChangeAspect="1"/>
@@ -3142,7 +2332,7 @@
 </p:sld>
 </file>
 
-<file path=ppt/slides/slide12.xml><?xml version="1.0" encoding="utf-8"?>
+<file path=ppt/slides/slide11.xml><?xml version="1.0" encoding="utf-8"?>
 <p:sld xmlns:a="http://schemas.openxmlformats.org/drawingml/2006/main" xmlns:r="http://schemas.openxmlformats.org/officeDocument/2006/relationships" xmlns:p="http://schemas.openxmlformats.org/presentationml/2006/main">
   <p:cSld name="Slide 8">
     <p:spTree>
@@ -3161,6 +2351,36 @@
       </p:grpSpPr>
       <p:pic>
         <p:nvPicPr>
+          <p:cNvPr id="3" name="Picture 2">
+            <a:extLst>
+              <a:ext uri="{FF2B5EF4-FFF2-40B4-BE49-F238E27FC236}">
+                <a16:creationId xmlns:a16="http://schemas.microsoft.com/office/drawing/2014/main" id="{6B20E899-DFD9-21DC-F7B6-344553B3F633}"/>
+              </a:ext>
+            </a:extLst>
+          </p:cNvPr>
+          <p:cNvPicPr>
+            <a:picLocks noChangeAspect="1"/>
+          </p:cNvPicPr>
+          <p:nvPr/>
+        </p:nvPicPr>
+        <p:blipFill>
+          <a:blip r:embed="rId3"/>
+          <a:stretch>
+            <a:fillRect/>
+          </a:stretch>
+        </p:blipFill>
+        <p:spPr>
+          <a:xfrm>
+            <a:off x="7982131" y="126449"/>
+            <a:ext cx="3447869" cy="1318303"/>
+          </a:xfrm>
+          <a:prstGeom prst="rect">
+            <a:avLst/>
+          </a:prstGeom>
+        </p:spPr>
+      </p:pic>
+      <p:pic>
+        <p:nvPicPr>
           <p:cNvPr id="40" name="Picture 39" descr="GR4AD_Figure4_crop.png"/>
           <p:cNvPicPr>
             <a:picLocks noChangeAspect="1"/>
@@ -3168,7 +2388,7 @@
           <p:nvPr/>
         </p:nvPicPr>
         <p:blipFill>
-          <a:blip r:embed="rId3"/>
+          <a:blip r:embed="rId4"/>
           <a:stretch>
             <a:fillRect/>
           </a:stretch>
@@ -3226,7 +2446,7 @@
         </p:nvSpPr>
         <p:spPr>
           <a:xfrm>
-            <a:off x="530352" y="731520"/>
+            <a:off x="495829" y="685221"/>
             <a:ext cx="10881360" cy="329184"/>
           </a:xfrm>
           <a:prstGeom prst="rect">
@@ -4249,7 +3469,7 @@
 </p:sld>
 </file>
 
-<file path=ppt/slides/slide13.xml><?xml version="1.0" encoding="utf-8"?>
+<file path=ppt/slides/slide12.xml><?xml version="1.0" encoding="utf-8"?>
 <p:sld xmlns:a="http://schemas.openxmlformats.org/drawingml/2006/main" xmlns:r="http://schemas.openxmlformats.org/officeDocument/2006/relationships" xmlns:p="http://schemas.openxmlformats.org/presentationml/2006/main">
   <p:cSld name="Slide 11">
     <p:spTree>
@@ -5891,7 +5111,7 @@
         </p:blipFill>
         <p:spPr>
           <a:xfrm>
-            <a:off x="615725" y="828558"/>
+            <a:off x="615725" y="1658983"/>
             <a:ext cx="10960549" cy="4263157"/>
           </a:xfrm>
           <a:prstGeom prst="rect">
@@ -5949,66 +5169,6 @@
 </file>
 
 <file path=ppt/slides/slide4.xml><?xml version="1.0" encoding="utf-8"?>
-<p:sld xmlns:a="http://schemas.openxmlformats.org/drawingml/2006/main" xmlns:r="http://schemas.openxmlformats.org/officeDocument/2006/relationships" xmlns:p="http://schemas.openxmlformats.org/presentationml/2006/main">
-  <p:cSld>
-    <p:spTree>
-      <p:nvGrpSpPr>
-        <p:cNvPr id="1" name=""/>
-        <p:cNvGrpSpPr/>
-        <p:nvPr/>
-      </p:nvGrpSpPr>
-      <p:grpSpPr>
-        <a:xfrm>
-          <a:off x="0" y="0"/>
-          <a:ext cx="0" cy="0"/>
-          <a:chOff x="0" y="0"/>
-          <a:chExt cx="0" cy="0"/>
-        </a:xfrm>
-      </p:grpSpPr>
-      <p:pic>
-        <p:nvPicPr>
-          <p:cNvPr id="2" name="Picture 1" descr="深度剖析RQ-VAE：从向量量化到生成式推荐的语义ID技术- 石头开会- 博客园">
-            <a:extLst>
-              <a:ext uri="{FF2B5EF4-FFF2-40B4-BE49-F238E27FC236}">
-                <a16:creationId xmlns:a16="http://schemas.microsoft.com/office/drawing/2014/main" id="{116150A3-0C9C-CE8E-2215-5F6482D7968F}"/>
-              </a:ext>
-            </a:extLst>
-          </p:cNvPr>
-          <p:cNvPicPr>
-            <a:picLocks noChangeAspect="1"/>
-          </p:cNvPicPr>
-          <p:nvPr/>
-        </p:nvPicPr>
-        <p:blipFill>
-          <a:blip r:embed="rId2"/>
-          <a:stretch>
-            <a:fillRect/>
-          </a:stretch>
-        </p:blipFill>
-        <p:spPr>
-          <a:xfrm>
-            <a:off x="1285290" y="655475"/>
-            <a:ext cx="9185655" cy="5213480"/>
-          </a:xfrm>
-          <a:prstGeom prst="rect">
-            <a:avLst/>
-          </a:prstGeom>
-        </p:spPr>
-      </p:pic>
-    </p:spTree>
-    <p:extLst>
-      <p:ext uri="{BB962C8B-B14F-4D97-AF65-F5344CB8AC3E}">
-        <p14:creationId xmlns:p14="http://schemas.microsoft.com/office/powerpoint/2010/main" val="1376345734"/>
-      </p:ext>
-    </p:extLst>
-  </p:cSld>
-  <p:clrMapOvr>
-    <a:masterClrMapping/>
-  </p:clrMapOvr>
-</p:sld>
-</file>
-
-<file path=ppt/slides/slide5.xml><?xml version="1.0" encoding="utf-8"?>
 <p:sld xmlns:a="http://schemas.openxmlformats.org/drawingml/2006/main" xmlns:r="http://schemas.openxmlformats.org/officeDocument/2006/relationships" xmlns:p="http://schemas.openxmlformats.org/presentationml/2006/main">
   <p:cSld name="Slide 5">
     <p:spTree>
@@ -6795,7 +5955,7 @@
 </p:sld>
 </file>
 
-<file path=ppt/slides/slide6.xml><?xml version="1.0" encoding="utf-8"?>
+<file path=ppt/slides/slide5.xml><?xml version="1.0" encoding="utf-8"?>
 <p:sld xmlns:a="http://schemas.openxmlformats.org/drawingml/2006/main" xmlns:r="http://schemas.openxmlformats.org/officeDocument/2006/relationships" xmlns:p="http://schemas.openxmlformats.org/presentationml/2006/main">
   <p:cSld>
     <p:spTree>
@@ -6855,7 +6015,7 @@
 </p:sld>
 </file>
 
-<file path=ppt/slides/slide7.xml><?xml version="1.0" encoding="utf-8"?>
+<file path=ppt/slides/slide6.xml><?xml version="1.0" encoding="utf-8"?>
 <p:sld xmlns:a="http://schemas.openxmlformats.org/drawingml/2006/main" xmlns:r="http://schemas.openxmlformats.org/officeDocument/2006/relationships" xmlns:p="http://schemas.openxmlformats.org/presentationml/2006/main">
   <p:cSld name="Slide 7">
     <p:spTree>
@@ -7624,7 +6784,7 @@
 </p:sld>
 </file>
 
-<file path=ppt/slides/slide8.xml><?xml version="1.0" encoding="utf-8"?>
+<file path=ppt/slides/slide7.xml><?xml version="1.0" encoding="utf-8"?>
 <p:sld xmlns:a="http://schemas.openxmlformats.org/drawingml/2006/main" xmlns:r="http://schemas.openxmlformats.org/officeDocument/2006/relationships" xmlns:p="http://schemas.openxmlformats.org/presentationml/2006/main">
   <p:cSld>
     <p:spTree>
@@ -8277,7 +7437,7 @@
 </p:sld>
 </file>
 
-<file path=ppt/slides/slide9.xml><?xml version="1.0" encoding="utf-8"?>
+<file path=ppt/slides/slide8.xml><?xml version="1.0" encoding="utf-8"?>
 <p:sld xmlns:a="http://schemas.openxmlformats.org/drawingml/2006/main" xmlns:r="http://schemas.openxmlformats.org/officeDocument/2006/relationships" xmlns:p="http://schemas.openxmlformats.org/presentationml/2006/main">
   <p:cSld>
     <p:spTree>
@@ -8388,12 +7548,607 @@
           </a:p>
         </p:txBody>
       </p:sp>
+      <p:sp>
+        <p:nvSpPr>
+          <p:cNvPr id="4" name="TextBox 3">
+            <a:extLst>
+              <a:ext uri="{FF2B5EF4-FFF2-40B4-BE49-F238E27FC236}">
+                <a16:creationId xmlns:a16="http://schemas.microsoft.com/office/drawing/2014/main" id="{9318D0F8-26A3-0B85-0EA8-7C050C913EF5}"/>
+              </a:ext>
+            </a:extLst>
+          </p:cNvPr>
+          <p:cNvSpPr txBox="1"/>
+          <p:nvPr/>
+        </p:nvSpPr>
+        <p:spPr>
+          <a:xfrm>
+            <a:off x="5971032" y="2034408"/>
+            <a:ext cx="6097554" cy="2246769"/>
+          </a:xfrm>
+          <a:prstGeom prst="rect">
+            <a:avLst/>
+          </a:prstGeom>
+          <a:noFill/>
+        </p:spPr>
+        <p:txBody>
+          <a:bodyPr wrap="square">
+            <a:spAutoFit/>
+          </a:bodyPr>
+          <a:lstStyle/>
+          <a:p>
+            <a:pPr marL="342900" lvl="0" indent="-342900">
+              <a:buFont typeface="Arial" panose="020B0604020202020204" pitchFamily="34" charset="0"/>
+              <a:buChar char="•"/>
+            </a:pPr>
+            <a:r>
+              <a:rPr lang="en-US" sz="1400" b="1" dirty="0"/>
+              <a:t>Residual K-Means:</a:t>
+            </a:r>
+            <a:r>
+              <a:rPr lang="en-US" sz="1400" dirty="0"/>
+              <a:t> </a:t>
+            </a:r>
+            <a:r>
+              <a:rPr lang="en-US" sz="1400" dirty="0" err="1"/>
+              <a:t>mỗi</a:t>
+            </a:r>
+            <a:r>
+              <a:rPr lang="en-US" sz="1400" dirty="0"/>
+              <a:t> level </a:t>
+            </a:r>
+            <a:r>
+              <a:rPr lang="en-US" sz="1400" dirty="0" err="1"/>
+              <a:t>chọn</a:t>
+            </a:r>
+            <a:r>
+              <a:rPr lang="en-US" sz="1400" dirty="0"/>
+              <a:t> centroid </a:t>
+            </a:r>
+            <a:r>
+              <a:rPr lang="en-US" sz="1400" dirty="0" err="1"/>
+              <a:t>gần</a:t>
+            </a:r>
+            <a:r>
+              <a:rPr lang="en-US" sz="1400" dirty="0"/>
+              <a:t> </a:t>
+            </a:r>
+            <a:r>
+              <a:rPr lang="en-US" sz="1400" dirty="0" err="1"/>
+              <a:t>nhất</a:t>
+            </a:r>
+            <a:r>
+              <a:rPr lang="en-US" sz="1400" dirty="0"/>
+              <a:t> → </a:t>
+            </a:r>
+            <a:r>
+              <a:rPr lang="en-US" sz="1400" dirty="0" err="1"/>
+              <a:t>lấy</a:t>
+            </a:r>
+            <a:r>
+              <a:rPr lang="en-US" sz="1400" dirty="0"/>
+              <a:t> cluster ID </a:t>
+            </a:r>
+            <a:r>
+              <a:rPr lang="en-US" sz="1400" dirty="0" err="1"/>
+              <a:t>làm</a:t>
+            </a:r>
+            <a:r>
+              <a:rPr lang="en-US" sz="1400" dirty="0"/>
+              <a:t> token → </a:t>
+            </a:r>
+            <a:r>
+              <a:rPr lang="en-US" sz="1400" dirty="0" err="1"/>
+              <a:t>trừ</a:t>
+            </a:r>
+            <a:r>
+              <a:rPr lang="en-US" sz="1400" dirty="0"/>
+              <a:t> centroid </a:t>
+            </a:r>
+            <a:r>
+              <a:rPr lang="en-US" sz="1400" dirty="0" err="1"/>
+              <a:t>để</a:t>
+            </a:r>
+            <a:r>
+              <a:rPr lang="en-US" sz="1400" dirty="0"/>
+              <a:t> </a:t>
+            </a:r>
+            <a:r>
+              <a:rPr lang="en-US" sz="1400" dirty="0" err="1"/>
+              <a:t>tạo</a:t>
+            </a:r>
+            <a:r>
+              <a:rPr lang="en-US" sz="1400" dirty="0"/>
+              <a:t> residual </a:t>
+            </a:r>
+            <a:r>
+              <a:rPr lang="en-US" sz="1400" dirty="0" err="1"/>
+              <a:t>cho</a:t>
+            </a:r>
+            <a:r>
+              <a:rPr lang="en-US" sz="1400" dirty="0"/>
+              <a:t> level </a:t>
+            </a:r>
+            <a:r>
+              <a:rPr lang="en-US" sz="1400" dirty="0" err="1"/>
+              <a:t>tiếp</a:t>
+            </a:r>
+            <a:r>
+              <a:rPr lang="en-US" sz="1400" dirty="0"/>
+              <a:t> </a:t>
+            </a:r>
+            <a:r>
+              <a:rPr lang="en-US" sz="1400" dirty="0" err="1"/>
+              <a:t>theo.</a:t>
+            </a:r>
+            <a:endParaRPr lang="en-US" sz="1400" dirty="0"/>
+          </a:p>
+          <a:p>
+            <a:pPr marL="342900" lvl="0" indent="-342900">
+              <a:buFont typeface="Arial" panose="020B0604020202020204" pitchFamily="34" charset="0"/>
+              <a:buChar char="•"/>
+            </a:pPr>
+            <a:r>
+              <a:rPr lang="en-US" sz="1400" b="1" dirty="0"/>
+              <a:t>Multi-Resolution:</a:t>
+            </a:r>
+            <a:r>
+              <a:rPr lang="en-US" sz="1400" dirty="0"/>
+              <a:t> </a:t>
+            </a:r>
+            <a:r>
+              <a:rPr lang="en-US" sz="1400" dirty="0" err="1"/>
+              <a:t>các</a:t>
+            </a:r>
+            <a:r>
+              <a:rPr lang="en-US" sz="1400" dirty="0"/>
+              <a:t> level </a:t>
+            </a:r>
+            <a:r>
+              <a:rPr lang="en-US" sz="1400" dirty="0" err="1"/>
+              <a:t>đầu</a:t>
+            </a:r>
+            <a:r>
+              <a:rPr lang="en-US" sz="1400" dirty="0"/>
+              <a:t> </a:t>
+            </a:r>
+            <a:r>
+              <a:rPr lang="en-US" sz="1400" dirty="0" err="1"/>
+              <a:t>dùng</a:t>
+            </a:r>
+            <a:r>
+              <a:rPr lang="en-US" sz="1400" dirty="0"/>
+              <a:t> codebook </a:t>
+            </a:r>
+            <a:r>
+              <a:rPr lang="en-US" sz="1400" dirty="0" err="1"/>
+              <a:t>lớn</a:t>
+            </a:r>
+            <a:r>
+              <a:rPr lang="en-US" sz="1400" dirty="0"/>
+              <a:t> </a:t>
+            </a:r>
+            <a:r>
+              <a:rPr lang="en-US" sz="1400" dirty="0" err="1"/>
+              <a:t>để</a:t>
+            </a:r>
+            <a:r>
+              <a:rPr lang="en-US" sz="1400" dirty="0"/>
+              <a:t> </a:t>
+            </a:r>
+            <a:r>
+              <a:rPr lang="en-US" sz="1400" dirty="0" err="1"/>
+              <a:t>bắt</a:t>
+            </a:r>
+            <a:r>
+              <a:rPr lang="en-US" sz="1400" dirty="0"/>
+              <a:t> </a:t>
+            </a:r>
+            <a:r>
+              <a:rPr lang="en-US" sz="1400" dirty="0" err="1"/>
+              <a:t>các</a:t>
+            </a:r>
+            <a:r>
+              <a:rPr lang="en-US" sz="1400" dirty="0"/>
+              <a:t> </a:t>
+            </a:r>
+            <a:r>
+              <a:rPr lang="en-US" sz="1400" dirty="0" err="1"/>
+              <a:t>yếu</a:t>
+            </a:r>
+            <a:r>
+              <a:rPr lang="en-US" sz="1400" dirty="0"/>
+              <a:t> </a:t>
+            </a:r>
+            <a:r>
+              <a:rPr lang="en-US" sz="1400" dirty="0" err="1"/>
+              <a:t>tố</a:t>
+            </a:r>
+            <a:r>
+              <a:rPr lang="en-US" sz="1400" dirty="0"/>
+              <a:t> semantic </a:t>
+            </a:r>
+            <a:r>
+              <a:rPr lang="en-US" sz="1400" dirty="0" err="1"/>
+              <a:t>chính</a:t>
+            </a:r>
+            <a:r>
+              <a:rPr lang="en-US" sz="1400" dirty="0"/>
+              <a:t>; residual </a:t>
+            </a:r>
+            <a:r>
+              <a:rPr lang="en-US" sz="1400" dirty="0" err="1"/>
+              <a:t>về</a:t>
+            </a:r>
+            <a:r>
+              <a:rPr lang="en-US" sz="1400" dirty="0"/>
+              <a:t> </a:t>
+            </a:r>
+            <a:r>
+              <a:rPr lang="en-US" sz="1400" dirty="0" err="1"/>
+              <a:t>sau</a:t>
+            </a:r>
+            <a:r>
+              <a:rPr lang="en-US" sz="1400" dirty="0"/>
+              <a:t> </a:t>
+            </a:r>
+            <a:r>
+              <a:rPr lang="en-US" sz="1400" dirty="0" err="1"/>
+              <a:t>có</a:t>
+            </a:r>
+            <a:r>
+              <a:rPr lang="en-US" sz="1400" dirty="0"/>
+              <a:t> entropy </a:t>
+            </a:r>
+            <a:r>
+              <a:rPr lang="en-US" sz="1400" dirty="0" err="1"/>
+              <a:t>thấp</a:t>
+            </a:r>
+            <a:r>
+              <a:rPr lang="en-US" sz="1400" dirty="0"/>
+              <a:t> </a:t>
+            </a:r>
+            <a:r>
+              <a:rPr lang="en-US" sz="1400" dirty="0" err="1"/>
+              <a:t>hơn</a:t>
+            </a:r>
+            <a:r>
+              <a:rPr lang="en-US" sz="1400" dirty="0"/>
+              <a:t> </a:t>
+            </a:r>
+            <a:r>
+              <a:rPr lang="en-US" sz="1400" dirty="0" err="1"/>
+              <a:t>nên</a:t>
+            </a:r>
+            <a:r>
+              <a:rPr lang="en-US" sz="1400" dirty="0"/>
+              <a:t> </a:t>
+            </a:r>
+            <a:r>
+              <a:rPr lang="en-US" sz="1400" dirty="0" err="1"/>
+              <a:t>không</a:t>
+            </a:r>
+            <a:r>
+              <a:rPr lang="en-US" sz="1400" dirty="0"/>
+              <a:t> </a:t>
+            </a:r>
+            <a:r>
+              <a:rPr lang="en-US" sz="1400" dirty="0" err="1"/>
+              <a:t>cần</a:t>
+            </a:r>
+            <a:r>
+              <a:rPr lang="en-US" sz="1400" dirty="0"/>
+              <a:t> </a:t>
+            </a:r>
+            <a:r>
+              <a:rPr lang="en-US" sz="1400" dirty="0" err="1"/>
+              <a:t>cùng</a:t>
+            </a:r>
+            <a:r>
+              <a:rPr lang="en-US" sz="1400" dirty="0"/>
+              <a:t> </a:t>
+            </a:r>
+            <a:r>
+              <a:rPr lang="en-US" sz="1400" dirty="0" err="1"/>
+              <a:t>độ</a:t>
+            </a:r>
+            <a:r>
+              <a:rPr lang="en-US" sz="1400" dirty="0"/>
+              <a:t> </a:t>
+            </a:r>
+            <a:r>
+              <a:rPr lang="en-US" sz="1400" dirty="0" err="1"/>
+              <a:t>phân</a:t>
+            </a:r>
+            <a:r>
+              <a:rPr lang="en-US" sz="1400" dirty="0"/>
+              <a:t> </a:t>
+            </a:r>
+            <a:r>
+              <a:rPr lang="en-US" sz="1400" dirty="0" err="1"/>
+              <a:t>giải</a:t>
+            </a:r>
+            <a:r>
+              <a:rPr lang="en-US" sz="1400" dirty="0"/>
+              <a:t>.</a:t>
+            </a:r>
+          </a:p>
+          <a:p>
+            <a:pPr marL="342900" lvl="0" indent="-342900">
+              <a:buFont typeface="Arial" panose="020B0604020202020204" pitchFamily="34" charset="0"/>
+              <a:buChar char="•"/>
+            </a:pPr>
+            <a:r>
+              <a:rPr lang="en-US" sz="1400" b="1" dirty="0"/>
+              <a:t>Balanced K-Means:</a:t>
+            </a:r>
+            <a:r>
+              <a:rPr lang="en-US" sz="1400" dirty="0"/>
+              <a:t> </a:t>
+            </a:r>
+            <a:r>
+              <a:rPr lang="en-US" sz="1400" dirty="0" err="1"/>
+              <a:t>ép</a:t>
+            </a:r>
+            <a:r>
+              <a:rPr lang="en-US" sz="1400" dirty="0"/>
+              <a:t> cluster </a:t>
+            </a:r>
+            <a:r>
+              <a:rPr lang="en-US" sz="1400" dirty="0" err="1"/>
+              <a:t>phân</a:t>
+            </a:r>
+            <a:r>
+              <a:rPr lang="en-US" sz="1400" dirty="0"/>
+              <a:t> </a:t>
+            </a:r>
+            <a:r>
+              <a:rPr lang="en-US" sz="1400" dirty="0" err="1"/>
+              <a:t>bố</a:t>
+            </a:r>
+            <a:r>
+              <a:rPr lang="en-US" sz="1400" dirty="0"/>
+              <a:t> </a:t>
+            </a:r>
+            <a:r>
+              <a:rPr lang="en-US" sz="1400" dirty="0" err="1"/>
+              <a:t>cân</a:t>
+            </a:r>
+            <a:r>
+              <a:rPr lang="en-US" sz="1400" dirty="0"/>
+              <a:t> </a:t>
+            </a:r>
+            <a:r>
+              <a:rPr lang="en-US" sz="1400" dirty="0" err="1"/>
+              <a:t>bằng</a:t>
+            </a:r>
+            <a:r>
+              <a:rPr lang="en-US" sz="1400" dirty="0"/>
+              <a:t> </a:t>
+            </a:r>
+            <a:r>
+              <a:rPr lang="en-US" sz="1400" dirty="0" err="1"/>
+              <a:t>hơn</a:t>
+            </a:r>
+            <a:r>
+              <a:rPr lang="en-US" sz="1400" dirty="0"/>
+              <a:t> → </a:t>
+            </a:r>
+            <a:r>
+              <a:rPr lang="en-US" sz="1400" b="1" dirty="0" err="1"/>
+              <a:t>tăng</a:t>
+            </a:r>
+            <a:r>
+              <a:rPr lang="en-US" sz="1400" b="1" dirty="0"/>
+              <a:t> codebook utilization</a:t>
+            </a:r>
+            <a:r>
+              <a:rPr lang="en-US" sz="1400" dirty="0"/>
+              <a:t>, </a:t>
+            </a:r>
+            <a:r>
+              <a:rPr lang="en-US" sz="1400" dirty="0" err="1"/>
+              <a:t>tránh</a:t>
+            </a:r>
+            <a:r>
+              <a:rPr lang="en-US" sz="1400" dirty="0"/>
+              <a:t> </a:t>
+            </a:r>
+            <a:r>
+              <a:rPr lang="en-US" sz="1400" dirty="0" err="1"/>
+              <a:t>nhiều</a:t>
+            </a:r>
+            <a:r>
+              <a:rPr lang="en-US" sz="1400" dirty="0"/>
+              <a:t> token </a:t>
+            </a:r>
+            <a:r>
+              <a:rPr lang="en-US" sz="1400" dirty="0" err="1"/>
+              <a:t>gần</a:t>
+            </a:r>
+            <a:r>
+              <a:rPr lang="en-US" sz="1400" dirty="0"/>
+              <a:t> </a:t>
+            </a:r>
+            <a:r>
+              <a:rPr lang="en-US" sz="1400" dirty="0" err="1"/>
+              <a:t>như</a:t>
+            </a:r>
+            <a:r>
+              <a:rPr lang="en-US" sz="1400" dirty="0"/>
+              <a:t> </a:t>
+            </a:r>
+            <a:r>
+              <a:rPr lang="en-US" sz="1400" dirty="0" err="1"/>
+              <a:t>không</a:t>
+            </a:r>
+            <a:r>
+              <a:rPr lang="en-US" sz="1400" dirty="0"/>
+              <a:t> </a:t>
+            </a:r>
+            <a:r>
+              <a:rPr lang="en-US" sz="1400" dirty="0" err="1"/>
+              <a:t>được</a:t>
+            </a:r>
+            <a:r>
+              <a:rPr lang="en-US" sz="1400" dirty="0"/>
+              <a:t> </a:t>
+            </a:r>
+            <a:r>
+              <a:rPr lang="en-US" sz="1400" dirty="0" err="1"/>
+              <a:t>dùng</a:t>
+            </a:r>
+            <a:r>
+              <a:rPr lang="en-US" sz="1400" dirty="0"/>
+              <a:t>.</a:t>
+            </a:r>
+          </a:p>
+          <a:p>
+            <a:pPr marL="342900" lvl="0" indent="-342900">
+              <a:buFont typeface="Arial" panose="020B0604020202020204" pitchFamily="34" charset="0"/>
+              <a:buChar char="•"/>
+            </a:pPr>
+            <a:r>
+              <a:rPr lang="en-US" sz="1400" b="1" dirty="0"/>
+              <a:t>Multi-Granularity:</a:t>
+            </a:r>
+            <a:r>
+              <a:rPr lang="en-US" sz="1400" dirty="0"/>
+              <a:t> level </a:t>
+            </a:r>
+            <a:r>
+              <a:rPr lang="en-US" sz="1400" dirty="0" err="1"/>
+              <a:t>cuối</a:t>
+            </a:r>
+            <a:r>
+              <a:rPr lang="en-US" sz="1400" dirty="0"/>
+              <a:t> </a:t>
+            </a:r>
+            <a:r>
+              <a:rPr lang="en-US" sz="1400" dirty="0" err="1"/>
+              <a:t>dùng</a:t>
+            </a:r>
+            <a:r>
+              <a:rPr lang="en-US" sz="1400" dirty="0"/>
+              <a:t> </a:t>
+            </a:r>
+            <a:r>
+              <a:rPr lang="en-US" sz="1400" b="1" dirty="0"/>
+              <a:t>hash </a:t>
+            </a:r>
+            <a:r>
+              <a:rPr lang="en-US" sz="1400" b="1" dirty="0" err="1"/>
+              <a:t>từ</a:t>
+            </a:r>
+            <a:r>
+              <a:rPr lang="en-US" sz="1400" b="1" dirty="0"/>
+              <a:t> business features</a:t>
+            </a:r>
+            <a:r>
+              <a:rPr lang="en-US" sz="1400" dirty="0"/>
+              <a:t> </a:t>
+            </a:r>
+            <a:r>
+              <a:rPr lang="en-US" sz="1400" dirty="0" err="1"/>
+              <a:t>như</a:t>
+            </a:r>
+            <a:r>
+              <a:rPr lang="en-US" sz="1400" dirty="0"/>
+              <a:t> Account ID / Conversion Type </a:t>
+            </a:r>
+            <a:r>
+              <a:rPr lang="en-US" sz="1400" dirty="0" err="1"/>
+              <a:t>để</a:t>
+            </a:r>
+            <a:r>
+              <a:rPr lang="en-US" sz="1400" dirty="0"/>
+              <a:t> </a:t>
+            </a:r>
+            <a:r>
+              <a:rPr lang="en-US" sz="1400" dirty="0" err="1"/>
+              <a:t>phân</a:t>
+            </a:r>
+            <a:r>
+              <a:rPr lang="en-US" sz="1400" dirty="0"/>
+              <a:t> </a:t>
+            </a:r>
+            <a:r>
+              <a:rPr lang="en-US" sz="1400" dirty="0" err="1"/>
+              <a:t>biệt</a:t>
+            </a:r>
+            <a:r>
+              <a:rPr lang="en-US" sz="1400" dirty="0"/>
+              <a:t> </a:t>
+            </a:r>
+            <a:r>
+              <a:rPr lang="en-US" sz="1400" dirty="0" err="1"/>
+              <a:t>các</a:t>
+            </a:r>
+            <a:r>
+              <a:rPr lang="en-US" sz="1400" dirty="0"/>
+              <a:t> Ads semantic </a:t>
+            </a:r>
+            <a:r>
+              <a:rPr lang="en-US" sz="1400" dirty="0" err="1"/>
+              <a:t>giống</a:t>
+            </a:r>
+            <a:r>
+              <a:rPr lang="en-US" sz="1400" dirty="0"/>
+              <a:t> </a:t>
+            </a:r>
+            <a:r>
+              <a:rPr lang="en-US" sz="1400" dirty="0" err="1"/>
+              <a:t>nhau</a:t>
+            </a:r>
+            <a:r>
+              <a:rPr lang="en-US" sz="1400" dirty="0"/>
+              <a:t> </a:t>
+            </a:r>
+            <a:r>
+              <a:rPr lang="en-US" sz="1400" dirty="0" err="1"/>
+              <a:t>nhưng</a:t>
+            </a:r>
+            <a:r>
+              <a:rPr lang="en-US" sz="1400" dirty="0"/>
+              <a:t> </a:t>
+            </a:r>
+            <a:r>
+              <a:rPr lang="en-US" sz="1400" dirty="0" err="1"/>
+              <a:t>mục</a:t>
+            </a:r>
+            <a:r>
+              <a:rPr lang="en-US" sz="1400" dirty="0"/>
+              <a:t> </a:t>
+            </a:r>
+            <a:r>
+              <a:rPr lang="en-US" sz="1400" dirty="0" err="1"/>
+              <a:t>tiêu</a:t>
+            </a:r>
+            <a:r>
+              <a:rPr lang="en-US" sz="1400" dirty="0"/>
+              <a:t> delivery </a:t>
+            </a:r>
+            <a:r>
+              <a:rPr lang="en-US" sz="1400" dirty="0" err="1"/>
+              <a:t>khác</a:t>
+            </a:r>
+            <a:r>
+              <a:rPr lang="en-US" sz="1400" dirty="0"/>
+              <a:t> </a:t>
+            </a:r>
+            <a:r>
+              <a:rPr lang="en-US" sz="1400" dirty="0" err="1"/>
+              <a:t>nhau</a:t>
+            </a:r>
+            <a:endParaRPr lang="en-US" sz="1400" dirty="0"/>
+          </a:p>
+        </p:txBody>
+      </p:sp>
       <p:pic>
         <p:nvPicPr>
-          <p:cNvPr id="3" name="Picture 2">
+          <p:cNvPr id="5" name="Picture 4" descr="深度剖析RQ-VAE：从向量量化到生成式推荐的语义ID技术- 石头开会- 博客园">
             <a:extLst>
               <a:ext uri="{FF2B5EF4-FFF2-40B4-BE49-F238E27FC236}">
-                <a16:creationId xmlns:a16="http://schemas.microsoft.com/office/drawing/2014/main" id="{A555F419-9F37-F634-2644-CC6C03F4AAAB}"/>
+                <a16:creationId xmlns:a16="http://schemas.microsoft.com/office/drawing/2014/main" id="{35F43364-B56A-8C07-5E20-57AE8047DC5D}"/>
               </a:ext>
             </a:extLst>
           </p:cNvPr>
@@ -8410,30 +8165,78 @@
         </p:blipFill>
         <p:spPr>
           <a:xfrm>
-            <a:off x="123414" y="1301620"/>
-            <a:ext cx="6256487" cy="4692365"/>
+            <a:off x="652211" y="1841774"/>
+            <a:ext cx="5593080" cy="3174451"/>
           </a:xfrm>
           <a:prstGeom prst="rect">
             <a:avLst/>
           </a:prstGeom>
         </p:spPr>
       </p:pic>
-      <p:sp>
-        <p:nvSpPr>
-          <p:cNvPr id="4" name="TextBox 3">
-            <a:extLst>
-              <a:ext uri="{FF2B5EF4-FFF2-40B4-BE49-F238E27FC236}">
-                <a16:creationId xmlns:a16="http://schemas.microsoft.com/office/drawing/2014/main" id="{9318D0F8-26A3-0B85-0EA8-7C050C913EF5}"/>
-              </a:ext>
-            </a:extLst>
-          </p:cNvPr>
+    </p:spTree>
+    <p:extLst>
+      <p:ext uri="{BB962C8B-B14F-4D97-AF65-F5344CB8AC3E}">
+        <p14:creationId xmlns:p14="http://schemas.microsoft.com/office/powerpoint/2010/main" val="3768493168"/>
+      </p:ext>
+    </p:extLst>
+  </p:cSld>
+  <p:clrMapOvr>
+    <a:masterClrMapping/>
+  </p:clrMapOvr>
+</p:sld>
+</file>
+
+<file path=ppt/slides/slide9.xml><?xml version="1.0" encoding="utf-8"?>
+<p:sld xmlns:a="http://schemas.openxmlformats.org/drawingml/2006/main" xmlns:r="http://schemas.openxmlformats.org/officeDocument/2006/relationships" xmlns:p="http://schemas.openxmlformats.org/presentationml/2006/main">
+  <p:cSld>
+    <p:spTree>
+      <p:nvGrpSpPr>
+        <p:cNvPr id="1" name=""/>
+        <p:cNvGrpSpPr/>
+        <p:nvPr/>
+      </p:nvGrpSpPr>
+      <p:grpSpPr>
+        <a:xfrm>
+          <a:off x="0" y="0"/>
+          <a:ext cx="0" cy="0"/>
+          <a:chOff x="0" y="0"/>
+          <a:chExt cx="0" cy="0"/>
+        </a:xfrm>
+      </p:grpSpPr>
+      <p:pic>
+        <p:nvPicPr>
+          <p:cNvPr id="6" name="Picture 5" descr="image.png"/>
+          <p:cNvPicPr>
+            <a:picLocks noChangeAspect="1"/>
+          </p:cNvPicPr>
+          <p:nvPr/>
+        </p:nvPicPr>
+        <p:blipFill>
+          <a:blip r:embed="rId3"/>
+          <a:stretch>
+            <a:fillRect/>
+          </a:stretch>
+        </p:blipFill>
+        <p:spPr>
+          <a:xfrm>
+            <a:off x="1494764" y="1115793"/>
+            <a:ext cx="9363456" cy="3446837"/>
+          </a:xfrm>
+          <a:prstGeom prst="rect">
+            <a:avLst/>
+          </a:prstGeom>
+        </p:spPr>
+      </p:pic>
+      <p:sp>
+        <p:nvSpPr>
+          <p:cNvPr id="7" name="TextBox 6"/>
           <p:cNvSpPr txBox="1"/>
           <p:nvPr/>
         </p:nvSpPr>
         <p:spPr>
           <a:xfrm>
-            <a:off x="5971032" y="2034408"/>
-            <a:ext cx="6097554" cy="2246769"/>
+            <a:off x="502920" y="228600"/>
+            <a:ext cx="11064240" cy="475488"/>
           </a:xfrm>
           <a:prstGeom prst="rect">
             <a:avLst/>
@@ -8441,584 +8244,750 @@
           <a:noFill/>
         </p:spPr>
         <p:txBody>
-          <a:bodyPr wrap="square">
+          <a:bodyPr wrap="square" anchor="ctr">
             <a:spAutoFit/>
           </a:bodyPr>
           <a:lstStyle/>
           <a:p>
-            <a:pPr marL="342900" lvl="0" indent="-342900">
-              <a:buFont typeface="Arial" panose="020B0604020202020204" pitchFamily="34" charset="0"/>
-              <a:buChar char="•"/>
-            </a:pPr>
-            <a:r>
-              <a:rPr lang="en-US" sz="1400" b="1" dirty="0"/>
-              <a:t>Residual K-Means:</a:t>
-            </a:r>
-            <a:r>
-              <a:rPr lang="en-US" sz="1400" dirty="0"/>
-              <a:t> </a:t>
-            </a:r>
-            <a:r>
-              <a:rPr lang="en-US" sz="1400" dirty="0" err="1"/>
-              <a:t>mỗi</a:t>
-            </a:r>
-            <a:r>
-              <a:rPr lang="en-US" sz="1400" dirty="0"/>
-              <a:t> level </a:t>
-            </a:r>
-            <a:r>
-              <a:rPr lang="en-US" sz="1400" dirty="0" err="1"/>
-              <a:t>chọn</a:t>
-            </a:r>
-            <a:r>
-              <a:rPr lang="en-US" sz="1400" dirty="0"/>
-              <a:t> centroid </a:t>
-            </a:r>
-            <a:r>
-              <a:rPr lang="en-US" sz="1400" dirty="0" err="1"/>
+            <a:pPr algn="l"/>
+            <a:r>
+              <a:rPr sz="2400" b="1">
+                <a:solidFill>
+                  <a:srgbClr val="192C4F"/>
+                </a:solidFill>
+                <a:latin typeface="Aptos"/>
+              </a:rPr>
+              <a:t>LazyAR — Không phải mọi decoder layer đều cần autoregressive</a:t>
+            </a:r>
+          </a:p>
+        </p:txBody>
+      </p:sp>
+      <p:sp>
+        <p:nvSpPr>
+          <p:cNvPr id="8" name="TextBox 7"/>
+          <p:cNvSpPr txBox="1"/>
+          <p:nvPr/>
+        </p:nvSpPr>
+        <p:spPr>
+          <a:xfrm>
+            <a:off x="530352" y="731520"/>
+            <a:ext cx="10881360" cy="329184"/>
+          </a:xfrm>
+          <a:prstGeom prst="rect">
+            <a:avLst/>
+          </a:prstGeom>
+          <a:noFill/>
+        </p:spPr>
+        <p:txBody>
+          <a:bodyPr wrap="square" anchor="ctr">
+            <a:spAutoFit/>
+          </a:bodyPr>
+          <a:lstStyle/>
+          <a:p>
+            <a:pPr algn="l"/>
+            <a:r>
+              <a:rPr sz="1350" b="0">
+                <a:solidFill>
+                  <a:srgbClr val="676F7B"/>
+                </a:solidFill>
+                <a:latin typeface="Aptos"/>
+              </a:rPr>
+              <a:t>Ý tưởng cốt lõi: chỉ inject token trước ở layer muộn; phần đầu được tính song song và reuse qua beam.</a:t>
+            </a:r>
+          </a:p>
+        </p:txBody>
+      </p:sp>
+      <p:sp>
+        <p:nvSpPr>
+          <p:cNvPr id="9" name="Rounded Rectangle 8"/>
+          <p:cNvSpPr/>
+          <p:nvPr/>
+        </p:nvSpPr>
+        <p:spPr>
+          <a:xfrm>
+            <a:off x="1173295" y="4617719"/>
+            <a:ext cx="3063240" cy="1417320"/>
+          </a:xfrm>
+          <a:prstGeom prst="roundRect">
+            <a:avLst/>
+          </a:prstGeom>
+          <a:solidFill>
+            <a:srgbClr val="F9FAFC"/>
+          </a:solidFill>
+          <a:ln w="12700">
+            <a:solidFill>
+              <a:srgbClr val="DBE0E7"/>
+            </a:solidFill>
+          </a:ln>
+        </p:spPr>
+        <p:style>
+          <a:lnRef idx="1">
+            <a:schemeClr val="accent1"/>
+          </a:lnRef>
+          <a:fillRef idx="3">
+            <a:schemeClr val="accent1"/>
+          </a:fillRef>
+          <a:effectRef idx="2">
+            <a:schemeClr val="accent1"/>
+          </a:effectRef>
+          <a:fontRef idx="minor">
+            <a:schemeClr val="lt1"/>
+          </a:fontRef>
+        </p:style>
+        <p:txBody>
+          <a:bodyPr rtlCol="0" anchor="ctr"/>
+          <a:lstStyle/>
+          <a:p>
+            <a:pPr algn="ctr"/>
+            <a:endParaRPr/>
+          </a:p>
+        </p:txBody>
+      </p:sp>
+      <p:sp>
+        <p:nvSpPr>
+          <p:cNvPr id="10" name="TextBox 9"/>
+          <p:cNvSpPr txBox="1"/>
+          <p:nvPr/>
+        </p:nvSpPr>
+        <p:spPr>
+          <a:xfrm>
+            <a:off x="1242277" y="4806235"/>
+            <a:ext cx="2743200" cy="256032"/>
+          </a:xfrm>
+          <a:prstGeom prst="rect">
+            <a:avLst/>
+          </a:prstGeom>
+          <a:noFill/>
+        </p:spPr>
+        <p:txBody>
+          <a:bodyPr wrap="square" anchor="t">
+            <a:spAutoFit/>
+          </a:bodyPr>
+          <a:lstStyle/>
+          <a:p>
+            <a:pPr algn="l"/>
+            <a:r>
+              <a:rPr sz="1550" b="1" dirty="0">
+                <a:solidFill>
+                  <a:srgbClr val="B74646"/>
+                </a:solidFill>
+                <a:latin typeface="Aptos"/>
+              </a:rPr>
+              <a:t>Vanilla AR</a:t>
+            </a:r>
+          </a:p>
+        </p:txBody>
+      </p:sp>
+      <p:sp>
+        <p:nvSpPr>
+          <p:cNvPr id="11" name="TextBox 10"/>
+          <p:cNvSpPr txBox="1"/>
+          <p:nvPr/>
+        </p:nvSpPr>
+        <p:spPr>
+          <a:xfrm>
+            <a:off x="1242277" y="5179497"/>
+            <a:ext cx="2743200" cy="749808"/>
+          </a:xfrm>
+          <a:prstGeom prst="rect">
+            <a:avLst/>
+          </a:prstGeom>
+          <a:noFill/>
+        </p:spPr>
+        <p:txBody>
+          <a:bodyPr wrap="square" anchor="t">
+            <a:spAutoFit/>
+          </a:bodyPr>
+          <a:lstStyle/>
+          <a:p>
+            <a:pPr algn="l"/>
+            <a:r>
+              <a:rPr sz="1180" b="0" dirty="0" err="1">
+                <a:solidFill>
+                  <a:srgbClr val="2B3341"/>
+                </a:solidFill>
+                <a:latin typeface="Aptos"/>
+              </a:rPr>
+              <a:t>Mỗi</a:t>
+            </a:r>
+            <a:r>
+              <a:rPr sz="1180" b="0" dirty="0">
+                <a:solidFill>
+                  <a:srgbClr val="2B3341"/>
+                </a:solidFill>
+                <a:latin typeface="Aptos"/>
+              </a:rPr>
+              <a:t> step </a:t>
+            </a:r>
+            <a:r>
+              <a:rPr sz="1180" b="0" dirty="0" err="1">
+                <a:solidFill>
+                  <a:srgbClr val="2B3341"/>
+                </a:solidFill>
+                <a:latin typeface="Aptos"/>
+              </a:rPr>
+              <a:t>chạy</a:t>
+            </a:r>
+            <a:r>
+              <a:rPr sz="1180" b="0" dirty="0">
+                <a:solidFill>
+                  <a:srgbClr val="2B3341"/>
+                </a:solidFill>
+                <a:latin typeface="Aptos"/>
+              </a:rPr>
+              <a:t> qua </a:t>
+            </a:r>
+            <a:r>
+              <a:rPr sz="1180" b="0" dirty="0" err="1">
+                <a:solidFill>
+                  <a:srgbClr val="2B3341"/>
+                </a:solidFill>
+                <a:latin typeface="Aptos"/>
+              </a:rPr>
+              <a:t>toàn</a:t>
+            </a:r>
+            <a:r>
+              <a:rPr sz="1180" b="0" dirty="0">
+                <a:solidFill>
+                  <a:srgbClr val="2B3341"/>
+                </a:solidFill>
+                <a:latin typeface="Aptos"/>
+              </a:rPr>
+              <a:t> </a:t>
+            </a:r>
+            <a:r>
+              <a:rPr sz="1180" b="0" dirty="0" err="1">
+                <a:solidFill>
+                  <a:srgbClr val="2B3341"/>
+                </a:solidFill>
+                <a:latin typeface="Aptos"/>
+              </a:rPr>
+              <a:t>bộ</a:t>
+            </a:r>
+            <a:r>
+              <a:rPr sz="1180" b="0" dirty="0">
+                <a:solidFill>
+                  <a:srgbClr val="2B3341"/>
+                </a:solidFill>
+                <a:latin typeface="Aptos"/>
+              </a:rPr>
+              <a:t> decoder </a:t>
+            </a:r>
+            <a:r>
+              <a:rPr sz="1180" b="0" dirty="0" err="1">
+                <a:solidFill>
+                  <a:srgbClr val="2B3341"/>
+                </a:solidFill>
+                <a:latin typeface="Aptos"/>
+              </a:rPr>
+              <a:t>và</a:t>
+            </a:r>
+            <a:r>
+              <a:rPr sz="1180" b="0" dirty="0">
+                <a:solidFill>
+                  <a:srgbClr val="2B3341"/>
+                </a:solidFill>
+                <a:latin typeface="Aptos"/>
+              </a:rPr>
+              <a:t> </a:t>
+            </a:r>
+            <a:r>
+              <a:rPr sz="1180" b="0" dirty="0" err="1">
+                <a:solidFill>
+                  <a:srgbClr val="2B3341"/>
+                </a:solidFill>
+                <a:latin typeface="Aptos"/>
+              </a:rPr>
+              <a:t>phụ</a:t>
+            </a:r>
+            <a:r>
+              <a:rPr sz="1180" b="0" dirty="0">
+                <a:solidFill>
+                  <a:srgbClr val="2B3341"/>
+                </a:solidFill>
+                <a:latin typeface="Aptos"/>
+              </a:rPr>
+              <a:t> </a:t>
+            </a:r>
+            <a:r>
+              <a:rPr sz="1180" b="0" dirty="0" err="1">
+                <a:solidFill>
+                  <a:srgbClr val="2B3341"/>
+                </a:solidFill>
+                <a:latin typeface="Aptos"/>
+              </a:rPr>
+              <a:t>thuộc</a:t>
+            </a:r>
+            <a:r>
+              <a:rPr sz="1180" b="0" dirty="0">
+                <a:solidFill>
+                  <a:srgbClr val="2B3341"/>
+                </a:solidFill>
+                <a:latin typeface="Aptos"/>
+              </a:rPr>
+              <a:t> token </a:t>
+            </a:r>
+            <a:r>
+              <a:rPr sz="1180" b="0" dirty="0" err="1">
+                <a:solidFill>
+                  <a:srgbClr val="2B3341"/>
+                </a:solidFill>
+                <a:latin typeface="Aptos"/>
+              </a:rPr>
+              <a:t>trước</a:t>
+            </a:r>
+            <a:r>
+              <a:rPr sz="1180" b="0" dirty="0">
+                <a:solidFill>
+                  <a:srgbClr val="2B3341"/>
+                </a:solidFill>
+                <a:latin typeface="Aptos"/>
+              </a:rPr>
+              <a:t> → sequential cost </a:t>
+            </a:r>
+            <a:r>
+              <a:rPr sz="1180" b="0" dirty="0" err="1">
+                <a:solidFill>
+                  <a:srgbClr val="2B3341"/>
+                </a:solidFill>
+                <a:latin typeface="Aptos"/>
+              </a:rPr>
+              <a:t>lớn</a:t>
+            </a:r>
+            <a:r>
+              <a:rPr sz="1180" b="0" dirty="0">
+                <a:solidFill>
+                  <a:srgbClr val="2B3341"/>
+                </a:solidFill>
+                <a:latin typeface="Aptos"/>
+              </a:rPr>
+              <a:t> </a:t>
+            </a:r>
+            <a:r>
+              <a:rPr sz="1180" b="0" dirty="0" err="1">
+                <a:solidFill>
+                  <a:srgbClr val="2B3341"/>
+                </a:solidFill>
+                <a:latin typeface="Aptos"/>
+              </a:rPr>
+              <a:t>khi</a:t>
+            </a:r>
+            <a:r>
+              <a:rPr sz="1180" b="0" dirty="0">
+                <a:solidFill>
+                  <a:srgbClr val="2B3341"/>
+                </a:solidFill>
+                <a:latin typeface="Aptos"/>
+              </a:rPr>
+              <a:t> beam </a:t>
+            </a:r>
+            <a:r>
+              <a:rPr sz="1180" b="0" dirty="0" err="1">
+                <a:solidFill>
+                  <a:srgbClr val="2B3341"/>
+                </a:solidFill>
+                <a:latin typeface="Aptos"/>
+              </a:rPr>
+              <a:t>tăng</a:t>
+            </a:r>
+            <a:r>
+              <a:rPr sz="1180" b="0" dirty="0">
+                <a:solidFill>
+                  <a:srgbClr val="2B3341"/>
+                </a:solidFill>
+                <a:latin typeface="Aptos"/>
+              </a:rPr>
+              <a:t>.</a:t>
+            </a:r>
+          </a:p>
+        </p:txBody>
+      </p:sp>
+      <p:sp>
+        <p:nvSpPr>
+          <p:cNvPr id="15" name="Rounded Rectangle 14"/>
+          <p:cNvSpPr/>
+          <p:nvPr/>
+        </p:nvSpPr>
+        <p:spPr>
+          <a:xfrm>
+            <a:off x="7955466" y="4645039"/>
+            <a:ext cx="3063240" cy="1417320"/>
+          </a:xfrm>
+          <a:prstGeom prst="roundRect">
+            <a:avLst/>
+          </a:prstGeom>
+          <a:solidFill>
+            <a:srgbClr val="F9FAFC"/>
+          </a:solidFill>
+          <a:ln w="12700">
+            <a:solidFill>
+              <a:srgbClr val="DBE0E7"/>
+            </a:solidFill>
+          </a:ln>
+        </p:spPr>
+        <p:style>
+          <a:lnRef idx="1">
+            <a:schemeClr val="accent1"/>
+          </a:lnRef>
+          <a:fillRef idx="3">
+            <a:schemeClr val="accent1"/>
+          </a:fillRef>
+          <a:effectRef idx="2">
+            <a:schemeClr val="accent1"/>
+          </a:effectRef>
+          <a:fontRef idx="minor">
+            <a:schemeClr val="lt1"/>
+          </a:fontRef>
+        </p:style>
+        <p:txBody>
+          <a:bodyPr rtlCol="0" anchor="ctr"/>
+          <a:lstStyle/>
+          <a:p>
+            <a:pPr algn="ctr"/>
+            <a:endParaRPr/>
+          </a:p>
+        </p:txBody>
+      </p:sp>
+      <p:sp>
+        <p:nvSpPr>
+          <p:cNvPr id="16" name="TextBox 15"/>
+          <p:cNvSpPr txBox="1"/>
+          <p:nvPr/>
+        </p:nvSpPr>
+        <p:spPr>
+          <a:xfrm>
+            <a:off x="8120057" y="4763911"/>
+            <a:ext cx="2743200" cy="256032"/>
+          </a:xfrm>
+          <a:prstGeom prst="rect">
+            <a:avLst/>
+          </a:prstGeom>
+          <a:noFill/>
+        </p:spPr>
+        <p:txBody>
+          <a:bodyPr wrap="square" anchor="t">
+            <a:spAutoFit/>
+          </a:bodyPr>
+          <a:lstStyle/>
+          <a:p>
+            <a:pPr algn="l"/>
+            <a:r>
+              <a:rPr sz="1550" b="1">
+                <a:solidFill>
+                  <a:srgbClr val="368461"/>
+                </a:solidFill>
+                <a:latin typeface="Aptos"/>
+              </a:rPr>
+              <a:t>LazyAR</a:t>
+            </a:r>
+          </a:p>
+        </p:txBody>
+      </p:sp>
+      <p:sp>
+        <p:nvSpPr>
+          <p:cNvPr id="17" name="TextBox 16"/>
+          <p:cNvSpPr txBox="1"/>
+          <p:nvPr/>
+        </p:nvSpPr>
+        <p:spPr>
+          <a:xfrm>
+            <a:off x="8120057" y="5102239"/>
+            <a:ext cx="2743200" cy="749808"/>
+          </a:xfrm>
+          <a:prstGeom prst="rect">
+            <a:avLst/>
+          </a:prstGeom>
+          <a:noFill/>
+        </p:spPr>
+        <p:txBody>
+          <a:bodyPr wrap="square" anchor="t">
+            <a:spAutoFit/>
+          </a:bodyPr>
+          <a:lstStyle/>
+          <a:p>
+            <a:pPr algn="l"/>
+            <a:r>
+              <a:rPr sz="1180" b="0">
+                <a:solidFill>
+                  <a:srgbClr val="2B3341"/>
+                </a:solidFill>
+                <a:latin typeface="Aptos"/>
+              </a:rPr>
+              <a:t>K layer đầu không phụ thuộc token trước → chạy song song, share qua beams. Chỉ L−K layer sau còn autoregressive.</a:t>
+            </a:r>
+          </a:p>
+        </p:txBody>
+      </p:sp>
+      <p:sp>
+        <p:nvSpPr>
+          <p:cNvPr id="18" name="TextBox 17"/>
+          <p:cNvSpPr txBox="1"/>
+          <p:nvPr/>
+        </p:nvSpPr>
+        <p:spPr>
+          <a:xfrm>
+            <a:off x="1353032" y="6269499"/>
+            <a:ext cx="9646920" cy="320040"/>
+          </a:xfrm>
+          <a:prstGeom prst="rect">
+            <a:avLst/>
+          </a:prstGeom>
+          <a:noFill/>
+        </p:spPr>
+        <p:txBody>
+          <a:bodyPr wrap="square" anchor="t">
+            <a:spAutoFit/>
+          </a:bodyPr>
+          <a:lstStyle/>
+          <a:p>
+            <a:pPr algn="ctr"/>
+            <a:r>
+              <a:rPr sz="1250" b="1" dirty="0">
+                <a:solidFill>
+                  <a:srgbClr val="192C4F"/>
+                </a:solidFill>
+                <a:latin typeface="Aptos"/>
+              </a:rPr>
+              <a:t>Trong </a:t>
+            </a:r>
+            <a:r>
+              <a:rPr sz="1250" b="1" dirty="0" err="1">
+                <a:solidFill>
+                  <a:srgbClr val="192C4F"/>
+                </a:solidFill>
+                <a:latin typeface="Aptos"/>
+              </a:rPr>
+              <a:t>thí</a:t>
+            </a:r>
+            <a:r>
+              <a:rPr sz="1250" b="1" dirty="0">
+                <a:solidFill>
+                  <a:srgbClr val="192C4F"/>
+                </a:solidFill>
+                <a:latin typeface="Aptos"/>
+              </a:rPr>
+              <a:t> </a:t>
+            </a:r>
+            <a:r>
+              <a:rPr sz="1250" b="1" dirty="0" err="1">
+                <a:solidFill>
+                  <a:srgbClr val="192C4F"/>
+                </a:solidFill>
+                <a:latin typeface="Aptos"/>
+              </a:rPr>
+              <a:t>nghiệm</a:t>
+            </a:r>
+            <a:r>
+              <a:rPr sz="1250" b="1" dirty="0">
+                <a:solidFill>
+                  <a:srgbClr val="192C4F"/>
+                </a:solidFill>
+                <a:latin typeface="Aptos"/>
+              </a:rPr>
+              <a:t>, </a:t>
+            </a:r>
+            <a:r>
+              <a:rPr sz="1250" b="1" dirty="0" err="1">
+                <a:solidFill>
+                  <a:srgbClr val="192C4F"/>
+                </a:solidFill>
+                <a:latin typeface="Aptos"/>
+              </a:rPr>
+              <a:t>một</a:t>
+            </a:r>
+            <a:r>
+              <a:rPr sz="1250" b="1" dirty="0">
+                <a:solidFill>
+                  <a:srgbClr val="192C4F"/>
+                </a:solidFill>
+                <a:latin typeface="Aptos"/>
+              </a:rPr>
+              <a:t> </a:t>
+            </a:r>
+            <a:r>
+              <a:rPr sz="1250" b="1" dirty="0" err="1">
+                <a:solidFill>
+                  <a:srgbClr val="192C4F"/>
+                </a:solidFill>
+                <a:latin typeface="Aptos"/>
+              </a:rPr>
+              <a:t>cấu</a:t>
+            </a:r>
+            <a:r>
+              <a:rPr sz="1250" b="1" dirty="0">
+                <a:solidFill>
+                  <a:srgbClr val="192C4F"/>
+                </a:solidFill>
+                <a:latin typeface="Aptos"/>
+              </a:rPr>
+              <a:t> </a:t>
+            </a:r>
+            <a:r>
+              <a:rPr sz="1250" b="1" dirty="0" err="1">
+                <a:solidFill>
+                  <a:srgbClr val="192C4F"/>
+                </a:solidFill>
+                <a:latin typeface="Aptos"/>
+              </a:rPr>
+              <a:t>hình</a:t>
+            </a:r>
+            <a:r>
+              <a:rPr sz="1250" b="1" dirty="0">
+                <a:solidFill>
+                  <a:srgbClr val="192C4F"/>
+                </a:solidFill>
+                <a:latin typeface="Aptos"/>
+              </a:rPr>
+              <a:t> K </a:t>
+            </a:r>
+            <a:r>
+              <a:rPr sz="1250" b="1" dirty="0" err="1">
+                <a:solidFill>
+                  <a:srgbClr val="192C4F"/>
+                </a:solidFill>
+                <a:latin typeface="Aptos"/>
+              </a:rPr>
+              <a:t>phù</a:t>
+            </a:r>
+            <a:r>
+              <a:rPr sz="1250" b="1" dirty="0">
+                <a:solidFill>
+                  <a:srgbClr val="192C4F"/>
+                </a:solidFill>
+                <a:latin typeface="Aptos"/>
+              </a:rPr>
+              <a:t> </a:t>
+            </a:r>
+            <a:r>
+              <a:rPr sz="1250" b="1" dirty="0" err="1">
+                <a:solidFill>
+                  <a:srgbClr val="192C4F"/>
+                </a:solidFill>
+                <a:latin typeface="Aptos"/>
+              </a:rPr>
+              <a:t>hợp</a:t>
+            </a:r>
+            <a:r>
+              <a:rPr sz="1250" b="1" dirty="0">
+                <a:solidFill>
+                  <a:srgbClr val="192C4F"/>
+                </a:solidFill>
+                <a:latin typeface="Aptos"/>
+              </a:rPr>
+              <a:t> </a:t>
+            </a:r>
+            <a:r>
+              <a:rPr sz="1250" b="1" dirty="0" err="1">
+                <a:solidFill>
+                  <a:srgbClr val="192C4F"/>
+                </a:solidFill>
+                <a:latin typeface="Aptos"/>
+              </a:rPr>
+              <a:t>giữ</a:t>
+            </a:r>
+            <a:r>
+              <a:rPr sz="1250" b="1" dirty="0">
+                <a:solidFill>
+                  <a:srgbClr val="192C4F"/>
+                </a:solidFill>
+                <a:latin typeface="Aptos"/>
+              </a:rPr>
+              <a:t> recommendation quality </a:t>
+            </a:r>
+            <a:r>
+              <a:rPr sz="1250" b="1" dirty="0" err="1">
+                <a:solidFill>
+                  <a:srgbClr val="192C4F"/>
+                </a:solidFill>
+                <a:latin typeface="Aptos"/>
+              </a:rPr>
+              <a:t>và</a:t>
+            </a:r>
+            <a:r>
+              <a:rPr sz="1250" b="1" dirty="0">
+                <a:solidFill>
+                  <a:srgbClr val="192C4F"/>
+                </a:solidFill>
+                <a:latin typeface="Aptos"/>
+              </a:rPr>
+              <a:t> </a:t>
+            </a:r>
+            <a:r>
+              <a:rPr sz="1250" b="1" dirty="0" err="1">
+                <a:solidFill>
+                  <a:srgbClr val="192C4F"/>
+                </a:solidFill>
+                <a:latin typeface="Aptos"/>
+              </a:rPr>
               <a:t>gần</a:t>
             </a:r>
             <a:r>
-              <a:rPr lang="en-US" sz="1400" dirty="0"/>
-              <a:t> </a:t>
-            </a:r>
-            <a:r>
-              <a:rPr lang="en-US" sz="1400" dirty="0" err="1"/>
-              <a:t>nhất</a:t>
-            </a:r>
-            <a:r>
-              <a:rPr lang="en-US" sz="1400" dirty="0"/>
-              <a:t> → </a:t>
-            </a:r>
-            <a:r>
-              <a:rPr lang="en-US" sz="1400" dirty="0" err="1"/>
-              <a:t>lấy</a:t>
-            </a:r>
-            <a:r>
-              <a:rPr lang="en-US" sz="1400" dirty="0"/>
-              <a:t> cluster ID </a:t>
-            </a:r>
-            <a:r>
-              <a:rPr lang="en-US" sz="1400" dirty="0" err="1"/>
-              <a:t>làm</a:t>
-            </a:r>
-            <a:r>
-              <a:rPr lang="en-US" sz="1400" dirty="0"/>
-              <a:t> token → </a:t>
-            </a:r>
-            <a:r>
-              <a:rPr lang="en-US" sz="1400" dirty="0" err="1"/>
-              <a:t>trừ</a:t>
-            </a:r>
-            <a:r>
-              <a:rPr lang="en-US" sz="1400" dirty="0"/>
-              <a:t> centroid </a:t>
-            </a:r>
-            <a:r>
-              <a:rPr lang="en-US" sz="1400" dirty="0" err="1"/>
-              <a:t>để</a:t>
-            </a:r>
-            <a:r>
-              <a:rPr lang="en-US" sz="1400" dirty="0"/>
-              <a:t> </a:t>
-            </a:r>
-            <a:r>
-              <a:rPr lang="en-US" sz="1400" dirty="0" err="1"/>
-              <a:t>tạo</a:t>
-            </a:r>
-            <a:r>
-              <a:rPr lang="en-US" sz="1400" dirty="0"/>
-              <a:t> residual </a:t>
-            </a:r>
-            <a:r>
-              <a:rPr lang="en-US" sz="1400" dirty="0" err="1"/>
-              <a:t>cho</a:t>
-            </a:r>
-            <a:r>
-              <a:rPr lang="en-US" sz="1400" dirty="0"/>
-              <a:t> level </a:t>
-            </a:r>
-            <a:r>
-              <a:rPr lang="en-US" sz="1400" dirty="0" err="1"/>
-              <a:t>tiếp</a:t>
-            </a:r>
-            <a:r>
-              <a:rPr lang="en-US" sz="1400" dirty="0"/>
-              <a:t> </a:t>
-            </a:r>
-            <a:r>
-              <a:rPr lang="en-US" sz="1400" dirty="0" err="1"/>
-              <a:t>theo.</a:t>
-            </a:r>
-            <a:endParaRPr lang="en-US" sz="1400" dirty="0"/>
-          </a:p>
-          <a:p>
-            <a:pPr marL="342900" lvl="0" indent="-342900">
-              <a:buFont typeface="Arial" panose="020B0604020202020204" pitchFamily="34" charset="0"/>
-              <a:buChar char="•"/>
-            </a:pPr>
-            <a:r>
-              <a:rPr lang="en-US" sz="1400" b="1" dirty="0"/>
-              <a:t>Multi-Resolution:</a:t>
-            </a:r>
-            <a:r>
-              <a:rPr lang="en-US" sz="1400" dirty="0"/>
-              <a:t> </a:t>
-            </a:r>
-            <a:r>
-              <a:rPr lang="en-US" sz="1400" dirty="0" err="1"/>
-              <a:t>các</a:t>
-            </a:r>
-            <a:r>
-              <a:rPr lang="en-US" sz="1400" dirty="0"/>
-              <a:t> level </a:t>
-            </a:r>
-            <a:r>
-              <a:rPr lang="en-US" sz="1400" dirty="0" err="1"/>
-              <a:t>đầu</a:t>
-            </a:r>
-            <a:r>
-              <a:rPr lang="en-US" sz="1400" dirty="0"/>
-              <a:t> </a:t>
-            </a:r>
-            <a:r>
-              <a:rPr lang="en-US" sz="1400" dirty="0" err="1"/>
-              <a:t>dùng</a:t>
-            </a:r>
-            <a:r>
-              <a:rPr lang="en-US" sz="1400" dirty="0"/>
-              <a:t> codebook </a:t>
-            </a:r>
-            <a:r>
-              <a:rPr lang="en-US" sz="1400" dirty="0" err="1"/>
-              <a:t>lớn</a:t>
-            </a:r>
-            <a:r>
-              <a:rPr lang="en-US" sz="1400" dirty="0"/>
-              <a:t> </a:t>
-            </a:r>
-            <a:r>
-              <a:rPr lang="en-US" sz="1400" dirty="0" err="1"/>
-              <a:t>để</a:t>
-            </a:r>
-            <a:r>
-              <a:rPr lang="en-US" sz="1400" dirty="0"/>
-              <a:t> </a:t>
-            </a:r>
-            <a:r>
-              <a:rPr lang="en-US" sz="1400" dirty="0" err="1"/>
-              <a:t>bắt</a:t>
-            </a:r>
-            <a:r>
-              <a:rPr lang="en-US" sz="1400" dirty="0"/>
-              <a:t> </a:t>
-            </a:r>
-            <a:r>
-              <a:rPr lang="en-US" sz="1400" dirty="0" err="1"/>
-              <a:t>các</a:t>
-            </a:r>
-            <a:r>
-              <a:rPr lang="en-US" sz="1400" dirty="0"/>
-              <a:t> </a:t>
-            </a:r>
-            <a:r>
-              <a:rPr lang="en-US" sz="1400" dirty="0" err="1"/>
-              <a:t>yếu</a:t>
-            </a:r>
-            <a:r>
-              <a:rPr lang="en-US" sz="1400" dirty="0"/>
-              <a:t> </a:t>
-            </a:r>
-            <a:r>
-              <a:rPr lang="en-US" sz="1400" dirty="0" err="1"/>
-              <a:t>tố</a:t>
-            </a:r>
-            <a:r>
-              <a:rPr lang="en-US" sz="1400" dirty="0"/>
-              <a:t> semantic </a:t>
-            </a:r>
-            <a:r>
-              <a:rPr lang="en-US" sz="1400" dirty="0" err="1"/>
-              <a:t>chính</a:t>
-            </a:r>
-            <a:r>
-              <a:rPr lang="en-US" sz="1400" dirty="0"/>
-              <a:t>; residual </a:t>
-            </a:r>
-            <a:r>
-              <a:rPr lang="en-US" sz="1400" dirty="0" err="1"/>
-              <a:t>về</a:t>
-            </a:r>
-            <a:r>
-              <a:rPr lang="en-US" sz="1400" dirty="0"/>
-              <a:t> </a:t>
-            </a:r>
-            <a:r>
-              <a:rPr lang="en-US" sz="1400" dirty="0" err="1"/>
-              <a:t>sau</a:t>
-            </a:r>
-            <a:r>
-              <a:rPr lang="en-US" sz="1400" dirty="0"/>
-              <a:t> </a:t>
-            </a:r>
-            <a:r>
-              <a:rPr lang="en-US" sz="1400" dirty="0" err="1"/>
-              <a:t>có</a:t>
-            </a:r>
-            <a:r>
-              <a:rPr lang="en-US" sz="1400" dirty="0"/>
-              <a:t> entropy </a:t>
-            </a:r>
-            <a:r>
-              <a:rPr lang="en-US" sz="1400" dirty="0" err="1"/>
-              <a:t>thấp</a:t>
-            </a:r>
-            <a:r>
-              <a:rPr lang="en-US" sz="1400" dirty="0"/>
-              <a:t> </a:t>
-            </a:r>
-            <a:r>
-              <a:rPr lang="en-US" sz="1400" dirty="0" err="1"/>
-              <a:t>hơn</a:t>
-            </a:r>
-            <a:r>
-              <a:rPr lang="en-US" sz="1400" dirty="0"/>
-              <a:t> </a:t>
-            </a:r>
-            <a:r>
-              <a:rPr lang="en-US" sz="1400" dirty="0" err="1"/>
-              <a:t>nên</a:t>
-            </a:r>
-            <a:r>
-              <a:rPr lang="en-US" sz="1400" dirty="0"/>
-              <a:t> </a:t>
-            </a:r>
-            <a:r>
-              <a:rPr lang="en-US" sz="1400" dirty="0" err="1"/>
-              <a:t>không</a:t>
-            </a:r>
-            <a:r>
-              <a:rPr lang="en-US" sz="1400" dirty="0"/>
-              <a:t> </a:t>
-            </a:r>
-            <a:r>
-              <a:rPr lang="en-US" sz="1400" dirty="0" err="1"/>
-              <a:t>cần</a:t>
-            </a:r>
-            <a:r>
-              <a:rPr lang="en-US" sz="1400" dirty="0"/>
-              <a:t> </a:t>
-            </a:r>
-            <a:r>
-              <a:rPr lang="en-US" sz="1400" dirty="0" err="1"/>
-              <a:t>cùng</a:t>
-            </a:r>
-            <a:r>
-              <a:rPr lang="en-US" sz="1400" dirty="0"/>
-              <a:t> </a:t>
-            </a:r>
-            <a:r>
-              <a:rPr lang="en-US" sz="1400" dirty="0" err="1"/>
-              <a:t>độ</a:t>
-            </a:r>
-            <a:r>
-              <a:rPr lang="en-US" sz="1400" dirty="0"/>
-              <a:t> </a:t>
-            </a:r>
-            <a:r>
-              <a:rPr lang="en-US" sz="1400" dirty="0" err="1"/>
-              <a:t>phân</a:t>
-            </a:r>
-            <a:r>
-              <a:rPr lang="en-US" sz="1400" dirty="0"/>
-              <a:t> </a:t>
-            </a:r>
-            <a:r>
-              <a:rPr lang="en-US" sz="1400" dirty="0" err="1"/>
-              <a:t>giải</a:t>
-            </a:r>
-            <a:r>
-              <a:rPr lang="en-US" sz="1400" dirty="0"/>
-              <a:t>.</a:t>
-            </a:r>
-          </a:p>
-          <a:p>
-            <a:pPr marL="342900" lvl="0" indent="-342900">
-              <a:buFont typeface="Arial" panose="020B0604020202020204" pitchFamily="34" charset="0"/>
-              <a:buChar char="•"/>
-            </a:pPr>
-            <a:r>
-              <a:rPr lang="en-US" sz="1400" b="1" dirty="0"/>
-              <a:t>Balanced K-Means:</a:t>
-            </a:r>
-            <a:r>
-              <a:rPr lang="en-US" sz="1400" dirty="0"/>
-              <a:t> </a:t>
-            </a:r>
-            <a:r>
-              <a:rPr lang="en-US" sz="1400" dirty="0" err="1"/>
-              <a:t>ép</a:t>
-            </a:r>
-            <a:r>
-              <a:rPr lang="en-US" sz="1400" dirty="0"/>
-              <a:t> cluster </a:t>
-            </a:r>
-            <a:r>
-              <a:rPr lang="en-US" sz="1400" dirty="0" err="1"/>
-              <a:t>phân</a:t>
-            </a:r>
-            <a:r>
-              <a:rPr lang="en-US" sz="1400" dirty="0"/>
-              <a:t> </a:t>
-            </a:r>
-            <a:r>
-              <a:rPr lang="en-US" sz="1400" dirty="0" err="1"/>
-              <a:t>bố</a:t>
-            </a:r>
-            <a:r>
-              <a:rPr lang="en-US" sz="1400" dirty="0"/>
-              <a:t> </a:t>
-            </a:r>
-            <a:r>
-              <a:rPr lang="en-US" sz="1400" dirty="0" err="1"/>
-              <a:t>cân</a:t>
-            </a:r>
-            <a:r>
-              <a:rPr lang="en-US" sz="1400" dirty="0"/>
-              <a:t> </a:t>
-            </a:r>
-            <a:r>
-              <a:rPr lang="en-US" sz="1400" dirty="0" err="1"/>
-              <a:t>bằng</a:t>
-            </a:r>
-            <a:r>
-              <a:rPr lang="en-US" sz="1400" dirty="0"/>
-              <a:t> </a:t>
-            </a:r>
-            <a:r>
-              <a:rPr lang="en-US" sz="1400" dirty="0" err="1"/>
-              <a:t>hơn</a:t>
-            </a:r>
-            <a:r>
-              <a:rPr lang="en-US" sz="1400" dirty="0"/>
-              <a:t> → </a:t>
-            </a:r>
-            <a:r>
-              <a:rPr lang="en-US" sz="1400" b="1" dirty="0" err="1"/>
-              <a:t>tăng</a:t>
-            </a:r>
-            <a:r>
-              <a:rPr lang="en-US" sz="1400" b="1" dirty="0"/>
-              <a:t> codebook utilization</a:t>
-            </a:r>
-            <a:r>
-              <a:rPr lang="en-US" sz="1400" dirty="0"/>
-              <a:t>, </a:t>
-            </a:r>
-            <a:r>
-              <a:rPr lang="en-US" sz="1400" dirty="0" err="1"/>
-              <a:t>tránh</a:t>
-            </a:r>
-            <a:r>
-              <a:rPr lang="en-US" sz="1400" dirty="0"/>
-              <a:t> </a:t>
-            </a:r>
-            <a:r>
-              <a:rPr lang="en-US" sz="1400" dirty="0" err="1"/>
-              <a:t>nhiều</a:t>
-            </a:r>
-            <a:r>
-              <a:rPr lang="en-US" sz="1400" dirty="0"/>
-              <a:t> token </a:t>
-            </a:r>
-            <a:r>
-              <a:rPr lang="en-US" sz="1400" dirty="0" err="1"/>
-              <a:t>gần</a:t>
-            </a:r>
-            <a:r>
-              <a:rPr lang="en-US" sz="1400" dirty="0"/>
-              <a:t> </a:t>
-            </a:r>
-            <a:r>
-              <a:rPr lang="en-US" sz="1400" dirty="0" err="1"/>
+              <a:rPr sz="1250" b="1" dirty="0">
+                <a:solidFill>
+                  <a:srgbClr val="192C4F"/>
+                </a:solidFill>
+                <a:latin typeface="Aptos"/>
+              </a:rPr>
+              <a:t> </a:t>
+            </a:r>
+            <a:r>
+              <a:rPr sz="1250" b="1" dirty="0" err="1">
+                <a:solidFill>
+                  <a:srgbClr val="192C4F"/>
+                </a:solidFill>
+                <a:latin typeface="Aptos"/>
+              </a:rPr>
               <a:t>như</a:t>
             </a:r>
             <a:r>
-              <a:rPr lang="en-US" sz="1400" dirty="0"/>
-              <a:t> </a:t>
-            </a:r>
-            <a:r>
-              <a:rPr lang="en-US" sz="1400" dirty="0" err="1"/>
-              <a:t>không</a:t>
-            </a:r>
-            <a:r>
-              <a:rPr lang="en-US" sz="1400" dirty="0"/>
-              <a:t> </a:t>
-            </a:r>
-            <a:r>
-              <a:rPr lang="en-US" sz="1400" dirty="0" err="1"/>
-              <a:t>được</a:t>
-            </a:r>
-            <a:r>
-              <a:rPr lang="en-US" sz="1400" dirty="0"/>
-              <a:t> </a:t>
-            </a:r>
-            <a:r>
-              <a:rPr lang="en-US" sz="1400" dirty="0" err="1"/>
-              <a:t>dùng</a:t>
-            </a:r>
-            <a:r>
-              <a:rPr lang="en-US" sz="1400" dirty="0"/>
-              <a:t>.</a:t>
-            </a:r>
-          </a:p>
-          <a:p>
-            <a:pPr marL="342900" lvl="0" indent="-342900">
-              <a:buFont typeface="Arial" panose="020B0604020202020204" pitchFamily="34" charset="0"/>
-              <a:buChar char="•"/>
-            </a:pPr>
-            <a:r>
-              <a:rPr lang="en-US" sz="1400" b="1" dirty="0"/>
-              <a:t>Multi-Granularity:</a:t>
-            </a:r>
-            <a:r>
-              <a:rPr lang="en-US" sz="1400" dirty="0"/>
-              <a:t> level </a:t>
-            </a:r>
-            <a:r>
-              <a:rPr lang="en-US" sz="1400" dirty="0" err="1"/>
-              <a:t>cuối</a:t>
-            </a:r>
-            <a:r>
-              <a:rPr lang="en-US" sz="1400" dirty="0"/>
-              <a:t> </a:t>
-            </a:r>
-            <a:r>
-              <a:rPr lang="en-US" sz="1400" dirty="0" err="1"/>
-              <a:t>dùng</a:t>
-            </a:r>
-            <a:r>
-              <a:rPr lang="en-US" sz="1400" dirty="0"/>
-              <a:t> </a:t>
-            </a:r>
-            <a:r>
-              <a:rPr lang="en-US" sz="1400" b="1" dirty="0"/>
-              <a:t>hash </a:t>
-            </a:r>
-            <a:r>
-              <a:rPr lang="en-US" sz="1400" b="1" dirty="0" err="1"/>
-              <a:t>từ</a:t>
-            </a:r>
-            <a:r>
-              <a:rPr lang="en-US" sz="1400" b="1" dirty="0"/>
-              <a:t> business features</a:t>
-            </a:r>
-            <a:r>
-              <a:rPr lang="en-US" sz="1400" dirty="0"/>
-              <a:t> </a:t>
-            </a:r>
-            <a:r>
-              <a:rPr lang="en-US" sz="1400" dirty="0" err="1"/>
-              <a:t>như</a:t>
-            </a:r>
-            <a:r>
-              <a:rPr lang="en-US" sz="1400" dirty="0"/>
-              <a:t> Account ID / Conversion Type </a:t>
-            </a:r>
-            <a:r>
-              <a:rPr lang="en-US" sz="1400" dirty="0" err="1"/>
-              <a:t>để</a:t>
-            </a:r>
-            <a:r>
-              <a:rPr lang="en-US" sz="1400" dirty="0"/>
-              <a:t> </a:t>
-            </a:r>
-            <a:r>
-              <a:rPr lang="en-US" sz="1400" dirty="0" err="1"/>
-              <a:t>phân</a:t>
-            </a:r>
-            <a:r>
-              <a:rPr lang="en-US" sz="1400" dirty="0"/>
-              <a:t> </a:t>
-            </a:r>
-            <a:r>
-              <a:rPr lang="en-US" sz="1400" dirty="0" err="1"/>
-              <a:t>biệt</a:t>
-            </a:r>
-            <a:r>
-              <a:rPr lang="en-US" sz="1400" dirty="0"/>
-              <a:t> </a:t>
-            </a:r>
-            <a:r>
-              <a:rPr lang="en-US" sz="1400" dirty="0" err="1"/>
-              <a:t>các</a:t>
-            </a:r>
-            <a:r>
-              <a:rPr lang="en-US" sz="1400" dirty="0"/>
-              <a:t> Ads semantic </a:t>
-            </a:r>
-            <a:r>
-              <a:rPr lang="en-US" sz="1400" dirty="0" err="1"/>
-              <a:t>giống</a:t>
-            </a:r>
-            <a:r>
-              <a:rPr lang="en-US" sz="1400" dirty="0"/>
-              <a:t> </a:t>
-            </a:r>
-            <a:r>
-              <a:rPr lang="en-US" sz="1400" dirty="0" err="1"/>
-              <a:t>nhau</a:t>
-            </a:r>
-            <a:r>
-              <a:rPr lang="en-US" sz="1400" dirty="0"/>
-              <a:t> </a:t>
-            </a:r>
-            <a:r>
-              <a:rPr lang="en-US" sz="1400" dirty="0" err="1"/>
-              <a:t>nhưng</a:t>
-            </a:r>
-            <a:r>
-              <a:rPr lang="en-US" sz="1400" dirty="0"/>
-              <a:t> </a:t>
-            </a:r>
-            <a:r>
-              <a:rPr lang="en-US" sz="1400" dirty="0" err="1"/>
-              <a:t>mục</a:t>
-            </a:r>
-            <a:r>
-              <a:rPr lang="en-US" sz="1400" dirty="0"/>
-              <a:t> </a:t>
-            </a:r>
-            <a:r>
-              <a:rPr lang="en-US" sz="1400" dirty="0" err="1"/>
-              <a:t>tiêu</a:t>
-            </a:r>
-            <a:r>
-              <a:rPr lang="en-US" sz="1400" dirty="0"/>
-              <a:t> delivery </a:t>
-            </a:r>
-            <a:r>
-              <a:rPr lang="en-US" sz="1400" dirty="0" err="1"/>
-              <a:t>khác</a:t>
-            </a:r>
-            <a:r>
-              <a:rPr lang="en-US" sz="1400" dirty="0"/>
-              <a:t> </a:t>
-            </a:r>
-            <a:r>
-              <a:rPr lang="en-US" sz="1400" dirty="0" err="1"/>
-              <a:t>nhau</a:t>
-            </a:r>
-            <a:endParaRPr lang="en-US" sz="1400" dirty="0"/>
+              <a:rPr sz="1250" b="1" dirty="0">
+                <a:solidFill>
+                  <a:srgbClr val="192C4F"/>
+                </a:solidFill>
+                <a:latin typeface="Aptos"/>
+              </a:rPr>
+              <a:t> </a:t>
+            </a:r>
+            <a:r>
+              <a:rPr sz="1250" b="1" dirty="0" err="1">
+                <a:solidFill>
+                  <a:srgbClr val="192C4F"/>
+                </a:solidFill>
+                <a:latin typeface="Aptos"/>
+              </a:rPr>
+              <a:t>nhân</a:t>
+            </a:r>
+            <a:r>
+              <a:rPr sz="1250" b="1" dirty="0">
+                <a:solidFill>
+                  <a:srgbClr val="192C4F"/>
+                </a:solidFill>
+                <a:latin typeface="Aptos"/>
+              </a:rPr>
+              <a:t> </a:t>
+            </a:r>
+            <a:r>
+              <a:rPr sz="1250" b="1" dirty="0" err="1">
+                <a:solidFill>
+                  <a:srgbClr val="192C4F"/>
+                </a:solidFill>
+                <a:latin typeface="Aptos"/>
+              </a:rPr>
+              <a:t>đôi</a:t>
+            </a:r>
+            <a:r>
+              <a:rPr sz="1250" b="1" dirty="0">
+                <a:solidFill>
+                  <a:srgbClr val="192C4F"/>
+                </a:solidFill>
+                <a:latin typeface="Aptos"/>
+              </a:rPr>
+              <a:t> throughput.</a:t>
+            </a:r>
           </a:p>
         </p:txBody>
       </p:sp>
     </p:spTree>
-    <p:extLst>
-      <p:ext uri="{BB962C8B-B14F-4D97-AF65-F5344CB8AC3E}">
-        <p14:creationId xmlns:p14="http://schemas.microsoft.com/office/powerpoint/2010/main" val="3768493168"/>
-      </p:ext>
-    </p:extLst>
   </p:cSld>
   <p:clrMapOvr>
     <a:masterClrMapping/>

</xml_diff>